<commit_message>
Add GitHub repository link to README, slides, and deck
Co-Authored-By: Claude Fable 5 <noreply@anthropic.com>
</commit_message>
<xml_diff>
--- a/BYTE_BRIGADE_SEMICON2026.pptx
+++ b/BYTE_BRIGADE_SEMICON2026.pptx
@@ -6423,11 +6423,11 @@
         <p:spPr>
           <a:xfrm>
             <a:off x="6400800" y="3977640"/>
-            <a:ext cx="5212080" cy="777240"/>
+            <a:ext cx="5212080" cy="868680"/>
           </a:xfrm>
           <a:prstGeom prst="roundRect">
             <a:avLst>
-              <a:gd name="adj" fmla="val 11765"/>
+              <a:gd name="adj" fmla="val 10526"/>
             </a:avLst>
           </a:prstGeom>
           <a:solidFill>
@@ -6443,7 +6443,7 @@
               <a:buNone/>
             </a:pPr>
             <a:r>
-              <a:rPr lang="en-US" sz="1600" b="1" dirty="0">
+              <a:rPr lang="en-US" sz="1400" b="1" dirty="0">
                 <a:solidFill>
                   <a:srgbClr val="FFFFFF"/>
                 </a:solidFill>
@@ -6451,9 +6451,26 @@
                 <a:ea typeface="Courier New" pitchFamily="34" charset="-122"/>
                 <a:cs typeface="Courier New" pitchFamily="34" charset="-120"/>
               </a:rPr>
-              <a:t>github.com/  ‹add repository link›</a:t>
-            </a:r>
-            <a:endParaRPr lang="en-US" sz="1600" dirty="0"/>
+              <a:t>github.com/prakharbajaj1551/</a:t>
+            </a:r>
+            <a:endParaRPr lang="en-US" sz="1400" dirty="0"/>
+          </a:p>
+          <a:p>
+            <a:pPr algn="ctr" indent="0" marL="0">
+              <a:buNone/>
+            </a:pPr>
+            <a:r>
+              <a:rPr lang="en-US" sz="1400" b="1" dirty="0">
+                <a:solidFill>
+                  <a:srgbClr val="FFFFFF"/>
+                </a:solidFill>
+                <a:latin typeface="Courier New" pitchFamily="34" charset="0"/>
+                <a:ea typeface="Courier New" pitchFamily="34" charset="-122"/>
+                <a:cs typeface="Courier New" pitchFamily="34" charset="-120"/>
+              </a:rPr>
+              <a:t>semicon-image-restoration</a:t>
+            </a:r>
+            <a:endParaRPr lang="en-US" sz="1400" dirty="0"/>
           </a:p>
         </p:txBody>
       </p:sp>

</xml_diff>

<commit_message>
Add submission deliverables: training/impact slides, sample outputs, video script
Organiser requirements needed three additions:
- Deck: dedicated Training Strategy and Impact & Feasibility slides
  (11 slides total), both required sections that were missing.
- results/: viewable sample outputs (6 images x 4 stages) and the full
  per-image metric tables, since outputs/ is gitignored.
- DEMO_VIDEO_SCRIPT.md: timed 4:30 script for the required demo video.

README documents results/ and warns against cloning into an existing copy.

Co-Authored-By: Claude Fable 5 <noreply@anthropic.com>
</commit_message>
<xml_diff>
--- a/BYTE_BRIGADE_SEMICON2026.pptx
+++ b/BYTE_BRIGADE_SEMICON2026.pptx
@@ -14,9 +14,11 @@
     <p:sldId id="262" r:id="rId8"/>
     <p:sldId id="263" r:id="rId9"/>
     <p:sldId id="264" r:id="rId10"/>
+    <p:sldId id="265" r:id="rId11"/>
+    <p:sldId id="266" r:id="rId12"/>
   </p:sldIdLst>
   <p:notesMasterIdLst>
-    <p:notesMasterId r:id="rId11"/>
+    <p:notesMasterId r:id="rId13"/>
   </p:notesMasterIdLst>
   <p:sldSz cx="12192000" cy="6858000"/>
   <p:notesSz cx="6858000" cy="12192000"/>
@@ -552,6 +554,182 @@
 </p:notes>
 </file>
 
+<file path=ppt/notesSlides/notesSlide10.xml><?xml version="1.0" encoding="utf-8"?>
+<p:notes xmlns:a="http://schemas.openxmlformats.org/drawingml/2006/main" xmlns:r="http://schemas.openxmlformats.org/officeDocument/2006/relationships" xmlns:p="http://schemas.openxmlformats.org/presentationml/2006/main">
+  <p:cSld>
+    <p:spTree>
+      <p:nvGrpSpPr>
+        <p:cNvPr id="1" name=""/>
+        <p:cNvGrpSpPr/>
+        <p:nvPr/>
+      </p:nvGrpSpPr>
+      <p:grpSpPr>
+        <a:xfrm>
+          <a:off x="0" y="0"/>
+          <a:ext cx="0" cy="0"/>
+          <a:chOff x="0" y="0"/>
+          <a:chExt cx="0" cy="0"/>
+        </a:xfrm>
+      </p:grpSpPr>
+      <p:sp>
+        <p:nvSpPr>
+          <p:cNvPr id="2" name="Slide Image Placeholder 1"/>
+          <p:cNvSpPr>
+            <a:spLocks noGrp="1" noRot="1" noChangeAspect="1"/>
+          </p:cNvSpPr>
+          <p:nvPr>
+            <p:ph type="sldImg"/>
+          </p:nvPr>
+        </p:nvSpPr>
+        <p:spPr/>
+      </p:sp>
+      <p:sp>
+        <p:nvSpPr>
+          <p:cNvPr id="3" name="Notes Placeholder 2"/>
+          <p:cNvSpPr>
+            <a:spLocks noGrp="1"/>
+          </p:cNvSpPr>
+          <p:nvPr>
+            <p:ph type="body" idx="1"/>
+          </p:nvPr>
+        </p:nvSpPr>
+        <p:spPr/>
+        <p:txBody>
+          <a:bodyPr/>
+          <a:lstStyle/>
+          <a:p>
+            <a:r>
+              <a:rPr lang="en-US" dirty="0"/>
+              <a:t>The repository is small and readable on purpose — nine short modules, each commented to explain why, not just what. The README reproduces every number on this slide deck with four commands.</a:t>
+            </a:r>
+            <a:endParaRPr lang="en-US" dirty="0"/>
+          </a:p>
+        </p:txBody>
+      </p:sp>
+      <p:sp>
+        <p:nvSpPr>
+          <p:cNvPr id="4" name="Slide Number Placeholder 3"/>
+          <p:cNvSpPr>
+            <a:spLocks noGrp="1"/>
+          </p:cNvSpPr>
+          <p:nvPr>
+            <p:ph type="sldNum" sz="quarter" idx="10"/>
+          </p:nvPr>
+        </p:nvSpPr>
+        <p:spPr/>
+        <p:txBody>
+          <a:bodyPr/>
+          <a:lstStyle/>
+          <a:p>
+            <a:fld id="{F7021451-1387-4CA6-816F-3879F97B5CBC}" type="slidenum">
+              <a:rPr lang="en-US"/>
+              <a:t>10</a:t>
+            </a:fld>
+            <a:endParaRPr lang="en-US"/>
+          </a:p>
+        </p:txBody>
+      </p:sp>
+    </p:spTree>
+    <p:extLst>
+      <p:ext uri="{BB962C8B-B14F-4D97-AF65-F5344CB8AC3E}">
+        <p14:creationId xmlns:p14="http://schemas.microsoft.com/office/powerpoint/2010/main" val="1024086991"/>
+      </p:ext>
+    </p:extLst>
+  </p:cSld>
+  <p:clrMapOvr>
+    <a:masterClrMapping/>
+  </p:clrMapOvr>
+</p:notes>
+</file>
+
+<file path=ppt/notesSlides/notesSlide11.xml><?xml version="1.0" encoding="utf-8"?>
+<p:notes xmlns:a="http://schemas.openxmlformats.org/drawingml/2006/main" xmlns:r="http://schemas.openxmlformats.org/officeDocument/2006/relationships" xmlns:p="http://schemas.openxmlformats.org/presentationml/2006/main">
+  <p:cSld>
+    <p:spTree>
+      <p:nvGrpSpPr>
+        <p:cNvPr id="1" name=""/>
+        <p:cNvGrpSpPr/>
+        <p:nvPr/>
+      </p:nvGrpSpPr>
+      <p:grpSpPr>
+        <a:xfrm>
+          <a:off x="0" y="0"/>
+          <a:ext cx="0" cy="0"/>
+          <a:chOff x="0" y="0"/>
+          <a:chExt cx="0" cy="0"/>
+        </a:xfrm>
+      </p:grpSpPr>
+      <p:sp>
+        <p:nvSpPr>
+          <p:cNvPr id="2" name="Slide Image Placeholder 1"/>
+          <p:cNvSpPr>
+            <a:spLocks noGrp="1" noRot="1" noChangeAspect="1"/>
+          </p:cNvSpPr>
+          <p:nvPr>
+            <p:ph type="sldImg"/>
+          </p:nvPr>
+        </p:nvSpPr>
+        <p:spPr/>
+      </p:sp>
+      <p:sp>
+        <p:nvSpPr>
+          <p:cNvPr id="3" name="Notes Placeholder 2"/>
+          <p:cNvSpPr>
+            <a:spLocks noGrp="1"/>
+          </p:cNvSpPr>
+          <p:nvPr>
+            <p:ph type="body" idx="1"/>
+          </p:nvPr>
+        </p:nvSpPr>
+        <p:spPr/>
+        <p:txBody>
+          <a:bodyPr/>
+          <a:lstStyle/>
+          <a:p>
+            <a:r>
+              <a:rPr lang="en-US" dirty="0"/>
+              <a:t>We stand on proven open research — NAFNet for the architecture, PixelShuffle for upscaling, LPIPS for perceptual quality. Thank you — questions welcome.</a:t>
+            </a:r>
+            <a:endParaRPr lang="en-US" dirty="0"/>
+          </a:p>
+        </p:txBody>
+      </p:sp>
+      <p:sp>
+        <p:nvSpPr>
+          <p:cNvPr id="4" name="Slide Number Placeholder 3"/>
+          <p:cNvSpPr>
+            <a:spLocks noGrp="1"/>
+          </p:cNvSpPr>
+          <p:nvPr>
+            <p:ph type="sldNum" sz="quarter" idx="10"/>
+          </p:nvPr>
+        </p:nvSpPr>
+        <p:spPr/>
+        <p:txBody>
+          <a:bodyPr/>
+          <a:lstStyle/>
+          <a:p>
+            <a:fld id="{F7021451-1387-4CA6-816F-3879F97B5CBC}" type="slidenum">
+              <a:rPr lang="en-US"/>
+              <a:t>11</a:t>
+            </a:fld>
+            <a:endParaRPr lang="en-US"/>
+          </a:p>
+        </p:txBody>
+      </p:sp>
+    </p:spTree>
+    <p:extLst>
+      <p:ext uri="{BB962C8B-B14F-4D97-AF65-F5344CB8AC3E}">
+        <p14:creationId xmlns:p14="http://schemas.microsoft.com/office/powerpoint/2010/main" val="1024086991"/>
+      </p:ext>
+    </p:extLst>
+  </p:cSld>
+  <p:clrMapOvr>
+    <a:masterClrMapping/>
+  </p:clrMapOvr>
+</p:notes>
+</file>
+
 <file path=ppt/notesSlides/notesSlide2.xml><?xml version="1.0" encoding="utf-8"?>
 <p:notes xmlns:a="http://schemas.openxmlformats.org/drawingml/2006/main" xmlns:r="http://schemas.openxmlformats.org/officeDocument/2006/relationships" xmlns:p="http://schemas.openxmlformats.org/presentationml/2006/main">
   <p:cSld>
@@ -862,7 +1040,7 @@
           <a:p>
             <a:r>
               <a:rPr lang="en-US" dirty="0"/>
-              <a:t>Our innovation is disciplined engineering, not exotic research. We train directly on the judged metrics. We guarantee no hallucination by construction. And one subtle point others may miss: the input arrays contain values outside zero-one — real noise signal. Our pipeline keeps full float precision everywhere; converting to images would destroy it.</a:t>
+              <a:t>Training strategy: 3,000 paired images, 128-pixel random crops in batches of 16, with eight-fold flip and rotation augmentation. The loss combines Charbonnier for pixel fidelity, SSIM for structure, and a small LPIPS term for perceptual quality — two of the three judged metrics optimised directly. AdamW with cosine learning-rate decay over 100 epochs, validating every fifth epoch and keeping the best checkpoint. Two hours on a free Colab GPU.</a:t>
             </a:r>
             <a:endParaRPr lang="en-US" dirty="0"/>
           </a:p>
@@ -950,7 +1128,7 @@
           <a:p>
             <a:r>
               <a:rPr lang="en-US" dirty="0"/>
-              <a:t>On one hundred held-out pairs: plus five dB PSNR — that's roughly 69 percent of pixel error eliminated — SSIM up from 0.54 to 0.76, and LPIPS, the perceptual metric, cut by 60 percent. Better on every judged axis. And it runs at about a second per image on a plain laptop CPU — 30 milliseconds on a GPU.</a:t>
+              <a:t>Our innovation is disciplined engineering, not exotic research. We train directly on the judged metrics. We guarantee no hallucination by construction. And one subtle point others may miss: the input arrays contain values outside zero-one — real noise signal. Our pipeline keeps full float precision everywhere; converting to images would destroy it.</a:t>
             </a:r>
             <a:endParaRPr lang="en-US" dirty="0"/>
           </a:p>
@@ -1038,7 +1216,7 @@
           <a:p>
             <a:r>
               <a:rPr lang="en-US" dirty="0"/>
-              <a:t>Everything is open source and reproducible. Training cost nothing — two hours on a free Colab GPU. Every random seed is fixed, and the model file carries its own configuration, so anyone can rerun our exact pipeline from the README in four commands. There's also a live Streamlit demo — happy to show it.</a:t>
+              <a:t>On one hundred held-out pairs: plus five dB PSNR — that's roughly 69 percent of pixel error eliminated — SSIM up from 0.54 to 0.76, and LPIPS, the perceptual metric, cut by 60 percent. Better on every judged axis. And it runs at about a second per image on a plain laptop CPU — 30 milliseconds on a GPU.</a:t>
             </a:r>
             <a:endParaRPr lang="en-US" dirty="0"/>
           </a:p>
@@ -1126,7 +1304,7 @@
           <a:p>
             <a:r>
               <a:rPr lang="en-US" dirty="0"/>
-              <a:t>The repository is small and readable on purpose — nine short modules, each commented to explain why, not just what. The README reproduces every number on this slide deck with four commands.</a:t>
+              <a:t>Impact: restoring noise-hidden detail means fewer missed defects, and it lets fabs scan faster or at lower dose because the software recovers quality — more throughput from the same microscopes. Feasibility is proven, not projected: the system is built and running, the model is six and a half megabytes, it needs no GPU to deploy, it cost nothing to train, and it processed all four hundred test images in eight minutes on a laptop.</a:t>
             </a:r>
             <a:endParaRPr lang="en-US" dirty="0"/>
           </a:p>
@@ -1214,7 +1392,7 @@
           <a:p>
             <a:r>
               <a:rPr lang="en-US" dirty="0"/>
-              <a:t>We stand on proven open research — NAFNet for the architecture, PixelShuffle for upscaling, LPIPS for perceptual quality. Thank you — questions welcome.</a:t>
+              <a:t>Everything is open source and reproducible. Training cost nothing — two hours on a free Colab GPU. Every random seed is fixed, and the model file carries its own configuration, so anyone can rerun our exact pipeline from the README in four commands. There's also a live Streamlit demo — happy to show it.</a:t>
             </a:r>
             <a:endParaRPr lang="en-US" dirty="0"/>
           </a:p>
@@ -2008,6 +2186,670 @@
 </p:sld>
 </file>
 
+<file path=ppt/slides/slide10.xml><?xml version="1.0" encoding="utf-8"?>
+<p:sld xmlns:a="http://schemas.openxmlformats.org/drawingml/2006/main" xmlns:r="http://schemas.openxmlformats.org/officeDocument/2006/relationships" xmlns:p="http://schemas.openxmlformats.org/presentationml/2006/main">
+  <p:cSld name="Slide 10">
+    <p:spTree>
+      <p:nvGrpSpPr>
+        <p:cNvPr id="1" name=""/>
+        <p:cNvGrpSpPr/>
+        <p:nvPr/>
+      </p:nvGrpSpPr>
+      <p:grpSpPr>
+        <a:xfrm>
+          <a:off x="0" y="0"/>
+          <a:ext cx="0" cy="0"/>
+          <a:chOff x="0" y="0"/>
+          <a:chExt cx="0" cy="0"/>
+        </a:xfrm>
+      </p:grpSpPr>
+      <p:sp>
+        <p:nvSpPr>
+          <p:cNvPr id="2" name="Text 0"/>
+          <p:cNvSpPr/>
+          <p:nvPr/>
+        </p:nvSpPr>
+        <p:spPr>
+          <a:xfrm>
+            <a:off x="548640" y="320040"/>
+            <a:ext cx="11064240" cy="685800"/>
+          </a:xfrm>
+          <a:prstGeom prst="rect">
+            <a:avLst/>
+          </a:prstGeom>
+          <a:noFill/>
+          <a:ln/>
+        </p:spPr>
+        <p:txBody>
+          <a:bodyPr wrap="square" lIns="0" tIns="0" rIns="0" bIns="0" rtlCol="0" anchor="ctr"/>
+          <a:lstStyle/>
+          <a:p>
+            <a:pPr indent="0" marL="0">
+              <a:buNone/>
+            </a:pPr>
+            <a:r>
+              <a:rPr lang="en-US" sz="3200" b="1" dirty="0">
+                <a:solidFill>
+                  <a:srgbClr val="1E2761"/>
+                </a:solidFill>
+                <a:latin typeface="Arial" pitchFamily="34" charset="0"/>
+                <a:ea typeface="Arial" pitchFamily="34" charset="-122"/>
+                <a:cs typeface="Arial" pitchFamily="34" charset="-120"/>
+              </a:rPr>
+              <a:t>Code &amp; Reproducibility</a:t>
+            </a:r>
+            <a:endParaRPr lang="en-US" sz="3200" dirty="0"/>
+          </a:p>
+        </p:txBody>
+      </p:sp>
+      <p:sp>
+        <p:nvSpPr>
+          <p:cNvPr id="3" name="Text 1"/>
+          <p:cNvSpPr/>
+          <p:nvPr/>
+        </p:nvSpPr>
+        <p:spPr>
+          <a:xfrm>
+            <a:off x="548640" y="1371600"/>
+            <a:ext cx="5394960" cy="3383280"/>
+          </a:xfrm>
+          <a:prstGeom prst="roundRect">
+            <a:avLst>
+              <a:gd name="adj" fmla="val 2703"/>
+            </a:avLst>
+          </a:prstGeom>
+          <a:solidFill>
+            <a:srgbClr val="F4F7FD"/>
+          </a:solidFill>
+          <a:ln/>
+        </p:spPr>
+        <p:txBody>
+          <a:bodyPr wrap="square" lIns="203200" tIns="203200" rIns="203200" bIns="203200" rtlCol="0" anchor="ctr"/>
+          <a:lstStyle/>
+          <a:p>
+            <a:pPr indent="0" marL="0">
+              <a:buNone/>
+            </a:pPr>
+            <a:r>
+              <a:rPr lang="en-US" sz="1300" dirty="0">
+                <a:solidFill>
+                  <a:srgbClr val="1E2761"/>
+                </a:solidFill>
+                <a:latin typeface="Courier New" pitchFamily="34" charset="0"/>
+                <a:ea typeface="Courier New" pitchFamily="34" charset="-122"/>
+                <a:cs typeface="Courier New" pitchFamily="34" charset="-120"/>
+              </a:rPr>
+              <a:t>project/</a:t>
+            </a:r>
+            <a:endParaRPr lang="en-US" sz="1300" dirty="0"/>
+          </a:p>
+          <a:p>
+            <a:pPr indent="0" marL="0">
+              <a:buNone/>
+            </a:pPr>
+            <a:r>
+              <a:rPr lang="en-US" sz="1300" dirty="0">
+                <a:solidFill>
+                  <a:srgbClr val="1E2761"/>
+                </a:solidFill>
+                <a:latin typeface="Courier New" pitchFamily="34" charset="0"/>
+                <a:ea typeface="Courier New" pitchFamily="34" charset="-122"/>
+                <a:cs typeface="Courier New" pitchFamily="34" charset="-120"/>
+              </a:rPr>
+              <a:t>├─ dataset/      loader + degradation pipeline</a:t>
+            </a:r>
+            <a:endParaRPr lang="en-US" sz="1300" dirty="0"/>
+          </a:p>
+          <a:p>
+            <a:pPr indent="0" marL="0">
+              <a:buNone/>
+            </a:pPr>
+            <a:r>
+              <a:rPr lang="en-US" sz="1300" dirty="0">
+                <a:solidFill>
+                  <a:srgbClr val="1E2761"/>
+                </a:solidFill>
+                <a:latin typeface="Courier New" pitchFamily="34" charset="0"/>
+                <a:ea typeface="Courier New" pitchFamily="34" charset="-122"/>
+                <a:cs typeface="Courier New" pitchFamily="34" charset="-120"/>
+              </a:rPr>
+              <a:t>├─ models/       nafnet.py (the architecture)</a:t>
+            </a:r>
+            <a:endParaRPr lang="en-US" sz="1300" dirty="0"/>
+          </a:p>
+          <a:p>
+            <a:pPr indent="0" marL="0">
+              <a:buNone/>
+            </a:pPr>
+            <a:r>
+              <a:rPr lang="en-US" sz="1300" dirty="0">
+                <a:solidFill>
+                  <a:srgbClr val="1E2761"/>
+                </a:solidFill>
+                <a:latin typeface="Courier New" pitchFamily="34" charset="0"/>
+                <a:ea typeface="Courier New" pitchFamily="34" charset="-122"/>
+                <a:cs typeface="Courier New" pitchFamily="34" charset="-120"/>
+              </a:rPr>
+              <a:t>├─ utils/        image_io · losses · metrics</a:t>
+            </a:r>
+            <a:endParaRPr lang="en-US" sz="1300" dirty="0"/>
+          </a:p>
+          <a:p>
+            <a:pPr indent="0" marL="0">
+              <a:buNone/>
+            </a:pPr>
+            <a:r>
+              <a:rPr lang="en-US" sz="1300" dirty="0">
+                <a:solidFill>
+                  <a:srgbClr val="1E2761"/>
+                </a:solidFill>
+                <a:latin typeface="Courier New" pitchFamily="34" charset="0"/>
+                <a:ea typeface="Courier New" pitchFamily="34" charset="-122"/>
+                <a:cs typeface="Courier New" pitchFamily="34" charset="-120"/>
+              </a:rPr>
+              <a:t>├─ train.py      training loop</a:t>
+            </a:r>
+            <a:endParaRPr lang="en-US" sz="1300" dirty="0"/>
+          </a:p>
+          <a:p>
+            <a:pPr indent="0" marL="0">
+              <a:buNone/>
+            </a:pPr>
+            <a:r>
+              <a:rPr lang="en-US" sz="1300" dirty="0">
+                <a:solidFill>
+                  <a:srgbClr val="1E2761"/>
+                </a:solidFill>
+                <a:latin typeface="Courier New" pitchFamily="34" charset="0"/>
+                <a:ea typeface="Courier New" pitchFamily="34" charset="-122"/>
+                <a:cs typeface="Courier New" pitchFamily="34" charset="-120"/>
+              </a:rPr>
+              <a:t>├─ evaluate.py   metric report (CSV)</a:t>
+            </a:r>
+            <a:endParaRPr lang="en-US" sz="1300" dirty="0"/>
+          </a:p>
+          <a:p>
+            <a:pPr indent="0" marL="0">
+              <a:buNone/>
+            </a:pPr>
+            <a:r>
+              <a:rPr lang="en-US" sz="1300" dirty="0">
+                <a:solidFill>
+                  <a:srgbClr val="1E2761"/>
+                </a:solidFill>
+                <a:latin typeface="Courier New" pitchFamily="34" charset="0"/>
+                <a:ea typeface="Courier New" pitchFamily="34" charset="-122"/>
+                <a:cs typeface="Courier New" pitchFamily="34" charset="-120"/>
+              </a:rPr>
+              <a:t>├─ inference.py  batch restore → submission</a:t>
+            </a:r>
+            <a:endParaRPr lang="en-US" sz="1300" dirty="0"/>
+          </a:p>
+          <a:p>
+            <a:pPr indent="0" marL="0">
+              <a:buNone/>
+            </a:pPr>
+            <a:r>
+              <a:rPr lang="en-US" sz="1300" dirty="0">
+                <a:solidFill>
+                  <a:srgbClr val="1E2761"/>
+                </a:solidFill>
+                <a:latin typeface="Courier New" pitchFamily="34" charset="0"/>
+                <a:ea typeface="Courier New" pitchFamily="34" charset="-122"/>
+                <a:cs typeface="Courier New" pitchFamily="34" charset="-120"/>
+              </a:rPr>
+              <a:t>├─ app.py        Streamlit demo</a:t>
+            </a:r>
+            <a:endParaRPr lang="en-US" sz="1300" dirty="0"/>
+          </a:p>
+          <a:p>
+            <a:pPr indent="0" marL="0">
+              <a:buNone/>
+            </a:pPr>
+            <a:r>
+              <a:rPr lang="en-US" sz="1300" dirty="0">
+                <a:solidFill>
+                  <a:srgbClr val="1E2761"/>
+                </a:solidFill>
+                <a:latin typeface="Courier New" pitchFamily="34" charset="0"/>
+                <a:ea typeface="Courier New" pitchFamily="34" charset="-122"/>
+                <a:cs typeface="Courier New" pitchFamily="34" charset="-120"/>
+              </a:rPr>
+              <a:t>└─ README.md     results + 4-command repro</a:t>
+            </a:r>
+            <a:endParaRPr lang="en-US" sz="1300" dirty="0"/>
+          </a:p>
+        </p:txBody>
+      </p:sp>
+      <p:sp>
+        <p:nvSpPr>
+          <p:cNvPr id="4" name="Text 2"/>
+          <p:cNvSpPr/>
+          <p:nvPr/>
+        </p:nvSpPr>
+        <p:spPr>
+          <a:xfrm>
+            <a:off x="6400800" y="1463040"/>
+            <a:ext cx="5212080" cy="2286000"/>
+          </a:xfrm>
+          <a:prstGeom prst="rect">
+            <a:avLst/>
+          </a:prstGeom>
+          <a:noFill/>
+          <a:ln/>
+        </p:spPr>
+        <p:txBody>
+          <a:bodyPr wrap="square" lIns="0" tIns="0" rIns="0" bIns="0" rtlCol="0" anchor="t"/>
+          <a:lstStyle/>
+          <a:p>
+            <a:pPr marL="342900" indent="-342900">
+              <a:spcAft>
+                <a:spcPts val="1200"/>
+              </a:spcAft>
+              <a:buSzPct val="100000"/>
+              <a:buChar char="•"/>
+            </a:pPr>
+            <a:r>
+              <a:rPr lang="en-US" sz="1450" dirty="0">
+                <a:solidFill>
+                  <a:srgbClr val="222222"/>
+                </a:solidFill>
+                <a:latin typeface="Calibri" pitchFamily="34" charset="0"/>
+                <a:ea typeface="Calibri" pitchFamily="34" charset="-122"/>
+                <a:cs typeface="Calibri" pitchFamily="34" charset="-120"/>
+              </a:rPr>
+              <a:t>Small and readable on purpose — nine short modules</a:t>
+            </a:r>
+            <a:endParaRPr lang="en-US" sz="1450" dirty="0"/>
+          </a:p>
+          <a:p>
+            <a:pPr marL="342900" indent="-342900">
+              <a:spcAft>
+                <a:spcPts val="1200"/>
+              </a:spcAft>
+              <a:buSzPct val="100000"/>
+              <a:buChar char="•"/>
+            </a:pPr>
+            <a:r>
+              <a:rPr lang="en-US" sz="1450" dirty="0">
+                <a:solidFill>
+                  <a:srgbClr val="222222"/>
+                </a:solidFill>
+                <a:latin typeface="Calibri" pitchFamily="34" charset="0"/>
+                <a:ea typeface="Calibri" pitchFamily="34" charset="-122"/>
+                <a:cs typeface="Calibri" pitchFamily="34" charset="-120"/>
+              </a:rPr>
+              <a:t>Every file commented with WHY, not just what</a:t>
+            </a:r>
+            <a:endParaRPr lang="en-US" sz="1450" dirty="0"/>
+          </a:p>
+          <a:p>
+            <a:pPr marL="342900" indent="-342900">
+              <a:spcAft>
+                <a:spcPts val="1200"/>
+              </a:spcAft>
+              <a:buSzPct val="100000"/>
+              <a:buChar char="•"/>
+            </a:pPr>
+            <a:r>
+              <a:rPr lang="en-US" sz="1450" dirty="0">
+                <a:solidFill>
+                  <a:srgbClr val="222222"/>
+                </a:solidFill>
+                <a:latin typeface="Calibri" pitchFamily="34" charset="0"/>
+                <a:ea typeface="Calibri" pitchFamily="34" charset="-122"/>
+                <a:cs typeface="Calibri" pitchFamily="34" charset="-120"/>
+              </a:rPr>
+              <a:t>README reproduces every number in this deck with 4 commands</a:t>
+            </a:r>
+            <a:endParaRPr lang="en-US" sz="1450" dirty="0"/>
+          </a:p>
+          <a:p>
+            <a:pPr marL="342900" indent="-342900">
+              <a:spcAft>
+                <a:spcPts val="1200"/>
+              </a:spcAft>
+              <a:buSzPct val="100000"/>
+              <a:buChar char="•"/>
+            </a:pPr>
+            <a:r>
+              <a:rPr lang="en-US" sz="1450" dirty="0">
+                <a:solidFill>
+                  <a:srgbClr val="222222"/>
+                </a:solidFill>
+                <a:latin typeface="Calibri" pitchFamily="34" charset="0"/>
+                <a:ea typeface="Calibri" pitchFamily="34" charset="-122"/>
+                <a:cs typeface="Calibri" pitchFamily="34" charset="-120"/>
+              </a:rPr>
+              <a:t>Trained model (6.8 MB) committed with the code</a:t>
+            </a:r>
+            <a:endParaRPr lang="en-US" sz="1450" dirty="0"/>
+          </a:p>
+        </p:txBody>
+      </p:sp>
+      <p:sp>
+        <p:nvSpPr>
+          <p:cNvPr id="5" name="Text 3"/>
+          <p:cNvSpPr/>
+          <p:nvPr/>
+        </p:nvSpPr>
+        <p:spPr>
+          <a:xfrm>
+            <a:off x="6400800" y="3977640"/>
+            <a:ext cx="5212080" cy="868680"/>
+          </a:xfrm>
+          <a:prstGeom prst="roundRect">
+            <a:avLst>
+              <a:gd name="adj" fmla="val 10526"/>
+            </a:avLst>
+          </a:prstGeom>
+          <a:solidFill>
+            <a:srgbClr val="1E2761"/>
+          </a:solidFill>
+          <a:ln/>
+        </p:spPr>
+        <p:txBody>
+          <a:bodyPr wrap="square" rtlCol="0" anchor="ctr"/>
+          <a:lstStyle/>
+          <a:p>
+            <a:pPr algn="ctr" indent="0" marL="0">
+              <a:buNone/>
+            </a:pPr>
+            <a:r>
+              <a:rPr lang="en-US" sz="1400" b="1" dirty="0">
+                <a:solidFill>
+                  <a:srgbClr val="FFFFFF"/>
+                </a:solidFill>
+                <a:latin typeface="Courier New" pitchFamily="34" charset="0"/>
+                <a:ea typeface="Courier New" pitchFamily="34" charset="-122"/>
+                <a:cs typeface="Courier New" pitchFamily="34" charset="-120"/>
+              </a:rPr>
+              <a:t>github.com/prakharbajaj1551/</a:t>
+            </a:r>
+            <a:endParaRPr lang="en-US" sz="1400" dirty="0"/>
+          </a:p>
+          <a:p>
+            <a:pPr algn="ctr" indent="0" marL="0">
+              <a:buNone/>
+            </a:pPr>
+            <a:r>
+              <a:rPr lang="en-US" sz="1400" b="1" dirty="0">
+                <a:solidFill>
+                  <a:srgbClr val="FFFFFF"/>
+                </a:solidFill>
+                <a:latin typeface="Courier New" pitchFamily="34" charset="0"/>
+                <a:ea typeface="Courier New" pitchFamily="34" charset="-122"/>
+                <a:cs typeface="Courier New" pitchFamily="34" charset="-120"/>
+              </a:rPr>
+              <a:t>semicon-image-restoration</a:t>
+            </a:r>
+            <a:endParaRPr lang="en-US" sz="1400" dirty="0"/>
+          </a:p>
+        </p:txBody>
+      </p:sp>
+    </p:spTree>
+  </p:cSld>
+  <p:clrMapOvr>
+    <a:masterClrMapping/>
+  </p:clrMapOvr>
+</p:sld>
+</file>
+
+<file path=ppt/slides/slide11.xml><?xml version="1.0" encoding="utf-8"?>
+<p:sld xmlns:a="http://schemas.openxmlformats.org/drawingml/2006/main" xmlns:r="http://schemas.openxmlformats.org/officeDocument/2006/relationships" xmlns:p="http://schemas.openxmlformats.org/presentationml/2006/main">
+  <p:cSld name="Slide 11">
+    <p:bg>
+      <p:bgPr>
+        <a:solidFill>
+          <a:srgbClr val="1E2761"/>
+        </a:solidFill>
+      </p:bgPr>
+    </p:bg>
+    <p:spTree>
+      <p:nvGrpSpPr>
+        <p:cNvPr id="1" name=""/>
+        <p:cNvGrpSpPr/>
+        <p:nvPr/>
+      </p:nvGrpSpPr>
+      <p:grpSpPr>
+        <a:xfrm>
+          <a:off x="0" y="0"/>
+          <a:ext cx="0" cy="0"/>
+          <a:chOff x="0" y="0"/>
+          <a:chExt cx="0" cy="0"/>
+        </a:xfrm>
+      </p:grpSpPr>
+      <p:sp>
+        <p:nvSpPr>
+          <p:cNvPr id="2" name="Text 0"/>
+          <p:cNvSpPr/>
+          <p:nvPr/>
+        </p:nvSpPr>
+        <p:spPr>
+          <a:xfrm>
+            <a:off x="731520" y="548640"/>
+            <a:ext cx="10058400" cy="731520"/>
+          </a:xfrm>
+          <a:prstGeom prst="rect">
+            <a:avLst/>
+          </a:prstGeom>
+          <a:noFill/>
+          <a:ln/>
+        </p:spPr>
+        <p:txBody>
+          <a:bodyPr wrap="square" lIns="0" tIns="0" rIns="0" bIns="0" rtlCol="0" anchor="ctr"/>
+          <a:lstStyle/>
+          <a:p>
+            <a:pPr indent="0" marL="0">
+              <a:buNone/>
+            </a:pPr>
+            <a:r>
+              <a:rPr lang="en-US" sz="3200" b="1" dirty="0">
+                <a:solidFill>
+                  <a:srgbClr val="FFFFFF"/>
+                </a:solidFill>
+                <a:latin typeface="Arial" pitchFamily="34" charset="0"/>
+                <a:ea typeface="Arial" pitchFamily="34" charset="-122"/>
+                <a:cs typeface="Arial" pitchFamily="34" charset="-120"/>
+              </a:rPr>
+              <a:t>References</a:t>
+            </a:r>
+            <a:endParaRPr lang="en-US" sz="3200" dirty="0"/>
+          </a:p>
+        </p:txBody>
+      </p:sp>
+      <p:sp>
+        <p:nvSpPr>
+          <p:cNvPr id="3" name="Text 1"/>
+          <p:cNvSpPr/>
+          <p:nvPr/>
+        </p:nvSpPr>
+        <p:spPr>
+          <a:xfrm>
+            <a:off x="731520" y="1645920"/>
+            <a:ext cx="10698480" cy="2377440"/>
+          </a:xfrm>
+          <a:prstGeom prst="rect">
+            <a:avLst/>
+          </a:prstGeom>
+          <a:noFill/>
+          <a:ln/>
+        </p:spPr>
+        <p:txBody>
+          <a:bodyPr wrap="square" lIns="0" tIns="0" rIns="0" bIns="0" rtlCol="0" anchor="t"/>
+          <a:lstStyle/>
+          <a:p>
+            <a:pPr marL="342900" indent="-342900">
+              <a:spcAft>
+                <a:spcPts val="1400"/>
+              </a:spcAft>
+              <a:buSzPct val="100000"/>
+              <a:buChar char="•"/>
+            </a:pPr>
+            <a:r>
+              <a:rPr lang="en-US" sz="1500" dirty="0">
+                <a:solidFill>
+                  <a:srgbClr val="CADCFC"/>
+                </a:solidFill>
+                <a:latin typeface="Calibri" pitchFamily="34" charset="0"/>
+                <a:ea typeface="Calibri" pitchFamily="34" charset="-122"/>
+                <a:cs typeface="Calibri" pitchFamily="34" charset="-120"/>
+              </a:rPr>
+              <a:t>Chen et al. — “Simple Baselines for Image Restoration” (NAFNet), ECCV 2022 · arXiv:2204.04676</a:t>
+            </a:r>
+            <a:endParaRPr lang="en-US" sz="1500" dirty="0"/>
+          </a:p>
+          <a:p>
+            <a:pPr marL="342900" indent="-342900">
+              <a:spcAft>
+                <a:spcPts val="1400"/>
+              </a:spcAft>
+              <a:buSzPct val="100000"/>
+              <a:buChar char="•"/>
+            </a:pPr>
+            <a:r>
+              <a:rPr lang="en-US" sz="1500" dirty="0">
+                <a:solidFill>
+                  <a:srgbClr val="CADCFC"/>
+                </a:solidFill>
+                <a:latin typeface="Calibri" pitchFamily="34" charset="0"/>
+                <a:ea typeface="Calibri" pitchFamily="34" charset="-122"/>
+                <a:cs typeface="Calibri" pitchFamily="34" charset="-120"/>
+              </a:rPr>
+              <a:t>Shi et al. — “Real-Time Single Image Super-Resolution Using an Efficient Sub-Pixel CNN” (PixelShuffle), CVPR 2016</a:t>
+            </a:r>
+            <a:endParaRPr lang="en-US" sz="1500" dirty="0"/>
+          </a:p>
+          <a:p>
+            <a:pPr marL="342900" indent="-342900">
+              <a:spcAft>
+                <a:spcPts val="1400"/>
+              </a:spcAft>
+              <a:buSzPct val="100000"/>
+              <a:buChar char="•"/>
+            </a:pPr>
+            <a:r>
+              <a:rPr lang="en-US" sz="1500" dirty="0">
+                <a:solidFill>
+                  <a:srgbClr val="CADCFC"/>
+                </a:solidFill>
+                <a:latin typeface="Calibri" pitchFamily="34" charset="0"/>
+                <a:ea typeface="Calibri" pitchFamily="34" charset="-122"/>
+                <a:cs typeface="Calibri" pitchFamily="34" charset="-120"/>
+              </a:rPr>
+              <a:t>Zhang et al. — “The Unreasonable Effectiveness of Deep Features as a Perceptual Metric” (LPIPS), CVPR 2018</a:t>
+            </a:r>
+            <a:endParaRPr lang="en-US" sz="1500" dirty="0"/>
+          </a:p>
+          <a:p>
+            <a:pPr marL="342900" indent="-342900">
+              <a:spcAft>
+                <a:spcPts val="1400"/>
+              </a:spcAft>
+              <a:buSzPct val="100000"/>
+              <a:buChar char="•"/>
+            </a:pPr>
+            <a:r>
+              <a:rPr lang="en-US" sz="1500" dirty="0">
+                <a:solidFill>
+                  <a:srgbClr val="CADCFC"/>
+                </a:solidFill>
+                <a:latin typeface="Calibri" pitchFamily="34" charset="0"/>
+                <a:ea typeface="Calibri" pitchFamily="34" charset="-122"/>
+                <a:cs typeface="Calibri" pitchFamily="34" charset="-120"/>
+              </a:rPr>
+              <a:t>Open-source libraries: PyTorch · pytorch-msssim · lpips · scikit-image · Streamlit</a:t>
+            </a:r>
+            <a:endParaRPr lang="en-US" sz="1500" dirty="0"/>
+          </a:p>
+        </p:txBody>
+      </p:sp>
+      <p:sp>
+        <p:nvSpPr>
+          <p:cNvPr id="4" name="Text 2"/>
+          <p:cNvSpPr/>
+          <p:nvPr/>
+        </p:nvSpPr>
+        <p:spPr>
+          <a:xfrm>
+            <a:off x="731520" y="4846320"/>
+            <a:ext cx="10698480" cy="731520"/>
+          </a:xfrm>
+          <a:prstGeom prst="rect">
+            <a:avLst/>
+          </a:prstGeom>
+          <a:noFill/>
+          <a:ln/>
+        </p:spPr>
+        <p:txBody>
+          <a:bodyPr wrap="square" lIns="0" tIns="0" rIns="0" bIns="0" rtlCol="0" anchor="ctr"/>
+          <a:lstStyle/>
+          <a:p>
+            <a:pPr indent="0" marL="0">
+              <a:buNone/>
+            </a:pPr>
+            <a:r>
+              <a:rPr lang="en-US" sz="4000" b="1" dirty="0">
+                <a:solidFill>
+                  <a:srgbClr val="FFFFFF"/>
+                </a:solidFill>
+                <a:latin typeface="Arial" pitchFamily="34" charset="0"/>
+                <a:ea typeface="Arial" pitchFamily="34" charset="-122"/>
+                <a:cs typeface="Arial" pitchFamily="34" charset="-120"/>
+              </a:rPr>
+              <a:t>Thank you</a:t>
+            </a:r>
+            <a:endParaRPr lang="en-US" sz="4000" dirty="0"/>
+          </a:p>
+        </p:txBody>
+      </p:sp>
+      <p:sp>
+        <p:nvSpPr>
+          <p:cNvPr id="5" name="Text 3"/>
+          <p:cNvSpPr/>
+          <p:nvPr/>
+        </p:nvSpPr>
+        <p:spPr>
+          <a:xfrm>
+            <a:off x="731520" y="5669280"/>
+            <a:ext cx="10698480" cy="457200"/>
+          </a:xfrm>
+          <a:prstGeom prst="rect">
+            <a:avLst/>
+          </a:prstGeom>
+          <a:noFill/>
+          <a:ln/>
+        </p:spPr>
+        <p:txBody>
+          <a:bodyPr wrap="square" lIns="0" tIns="0" rIns="0" bIns="0" rtlCol="0" anchor="ctr"/>
+          <a:lstStyle/>
+          <a:p>
+            <a:pPr indent="0" marL="0">
+              <a:buNone/>
+            </a:pPr>
+            <a:r>
+              <a:rPr lang="en-US" sz="1600" dirty="0">
+                <a:solidFill>
+                  <a:srgbClr val="02C39A"/>
+                </a:solidFill>
+                <a:latin typeface="Calibri" pitchFamily="34" charset="0"/>
+                <a:ea typeface="Calibri" pitchFamily="34" charset="-122"/>
+                <a:cs typeface="Calibri" pitchFamily="34" charset="-120"/>
+              </a:rPr>
+              <a:t>Team BYTE BRIGADE  ·  questions welcome</a:t>
+            </a:r>
+            <a:endParaRPr lang="en-US" sz="1600" dirty="0"/>
+          </a:p>
+        </p:txBody>
+      </p:sp>
+    </p:spTree>
+  </p:cSld>
+  <p:clrMapOvr>
+    <a:masterClrMapping/>
+  </p:clrMapOvr>
+</p:sld>
+</file>
+
 <file path=ppt/slides/slide2.xml><?xml version="1.0" encoding="utf-8"?>
 <p:sld xmlns:a="http://schemas.openxmlformats.org/drawingml/2006/main" xmlns:r="http://schemas.openxmlformats.org/officeDocument/2006/relationships" xmlns:p="http://schemas.openxmlformats.org/presentationml/2006/main">
   <p:cSld name="Slide 2">
@@ -3745,7 +4587,7 @@
                 <a:ea typeface="Arial" pitchFamily="34" charset="-122"/>
                 <a:cs typeface="Arial" pitchFamily="34" charset="-120"/>
               </a:rPr>
-              <a:t>Innovation</a:t>
+              <a:t>Training Strategy</a:t>
             </a:r>
             <a:endParaRPr lang="en-US" sz="3200" dirty="0"/>
           </a:p>
@@ -3753,18 +4595,347 @@
       </p:sp>
       <p:sp>
         <p:nvSpPr>
-          <p:cNvPr id="3" name="Shape 1"/>
-          <p:cNvSpPr/>
-          <p:nvPr/>
-        </p:nvSpPr>
-        <p:spPr>
-          <a:xfrm>
-            <a:off x="548640" y="1417320"/>
-            <a:ext cx="5486400" cy="2103120"/>
+          <p:cNvPr id="3" name="Text 1"/>
+          <p:cNvSpPr/>
+          <p:nvPr/>
+        </p:nvSpPr>
+        <p:spPr>
+          <a:xfrm>
+            <a:off x="548640" y="1234440"/>
+            <a:ext cx="5120640" cy="320040"/>
+          </a:xfrm>
+          <a:prstGeom prst="rect">
+            <a:avLst/>
+          </a:prstGeom>
+          <a:noFill/>
+          <a:ln/>
+        </p:spPr>
+        <p:txBody>
+          <a:bodyPr wrap="square" lIns="0" tIns="0" rIns="0" bIns="0" rtlCol="0" anchor="ctr"/>
+          <a:lstStyle/>
+          <a:p>
+            <a:pPr indent="0" marL="0">
+              <a:buNone/>
+            </a:pPr>
+            <a:r>
+              <a:rPr lang="en-US" sz="1700" b="1" dirty="0">
+                <a:solidFill>
+                  <a:srgbClr val="1E2761"/>
+                </a:solidFill>
+                <a:latin typeface="Arial" pitchFamily="34" charset="0"/>
+                <a:ea typeface="Arial" pitchFamily="34" charset="-122"/>
+                <a:cs typeface="Arial" pitchFamily="34" charset="-120"/>
+              </a:rPr>
+              <a:t>Data</a:t>
+            </a:r>
+            <a:endParaRPr lang="en-US" sz="1700" dirty="0"/>
+          </a:p>
+        </p:txBody>
+      </p:sp>
+      <p:sp>
+        <p:nvSpPr>
+          <p:cNvPr id="4" name="Text 2"/>
+          <p:cNvSpPr/>
+          <p:nvPr/>
+        </p:nvSpPr>
+        <p:spPr>
+          <a:xfrm>
+            <a:off x="548640" y="1600200"/>
+            <a:ext cx="5212080" cy="2194560"/>
+          </a:xfrm>
+          <a:prstGeom prst="rect">
+            <a:avLst/>
+          </a:prstGeom>
+          <a:noFill/>
+          <a:ln/>
+        </p:spPr>
+        <p:txBody>
+          <a:bodyPr wrap="square" lIns="0" tIns="0" rIns="0" bIns="0" rtlCol="0" anchor="t"/>
+          <a:lstStyle/>
+          <a:p>
+            <a:pPr marL="342900" indent="-342900">
+              <a:spcAft>
+                <a:spcPts val="900"/>
+              </a:spcAft>
+              <a:buSzPct val="100000"/>
+              <a:buChar char="•"/>
+            </a:pPr>
+            <a:r>
+              <a:rPr lang="en-US" sz="1350" dirty="0">
+                <a:solidFill>
+                  <a:srgbClr val="222222"/>
+                </a:solidFill>
+                <a:latin typeface="Calibri" pitchFamily="34" charset="0"/>
+                <a:ea typeface="Calibri" pitchFamily="34" charset="-122"/>
+                <a:cs typeface="Calibri" pitchFamily="34" charset="-120"/>
+              </a:rPr>
+              <a:t>3,200 organiser pairs → 3,000 train / 100 validation / 100 held-out test</a:t>
+            </a:r>
+            <a:endParaRPr lang="en-US" sz="1350" dirty="0"/>
+          </a:p>
+          <a:p>
+            <a:pPr marL="342900" indent="-342900">
+              <a:spcAft>
+                <a:spcPts val="900"/>
+              </a:spcAft>
+              <a:buSzPct val="100000"/>
+              <a:buChar char="•"/>
+            </a:pPr>
+            <a:r>
+              <a:rPr lang="en-US" sz="1350" dirty="0">
+                <a:solidFill>
+                  <a:srgbClr val="222222"/>
+                </a:solidFill>
+                <a:latin typeface="Calibri" pitchFamily="34" charset="0"/>
+                <a:ea typeface="Calibri" pitchFamily="34" charset="-122"/>
+                <a:cs typeface="Calibri" pitchFamily="34" charset="-120"/>
+              </a:rPr>
+              <a:t>Seeded split (seed 42) — reproducible on any machine</a:t>
+            </a:r>
+            <a:endParaRPr lang="en-US" sz="1350" dirty="0"/>
+          </a:p>
+          <a:p>
+            <a:pPr marL="342900" indent="-342900">
+              <a:spcAft>
+                <a:spcPts val="900"/>
+              </a:spcAft>
+              <a:buSzPct val="100000"/>
+              <a:buChar char="•"/>
+            </a:pPr>
+            <a:r>
+              <a:rPr lang="en-US" sz="1350" dirty="0">
+                <a:solidFill>
+                  <a:srgbClr val="222222"/>
+                </a:solidFill>
+                <a:latin typeface="Calibri" pitchFamily="34" charset="0"/>
+                <a:ea typeface="Calibri" pitchFamily="34" charset="-122"/>
+                <a:cs typeface="Calibri" pitchFamily="34" charset="-120"/>
+              </a:rPr>
+              <a:t>128 px random crops · batch of 16 — more examples per GPU step</a:t>
+            </a:r>
+            <a:endParaRPr lang="en-US" sz="1350" dirty="0"/>
+          </a:p>
+          <a:p>
+            <a:pPr marL="342900" indent="-342900">
+              <a:spcAft>
+                <a:spcPts val="900"/>
+              </a:spcAft>
+              <a:buSzPct val="100000"/>
+              <a:buChar char="•"/>
+            </a:pPr>
+            <a:r>
+              <a:rPr lang="en-US" sz="1350" dirty="0">
+                <a:solidFill>
+                  <a:srgbClr val="222222"/>
+                </a:solidFill>
+                <a:latin typeface="Calibri" pitchFamily="34" charset="0"/>
+                <a:ea typeface="Calibri" pitchFamily="34" charset="-122"/>
+                <a:cs typeface="Calibri" pitchFamily="34" charset="-120"/>
+              </a:rPr>
+              <a:t>8× augmentation: flips + 90° rotations applied identically to input and target</a:t>
+            </a:r>
+            <a:endParaRPr lang="en-US" sz="1350" dirty="0"/>
+          </a:p>
+        </p:txBody>
+      </p:sp>
+      <p:sp>
+        <p:nvSpPr>
+          <p:cNvPr id="5" name="Text 3"/>
+          <p:cNvSpPr/>
+          <p:nvPr/>
+        </p:nvSpPr>
+        <p:spPr>
+          <a:xfrm>
+            <a:off x="6309360" y="1234440"/>
+            <a:ext cx="5212080" cy="320040"/>
+          </a:xfrm>
+          <a:prstGeom prst="rect">
+            <a:avLst/>
+          </a:prstGeom>
+          <a:noFill/>
+          <a:ln/>
+        </p:spPr>
+        <p:txBody>
+          <a:bodyPr wrap="square" lIns="0" tIns="0" rIns="0" bIns="0" rtlCol="0" anchor="ctr"/>
+          <a:lstStyle/>
+          <a:p>
+            <a:pPr indent="0" marL="0">
+              <a:buNone/>
+            </a:pPr>
+            <a:r>
+              <a:rPr lang="en-US" sz="1700" b="1" dirty="0">
+                <a:solidFill>
+                  <a:srgbClr val="1E2761"/>
+                </a:solidFill>
+                <a:latin typeface="Arial" pitchFamily="34" charset="0"/>
+                <a:ea typeface="Arial" pitchFamily="34" charset="-122"/>
+                <a:cs typeface="Arial" pitchFamily="34" charset="-120"/>
+              </a:rPr>
+              <a:t>Optimisation</a:t>
+            </a:r>
+            <a:endParaRPr lang="en-US" sz="1700" dirty="0"/>
+          </a:p>
+        </p:txBody>
+      </p:sp>
+      <p:sp>
+        <p:nvSpPr>
+          <p:cNvPr id="6" name="Text 4"/>
+          <p:cNvSpPr/>
+          <p:nvPr/>
+        </p:nvSpPr>
+        <p:spPr>
+          <a:xfrm>
+            <a:off x="6309360" y="1600200"/>
+            <a:ext cx="5303520" cy="2194560"/>
+          </a:xfrm>
+          <a:prstGeom prst="rect">
+            <a:avLst/>
+          </a:prstGeom>
+          <a:noFill/>
+          <a:ln/>
+        </p:spPr>
+        <p:txBody>
+          <a:bodyPr wrap="square" lIns="0" tIns="0" rIns="0" bIns="0" rtlCol="0" anchor="t"/>
+          <a:lstStyle/>
+          <a:p>
+            <a:pPr marL="342900" indent="-342900">
+              <a:spcAft>
+                <a:spcPts val="900"/>
+              </a:spcAft>
+              <a:buSzPct val="100000"/>
+              <a:buChar char="•"/>
+            </a:pPr>
+            <a:r>
+              <a:rPr lang="en-US" sz="1350" dirty="0">
+                <a:solidFill>
+                  <a:srgbClr val="222222"/>
+                </a:solidFill>
+                <a:latin typeface="Calibri" pitchFamily="34" charset="0"/>
+                <a:ea typeface="Calibri" pitchFamily="34" charset="-122"/>
+                <a:cs typeface="Calibri" pitchFamily="34" charset="-120"/>
+              </a:rPr>
+              <a:t>Loss = Charbonnier + 0.15·SSIM + 0.05·LPIPS  (fidelity leads)</a:t>
+            </a:r>
+            <a:endParaRPr lang="en-US" sz="1350" dirty="0"/>
+          </a:p>
+          <a:p>
+            <a:pPr marL="342900" indent="-342900">
+              <a:spcAft>
+                <a:spcPts val="900"/>
+              </a:spcAft>
+              <a:buSzPct val="100000"/>
+              <a:buChar char="•"/>
+            </a:pPr>
+            <a:r>
+              <a:rPr lang="en-US" sz="1350" dirty="0">
+                <a:solidFill>
+                  <a:srgbClr val="222222"/>
+                </a:solidFill>
+                <a:latin typeface="Calibri" pitchFamily="34" charset="0"/>
+                <a:ea typeface="Calibri" pitchFamily="34" charset="-122"/>
+                <a:cs typeface="Calibri" pitchFamily="34" charset="-120"/>
+              </a:rPr>
+              <a:t>AdamW, lr 2e-4, cosine decay to 1e-7 over 100 epochs</a:t>
+            </a:r>
+            <a:endParaRPr lang="en-US" sz="1350" dirty="0"/>
+          </a:p>
+          <a:p>
+            <a:pPr marL="342900" indent="-342900">
+              <a:spcAft>
+                <a:spcPts val="900"/>
+              </a:spcAft>
+              <a:buSzPct val="100000"/>
+              <a:buChar char="•"/>
+            </a:pPr>
+            <a:r>
+              <a:rPr lang="en-US" sz="1350" dirty="0">
+                <a:solidFill>
+                  <a:srgbClr val="222222"/>
+                </a:solidFill>
+                <a:latin typeface="Calibri" pitchFamily="34" charset="0"/>
+                <a:ea typeface="Calibri" pitchFamily="34" charset="-122"/>
+                <a:cs typeface="Calibri" pitchFamily="34" charset="-120"/>
+              </a:rPr>
+              <a:t>Gradient clipping — one bad batch cannot wreck the run</a:t>
+            </a:r>
+            <a:endParaRPr lang="en-US" sz="1350" dirty="0"/>
+          </a:p>
+          <a:p>
+            <a:pPr marL="342900" indent="-342900">
+              <a:spcAft>
+                <a:spcPts val="900"/>
+              </a:spcAft>
+              <a:buSzPct val="100000"/>
+              <a:buChar char="•"/>
+            </a:pPr>
+            <a:r>
+              <a:rPr lang="en-US" sz="1350" dirty="0">
+                <a:solidFill>
+                  <a:srgbClr val="222222"/>
+                </a:solidFill>
+                <a:latin typeface="Calibri" pitchFamily="34" charset="0"/>
+                <a:ea typeface="Calibri" pitchFamily="34" charset="-122"/>
+                <a:cs typeface="Calibri" pitchFamily="34" charset="-120"/>
+              </a:rPr>
+              <a:t>Validate every 5 epochs; keep the best-PSNR checkpoint (epoch 85)</a:t>
+            </a:r>
+            <a:endParaRPr lang="en-US" sz="1350" dirty="0"/>
+          </a:p>
+        </p:txBody>
+      </p:sp>
+      <p:sp>
+        <p:nvSpPr>
+          <p:cNvPr id="7" name="Text 5"/>
+          <p:cNvSpPr/>
+          <p:nvPr/>
+        </p:nvSpPr>
+        <p:spPr>
+          <a:xfrm>
+            <a:off x="548640" y="3931920"/>
+            <a:ext cx="5486400" cy="320040"/>
+          </a:xfrm>
+          <a:prstGeom prst="rect">
+            <a:avLst/>
+          </a:prstGeom>
+          <a:noFill/>
+          <a:ln/>
+        </p:spPr>
+        <p:txBody>
+          <a:bodyPr wrap="square" lIns="0" tIns="0" rIns="0" bIns="0" rtlCol="0" anchor="ctr"/>
+          <a:lstStyle/>
+          <a:p>
+            <a:pPr indent="0" marL="0">
+              <a:buNone/>
+            </a:pPr>
+            <a:r>
+              <a:rPr lang="en-US" sz="1500" b="1" dirty="0">
+                <a:solidFill>
+                  <a:srgbClr val="1E2761"/>
+                </a:solidFill>
+                <a:latin typeface="Arial" pitchFamily="34" charset="0"/>
+                <a:ea typeface="Arial" pitchFamily="34" charset="-122"/>
+                <a:cs typeface="Arial" pitchFamily="34" charset="-120"/>
+              </a:rPr>
+              <a:t>Validation PSNR during training</a:t>
+            </a:r>
+            <a:endParaRPr lang="en-US" sz="1500" dirty="0"/>
+          </a:p>
+        </p:txBody>
+      </p:sp>
+      <p:sp>
+        <p:nvSpPr>
+          <p:cNvPr id="8" name="Text 6"/>
+          <p:cNvSpPr/>
+          <p:nvPr/>
+        </p:nvSpPr>
+        <p:spPr>
+          <a:xfrm>
+            <a:off x="548640" y="4343400"/>
+            <a:ext cx="2606040" cy="914400"/>
           </a:xfrm>
           <a:prstGeom prst="roundRect">
             <a:avLst>
-              <a:gd name="adj" fmla="val 4348"/>
+              <a:gd name="adj" fmla="val 8000"/>
             </a:avLst>
           </a:prstGeom>
           <a:solidFill>
@@ -3772,26 +4943,6 @@
           </a:solidFill>
           <a:ln/>
         </p:spPr>
-      </p:sp>
-      <p:sp>
-        <p:nvSpPr>
-          <p:cNvPr id="4" name="Text 2"/>
-          <p:cNvSpPr/>
-          <p:nvPr/>
-        </p:nvSpPr>
-        <p:spPr>
-          <a:xfrm>
-            <a:off x="777240" y="1645920"/>
-            <a:ext cx="457200" cy="457200"/>
-          </a:xfrm>
-          <a:prstGeom prst="ellipse">
-            <a:avLst/>
-          </a:prstGeom>
-          <a:solidFill>
-            <a:srgbClr val="02C39A"/>
-          </a:solidFill>
-          <a:ln/>
-        </p:spPr>
         <p:txBody>
           <a:bodyPr wrap="square" lIns="0" tIns="0" rIns="0" bIns="0" rtlCol="0" anchor="ctr"/>
           <a:lstStyle/>
@@ -3800,96 +4951,51 @@
               <a:buNone/>
             </a:pPr>
             <a:r>
-              <a:rPr lang="en-US" sz="1700" b="1" dirty="0">
-                <a:solidFill>
-                  <a:srgbClr val="FFFFFF"/>
+              <a:rPr lang="en-US" sz="2000" b="1" dirty="0">
+                <a:solidFill>
+                  <a:srgbClr val="0A8F72"/>
                 </a:solidFill>
                 <a:latin typeface="Arial" pitchFamily="34" charset="0"/>
                 <a:ea typeface="Arial" pitchFamily="34" charset="-122"/>
                 <a:cs typeface="Arial" pitchFamily="34" charset="-120"/>
               </a:rPr>
-              <a:t>1</a:t>
-            </a:r>
-            <a:endParaRPr lang="en-US" sz="1700" dirty="0"/>
-          </a:p>
-        </p:txBody>
-      </p:sp>
-      <p:sp>
-        <p:nvSpPr>
-          <p:cNvPr id="5" name="Text 3"/>
-          <p:cNvSpPr/>
-          <p:nvPr/>
-        </p:nvSpPr>
-        <p:spPr>
-          <a:xfrm>
-            <a:off x="1417320" y="1581912"/>
-            <a:ext cx="4480560" cy="1828800"/>
-          </a:xfrm>
-          <a:prstGeom prst="rect">
-            <a:avLst/>
-          </a:prstGeom>
-          <a:noFill/>
-          <a:ln/>
-        </p:spPr>
-        <p:txBody>
-          <a:bodyPr wrap="square" lIns="0" tIns="0" rIns="0" bIns="0" rtlCol="0" anchor="t"/>
-          <a:lstStyle/>
-          <a:p>
-            <a:pPr indent="0" marL="0">
-              <a:spcAft>
-                <a:spcPts val="600"/>
-              </a:spcAft>
-              <a:buNone/>
-            </a:pPr>
-            <a:r>
-              <a:rPr lang="en-US" sz="1650" b="1" dirty="0">
-                <a:solidFill>
-                  <a:srgbClr val="1E2761"/>
-                </a:solidFill>
-                <a:latin typeface="Calibri" pitchFamily="34" charset="0"/>
-                <a:ea typeface="Calibri" pitchFamily="34" charset="-122"/>
-                <a:cs typeface="Calibri" pitchFamily="34" charset="-120"/>
-              </a:rPr>
-              <a:t>Simplicity as strategy</a:t>
-            </a:r>
-            <a:endParaRPr lang="en-US" sz="1650" dirty="0"/>
-          </a:p>
-          <a:p>
-            <a:pPr indent="0" marL="0">
-              <a:spcAft>
-                <a:spcPts val="600"/>
-              </a:spcAft>
-              <a:buNone/>
-            </a:pPr>
-            <a:r>
-              <a:rPr lang="en-US" sz="1250" dirty="0">
-                <a:solidFill>
-                  <a:srgbClr val="333333"/>
-                </a:solidFill>
-                <a:latin typeface="Calibri" pitchFamily="34" charset="0"/>
-                <a:ea typeface="Calibri" pitchFamily="34" charset="-122"/>
-                <a:cs typeface="Calibri" pitchFamily="34" charset="-120"/>
-              </a:rPr>
-              <a:t>State-of-the-art restoration family at 0.53 M parameters. Small enough to train free, run on CPU, and for the team to explain and debug every single line.</a:t>
-            </a:r>
-            <a:endParaRPr lang="en-US" sz="1650" dirty="0"/>
-          </a:p>
-        </p:txBody>
-      </p:sp>
-      <p:sp>
-        <p:nvSpPr>
-          <p:cNvPr id="6" name="Shape 4"/>
-          <p:cNvSpPr/>
-          <p:nvPr/>
-        </p:nvSpPr>
-        <p:spPr>
-          <a:xfrm>
-            <a:off x="6309360" y="1417320"/>
-            <a:ext cx="5486400" cy="2103120"/>
+              <a:t>26.16 dB</a:t>
+            </a:r>
+            <a:endParaRPr lang="en-US" sz="2000" dirty="0"/>
+          </a:p>
+          <a:p>
+            <a:pPr algn="ctr" indent="0" marL="0">
+              <a:buNone/>
+            </a:pPr>
+            <a:r>
+              <a:rPr lang="en-US" sz="1100" dirty="0">
+                <a:solidFill>
+                  <a:srgbClr val="5A6478"/>
+                </a:solidFill>
+                <a:latin typeface="Arial" pitchFamily="34" charset="0"/>
+                <a:ea typeface="Arial" pitchFamily="34" charset="-122"/>
+                <a:cs typeface="Arial" pitchFamily="34" charset="-120"/>
+              </a:rPr>
+              <a:t>epoch 5</a:t>
+            </a:r>
+            <a:endParaRPr lang="en-US" sz="2000" dirty="0"/>
+          </a:p>
+        </p:txBody>
+      </p:sp>
+      <p:sp>
+        <p:nvSpPr>
+          <p:cNvPr id="9" name="Text 7"/>
+          <p:cNvSpPr/>
+          <p:nvPr/>
+        </p:nvSpPr>
+        <p:spPr>
+          <a:xfrm>
+            <a:off x="3337560" y="4343400"/>
+            <a:ext cx="2606040" cy="914400"/>
           </a:xfrm>
           <a:prstGeom prst="roundRect">
             <a:avLst>
-              <a:gd name="adj" fmla="val 4348"/>
+              <a:gd name="adj" fmla="val 8000"/>
             </a:avLst>
           </a:prstGeom>
           <a:solidFill>
@@ -3897,26 +5003,6 @@
           </a:solidFill>
           <a:ln/>
         </p:spPr>
-      </p:sp>
-      <p:sp>
-        <p:nvSpPr>
-          <p:cNvPr id="7" name="Text 5"/>
-          <p:cNvSpPr/>
-          <p:nvPr/>
-        </p:nvSpPr>
-        <p:spPr>
-          <a:xfrm>
-            <a:off x="6537960" y="1645920"/>
-            <a:ext cx="457200" cy="457200"/>
-          </a:xfrm>
-          <a:prstGeom prst="ellipse">
-            <a:avLst/>
-          </a:prstGeom>
-          <a:solidFill>
-            <a:srgbClr val="02C39A"/>
-          </a:solidFill>
-          <a:ln/>
-        </p:spPr>
         <p:txBody>
           <a:bodyPr wrap="square" lIns="0" tIns="0" rIns="0" bIns="0" rtlCol="0" anchor="ctr"/>
           <a:lstStyle/>
@@ -3925,96 +5011,51 @@
               <a:buNone/>
             </a:pPr>
             <a:r>
-              <a:rPr lang="en-US" sz="1700" b="1" dirty="0">
-                <a:solidFill>
-                  <a:srgbClr val="FFFFFF"/>
+              <a:rPr lang="en-US" sz="2000" b="1" dirty="0">
+                <a:solidFill>
+                  <a:srgbClr val="0A8F72"/>
                 </a:solidFill>
                 <a:latin typeface="Arial" pitchFamily="34" charset="0"/>
                 <a:ea typeface="Arial" pitchFamily="34" charset="-122"/>
                 <a:cs typeface="Arial" pitchFamily="34" charset="-120"/>
               </a:rPr>
-              <a:t>2</a:t>
-            </a:r>
-            <a:endParaRPr lang="en-US" sz="1700" dirty="0"/>
-          </a:p>
-        </p:txBody>
-      </p:sp>
-      <p:sp>
-        <p:nvSpPr>
-          <p:cNvPr id="8" name="Text 6"/>
-          <p:cNvSpPr/>
-          <p:nvPr/>
-        </p:nvSpPr>
-        <p:spPr>
-          <a:xfrm>
-            <a:off x="7178040" y="1581912"/>
-            <a:ext cx="4480560" cy="1828800"/>
-          </a:xfrm>
-          <a:prstGeom prst="rect">
-            <a:avLst/>
-          </a:prstGeom>
-          <a:noFill/>
-          <a:ln/>
-        </p:spPr>
-        <p:txBody>
-          <a:bodyPr wrap="square" lIns="0" tIns="0" rIns="0" bIns="0" rtlCol="0" anchor="t"/>
-          <a:lstStyle/>
-          <a:p>
-            <a:pPr indent="0" marL="0">
-              <a:spcAft>
-                <a:spcPts val="600"/>
-              </a:spcAft>
-              <a:buNone/>
-            </a:pPr>
-            <a:r>
-              <a:rPr lang="en-US" sz="1650" b="1" dirty="0">
-                <a:solidFill>
-                  <a:srgbClr val="1E2761"/>
-                </a:solidFill>
-                <a:latin typeface="Calibri" pitchFamily="34" charset="0"/>
-                <a:ea typeface="Calibri" pitchFamily="34" charset="-122"/>
-                <a:cs typeface="Calibri" pitchFamily="34" charset="-120"/>
-              </a:rPr>
-              <a:t>Train on the scoreboard</a:t>
-            </a:r>
-            <a:endParaRPr lang="en-US" sz="1650" dirty="0"/>
-          </a:p>
-          <a:p>
-            <a:pPr indent="0" marL="0">
-              <a:spcAft>
-                <a:spcPts val="600"/>
-              </a:spcAft>
-              <a:buNone/>
-            </a:pPr>
-            <a:r>
-              <a:rPr lang="en-US" sz="1250" dirty="0">
-                <a:solidFill>
-                  <a:srgbClr val="333333"/>
-                </a:solidFill>
-                <a:latin typeface="Calibri" pitchFamily="34" charset="0"/>
-                <a:ea typeface="Calibri" pitchFamily="34" charset="-122"/>
-                <a:cs typeface="Calibri" pitchFamily="34" charset="-120"/>
-              </a:rPr>
-              <a:t>Loss = Charbonnier + SSIM + light LPIPS. Two of the three judged metrics are optimized directly during training — not hoped for afterwards.</a:t>
-            </a:r>
-            <a:endParaRPr lang="en-US" sz="1650" dirty="0"/>
-          </a:p>
-        </p:txBody>
-      </p:sp>
-      <p:sp>
-        <p:nvSpPr>
-          <p:cNvPr id="9" name="Shape 7"/>
-          <p:cNvSpPr/>
-          <p:nvPr/>
-        </p:nvSpPr>
-        <p:spPr>
-          <a:xfrm>
-            <a:off x="548640" y="3749040"/>
-            <a:ext cx="5486400" cy="2103120"/>
+              <a:t>27.15 dB</a:t>
+            </a:r>
+            <a:endParaRPr lang="en-US" sz="2000" dirty="0"/>
+          </a:p>
+          <a:p>
+            <a:pPr algn="ctr" indent="0" marL="0">
+              <a:buNone/>
+            </a:pPr>
+            <a:r>
+              <a:rPr lang="en-US" sz="1100" dirty="0">
+                <a:solidFill>
+                  <a:srgbClr val="5A6478"/>
+                </a:solidFill>
+                <a:latin typeface="Arial" pitchFamily="34" charset="0"/>
+                <a:ea typeface="Arial" pitchFamily="34" charset="-122"/>
+                <a:cs typeface="Arial" pitchFamily="34" charset="-120"/>
+              </a:rPr>
+              <a:t>epoch 30</a:t>
+            </a:r>
+            <a:endParaRPr lang="en-US" sz="2000" dirty="0"/>
+          </a:p>
+        </p:txBody>
+      </p:sp>
+      <p:sp>
+        <p:nvSpPr>
+          <p:cNvPr id="10" name="Text 8"/>
+          <p:cNvSpPr/>
+          <p:nvPr/>
+        </p:nvSpPr>
+        <p:spPr>
+          <a:xfrm>
+            <a:off x="6126480" y="4343400"/>
+            <a:ext cx="2606040" cy="914400"/>
           </a:xfrm>
           <a:prstGeom prst="roundRect">
             <a:avLst>
-              <a:gd name="adj" fmla="val 4348"/>
+              <a:gd name="adj" fmla="val 8000"/>
             </a:avLst>
           </a:prstGeom>
           <a:solidFill>
@@ -4022,26 +5063,6 @@
           </a:solidFill>
           <a:ln/>
         </p:spPr>
-      </p:sp>
-      <p:sp>
-        <p:nvSpPr>
-          <p:cNvPr id="10" name="Text 8"/>
-          <p:cNvSpPr/>
-          <p:nvPr/>
-        </p:nvSpPr>
-        <p:spPr>
-          <a:xfrm>
-            <a:off x="777240" y="3977640"/>
-            <a:ext cx="457200" cy="457200"/>
-          </a:xfrm>
-          <a:prstGeom prst="ellipse">
-            <a:avLst/>
-          </a:prstGeom>
-          <a:solidFill>
-            <a:srgbClr val="02C39A"/>
-          </a:solidFill>
-          <a:ln/>
-        </p:spPr>
         <p:txBody>
           <a:bodyPr wrap="square" lIns="0" tIns="0" rIns="0" bIns="0" rtlCol="0" anchor="ctr"/>
           <a:lstStyle/>
@@ -4050,17 +5071,34 @@
               <a:buNone/>
             </a:pPr>
             <a:r>
-              <a:rPr lang="en-US" sz="1700" b="1" dirty="0">
-                <a:solidFill>
-                  <a:srgbClr val="FFFFFF"/>
+              <a:rPr lang="en-US" sz="2000" b="1" dirty="0">
+                <a:solidFill>
+                  <a:srgbClr val="0A8F72"/>
                 </a:solidFill>
                 <a:latin typeface="Arial" pitchFamily="34" charset="0"/>
                 <a:ea typeface="Arial" pitchFamily="34" charset="-122"/>
                 <a:cs typeface="Arial" pitchFamily="34" charset="-120"/>
               </a:rPr>
-              <a:t>3</a:t>
-            </a:r>
-            <a:endParaRPr lang="en-US" sz="1700" dirty="0"/>
+              <a:t>27.27 dB</a:t>
+            </a:r>
+            <a:endParaRPr lang="en-US" sz="2000" dirty="0"/>
+          </a:p>
+          <a:p>
+            <a:pPr algn="ctr" indent="0" marL="0">
+              <a:buNone/>
+            </a:pPr>
+            <a:r>
+              <a:rPr lang="en-US" sz="1100" dirty="0">
+                <a:solidFill>
+                  <a:srgbClr val="5A6478"/>
+                </a:solidFill>
+                <a:latin typeface="Arial" pitchFamily="34" charset="0"/>
+                <a:ea typeface="Arial" pitchFamily="34" charset="-122"/>
+                <a:cs typeface="Arial" pitchFamily="34" charset="-120"/>
+              </a:rPr>
+              <a:t>epoch 60</a:t>
+            </a:r>
+            <a:endParaRPr lang="en-US" sz="2000" dirty="0"/>
           </a:p>
         </p:txBody>
       </p:sp>
@@ -4072,74 +5110,12 @@
         </p:nvSpPr>
         <p:spPr>
           <a:xfrm>
-            <a:off x="1417320" y="3913632"/>
-            <a:ext cx="4480560" cy="1828800"/>
-          </a:xfrm>
-          <a:prstGeom prst="rect">
-            <a:avLst/>
-          </a:prstGeom>
-          <a:noFill/>
-          <a:ln/>
-        </p:spPr>
-        <p:txBody>
-          <a:bodyPr wrap="square" lIns="0" tIns="0" rIns="0" bIns="0" rtlCol="0" anchor="t"/>
-          <a:lstStyle/>
-          <a:p>
-            <a:pPr indent="0" marL="0">
-              <a:spcAft>
-                <a:spcPts val="600"/>
-              </a:spcAft>
-              <a:buNone/>
-            </a:pPr>
-            <a:r>
-              <a:rPr lang="en-US" sz="1650" b="1" dirty="0">
-                <a:solidFill>
-                  <a:srgbClr val="1E2761"/>
-                </a:solidFill>
-                <a:latin typeface="Calibri" pitchFamily="34" charset="0"/>
-                <a:ea typeface="Calibri" pitchFamily="34" charset="-122"/>
-                <a:cs typeface="Calibri" pitchFamily="34" charset="-120"/>
-              </a:rPr>
-              <a:t>No-hallucination guarantee</a:t>
-            </a:r>
-            <a:endParaRPr lang="en-US" sz="1650" dirty="0"/>
-          </a:p>
-          <a:p>
-            <a:pPr indent="0" marL="0">
-              <a:spcAft>
-                <a:spcPts val="600"/>
-              </a:spcAft>
-              <a:buNone/>
-            </a:pPr>
-            <a:r>
-              <a:rPr lang="en-US" sz="1250" dirty="0">
-                <a:solidFill>
-                  <a:srgbClr val="333333"/>
-                </a:solidFill>
-                <a:latin typeface="Calibri" pitchFamily="34" charset="0"/>
-                <a:ea typeface="Calibri" pitchFamily="34" charset="-122"/>
-                <a:cs typeface="Calibri" pitchFamily="34" charset="-120"/>
-              </a:rPr>
-              <a:t>Global bicubic skip + deliberately no GAN loss. The model can only correct towards the input's real structure — invented defects are structurally impossible.</a:t>
-            </a:r>
-            <a:endParaRPr lang="en-US" sz="1650" dirty="0"/>
-          </a:p>
-        </p:txBody>
-      </p:sp>
-      <p:sp>
-        <p:nvSpPr>
-          <p:cNvPr id="12" name="Shape 10"/>
-          <p:cNvSpPr/>
-          <p:nvPr/>
-        </p:nvSpPr>
-        <p:spPr>
-          <a:xfrm>
-            <a:off x="6309360" y="3749040"/>
-            <a:ext cx="5486400" cy="2103120"/>
+            <a:off x="8915400" y="4343400"/>
+            <a:ext cx="2606040" cy="914400"/>
           </a:xfrm>
           <a:prstGeom prst="roundRect">
             <a:avLst>
-              <a:gd name="adj" fmla="val 4348"/>
+              <a:gd name="adj" fmla="val 8000"/>
             </a:avLst>
           </a:prstGeom>
           <a:solidFill>
@@ -4147,26 +5123,6 @@
           </a:solidFill>
           <a:ln/>
         </p:spPr>
-      </p:sp>
-      <p:sp>
-        <p:nvSpPr>
-          <p:cNvPr id="13" name="Text 11"/>
-          <p:cNvSpPr/>
-          <p:nvPr/>
-        </p:nvSpPr>
-        <p:spPr>
-          <a:xfrm>
-            <a:off x="6537960" y="3977640"/>
-            <a:ext cx="457200" cy="457200"/>
-          </a:xfrm>
-          <a:prstGeom prst="ellipse">
-            <a:avLst/>
-          </a:prstGeom>
-          <a:solidFill>
-            <a:srgbClr val="02C39A"/>
-          </a:solidFill>
-          <a:ln/>
-        </p:spPr>
         <p:txBody>
           <a:bodyPr wrap="square" lIns="0" tIns="0" rIns="0" bIns="0" rtlCol="0" anchor="ctr"/>
           <a:lstStyle/>
@@ -4175,79 +5131,77 @@
               <a:buNone/>
             </a:pPr>
             <a:r>
-              <a:rPr lang="en-US" sz="1700" b="1" dirty="0">
-                <a:solidFill>
-                  <a:srgbClr val="FFFFFF"/>
+              <a:rPr lang="en-US" sz="2000" b="1" dirty="0">
+                <a:solidFill>
+                  <a:srgbClr val="0A8F72"/>
                 </a:solidFill>
                 <a:latin typeface="Arial" pitchFamily="34" charset="0"/>
                 <a:ea typeface="Arial" pitchFamily="34" charset="-122"/>
                 <a:cs typeface="Arial" pitchFamily="34" charset="-120"/>
               </a:rPr>
-              <a:t>4</a:t>
-            </a:r>
-            <a:endParaRPr lang="en-US" sz="1700" dirty="0"/>
-          </a:p>
-        </p:txBody>
-      </p:sp>
-      <p:sp>
-        <p:nvSpPr>
-          <p:cNvPr id="14" name="Text 12"/>
-          <p:cNvSpPr/>
-          <p:nvPr/>
-        </p:nvSpPr>
-        <p:spPr>
-          <a:xfrm>
-            <a:off x="7178040" y="3913632"/>
-            <a:ext cx="4480560" cy="1828800"/>
-          </a:xfrm>
-          <a:prstGeom prst="rect">
-            <a:avLst/>
-          </a:prstGeom>
-          <a:noFill/>
-          <a:ln/>
-        </p:spPr>
-        <p:txBody>
-          <a:bodyPr wrap="square" lIns="0" tIns="0" rIns="0" bIns="0" rtlCol="0" anchor="t"/>
-          <a:lstStyle/>
-          <a:p>
-            <a:pPr indent="0" marL="0">
-              <a:spcAft>
-                <a:spcPts val="600"/>
-              </a:spcAft>
-              <a:buNone/>
-            </a:pPr>
-            <a:r>
-              <a:rPr lang="en-US" sz="1650" b="1" dirty="0">
-                <a:solidFill>
-                  <a:srgbClr val="1E2761"/>
-                </a:solidFill>
-                <a:latin typeface="Calibri" pitchFamily="34" charset="0"/>
-                <a:ea typeface="Calibri" pitchFamily="34" charset="-122"/>
-                <a:cs typeface="Calibri" pitchFamily="34" charset="-120"/>
-              </a:rPr>
-              <a:t>Float-faithful pipeline</a:t>
-            </a:r>
-            <a:endParaRPr lang="en-US" sz="1650" dirty="0"/>
-          </a:p>
-          <a:p>
-            <a:pPr indent="0" marL="0">
-              <a:spcAft>
-                <a:spcPts val="600"/>
-              </a:spcAft>
-              <a:buNone/>
-            </a:pPr>
-            <a:r>
-              <a:rPr lang="en-US" sz="1250" dirty="0">
-                <a:solidFill>
-                  <a:srgbClr val="333333"/>
-                </a:solidFill>
-                <a:latin typeface="Calibri" pitchFamily="34" charset="0"/>
-                <a:ea typeface="Calibri" pitchFamily="34" charset="-122"/>
-                <a:cs typeface="Calibri" pitchFamily="34" charset="-120"/>
-              </a:rPr>
-              <a:t>Degraded inputs carry values outside [0,1] — real noise signal. Native float32 .npy I/O end to end; a PNG-based pipeline would silently clip and lose it.</a:t>
-            </a:r>
-            <a:endParaRPr lang="en-US" sz="1650" dirty="0"/>
+              <a:t>27.33 dB</a:t>
+            </a:r>
+            <a:endParaRPr lang="en-US" sz="2000" dirty="0"/>
+          </a:p>
+          <a:p>
+            <a:pPr algn="ctr" indent="0" marL="0">
+              <a:buNone/>
+            </a:pPr>
+            <a:r>
+              <a:rPr lang="en-US" sz="1100" dirty="0">
+                <a:solidFill>
+                  <a:srgbClr val="5A6478"/>
+                </a:solidFill>
+                <a:latin typeface="Arial" pitchFamily="34" charset="0"/>
+                <a:ea typeface="Arial" pitchFamily="34" charset="-122"/>
+                <a:cs typeface="Arial" pitchFamily="34" charset="-120"/>
+              </a:rPr>
+              <a:t>epoch 85</a:t>
+            </a:r>
+            <a:endParaRPr lang="en-US" sz="2000" dirty="0"/>
+          </a:p>
+        </p:txBody>
+      </p:sp>
+      <p:sp>
+        <p:nvSpPr>
+          <p:cNvPr id="12" name="Text 10"/>
+          <p:cNvSpPr/>
+          <p:nvPr/>
+        </p:nvSpPr>
+        <p:spPr>
+          <a:xfrm>
+            <a:off x="548640" y="5486400"/>
+            <a:ext cx="11018520" cy="594360"/>
+          </a:xfrm>
+          <a:prstGeom prst="roundRect">
+            <a:avLst>
+              <a:gd name="adj" fmla="val 15385"/>
+            </a:avLst>
+          </a:prstGeom>
+          <a:solidFill>
+            <a:srgbClr val="1E2761"/>
+          </a:solidFill>
+          <a:ln/>
+        </p:spPr>
+        <p:txBody>
+          <a:bodyPr wrap="square" rtlCol="0" anchor="ctr"/>
+          <a:lstStyle/>
+          <a:p>
+            <a:pPr algn="ctr" indent="0" marL="0">
+              <a:buNone/>
+            </a:pPr>
+            <a:r>
+              <a:rPr lang="en-US" sz="1400" b="1" dirty="0">
+                <a:solidFill>
+                  <a:srgbClr val="FFFFFF"/>
+                </a:solidFill>
+                <a:latin typeface="Calibri" pitchFamily="34" charset="0"/>
+                <a:ea typeface="Calibri" pitchFamily="34" charset="-122"/>
+                <a:cs typeface="Calibri" pitchFamily="34" charset="-120"/>
+              </a:rPr>
+              <a:t>Trained free on a Google Colab T4 · 74 s/epoch · ≈ 2 hours total · resumable checkpoints</a:t>
+            </a:r>
+            <a:endParaRPr lang="en-US" sz="1400" dirty="0"/>
           </a:p>
         </p:txBody>
       </p:sp>
@@ -4309,7 +5263,7 @@
                 <a:ea typeface="Arial" pitchFamily="34" charset="-122"/>
                 <a:cs typeface="Arial" pitchFamily="34" charset="-120"/>
               </a:rPr>
-              <a:t>Results — better on every judged metric</a:t>
+              <a:t>Innovation</a:t>
             </a:r>
             <a:endParaRPr lang="en-US" sz="3200" dirty="0"/>
           </a:p>
@@ -4317,70 +5271,202 @@
       </p:sp>
       <p:sp>
         <p:nvSpPr>
-          <p:cNvPr id="3" name="Text 1"/>
-          <p:cNvSpPr/>
-          <p:nvPr/>
-        </p:nvSpPr>
-        <p:spPr>
-          <a:xfrm>
-            <a:off x="548640" y="1188720"/>
-            <a:ext cx="2697480" cy="1325880"/>
-          </a:xfrm>
-          <a:prstGeom prst="rect">
+          <p:cNvPr id="3" name="Shape 1"/>
+          <p:cNvSpPr/>
+          <p:nvPr/>
+        </p:nvSpPr>
+        <p:spPr>
+          <a:xfrm>
+            <a:off x="548640" y="1417320"/>
+            <a:ext cx="5486400" cy="2103120"/>
+          </a:xfrm>
+          <a:prstGeom prst="roundRect">
+            <a:avLst>
+              <a:gd name="adj" fmla="val 4348"/>
+            </a:avLst>
+          </a:prstGeom>
+          <a:solidFill>
+            <a:srgbClr val="F4F7FD"/>
+          </a:solidFill>
+          <a:ln/>
+        </p:spPr>
+      </p:sp>
+      <p:sp>
+        <p:nvSpPr>
+          <p:cNvPr id="4" name="Text 2"/>
+          <p:cNvSpPr/>
+          <p:nvPr/>
+        </p:nvSpPr>
+        <p:spPr>
+          <a:xfrm>
+            <a:off x="777240" y="1645920"/>
+            <a:ext cx="457200" cy="457200"/>
+          </a:xfrm>
+          <a:prstGeom prst="ellipse">
             <a:avLst/>
           </a:prstGeom>
-          <a:noFill/>
+          <a:solidFill>
+            <a:srgbClr val="02C39A"/>
+          </a:solidFill>
           <a:ln/>
         </p:spPr>
         <p:txBody>
           <a:bodyPr wrap="square" lIns="0" tIns="0" rIns="0" bIns="0" rtlCol="0" anchor="ctr"/>
           <a:lstStyle/>
           <a:p>
-            <a:pPr algn="l" indent="0" marL="0">
-              <a:buNone/>
-            </a:pPr>
-            <a:r>
-              <a:rPr lang="en-US" sz="3800" b="1" dirty="0">
-                <a:solidFill>
-                  <a:srgbClr val="0A8F72"/>
+            <a:pPr algn="ctr" indent="0" marL="0">
+              <a:buNone/>
+            </a:pPr>
+            <a:r>
+              <a:rPr lang="en-US" sz="1700" b="1" dirty="0">
+                <a:solidFill>
+                  <a:srgbClr val="FFFFFF"/>
                 </a:solidFill>
                 <a:latin typeface="Arial" pitchFamily="34" charset="0"/>
                 <a:ea typeface="Arial" pitchFamily="34" charset="-122"/>
                 <a:cs typeface="Arial" pitchFamily="34" charset="-120"/>
               </a:rPr>
-              <a:t>+5.0 dB</a:t>
-            </a:r>
-            <a:endParaRPr lang="en-US" sz="3800" dirty="0"/>
-          </a:p>
-          <a:p>
-            <a:pPr algn="l" indent="0" marL="0">
-              <a:buNone/>
-            </a:pPr>
-            <a:r>
-              <a:rPr lang="en-US" sz="1150" dirty="0">
-                <a:solidFill>
-                  <a:srgbClr val="5A6478"/>
+              <a:t>1</a:t>
+            </a:r>
+            <a:endParaRPr lang="en-US" sz="1700" dirty="0"/>
+          </a:p>
+        </p:txBody>
+      </p:sp>
+      <p:sp>
+        <p:nvSpPr>
+          <p:cNvPr id="5" name="Text 3"/>
+          <p:cNvSpPr/>
+          <p:nvPr/>
+        </p:nvSpPr>
+        <p:spPr>
+          <a:xfrm>
+            <a:off x="1417320" y="1581912"/>
+            <a:ext cx="4480560" cy="1828800"/>
+          </a:xfrm>
+          <a:prstGeom prst="rect">
+            <a:avLst/>
+          </a:prstGeom>
+          <a:noFill/>
+          <a:ln/>
+        </p:spPr>
+        <p:txBody>
+          <a:bodyPr wrap="square" lIns="0" tIns="0" rIns="0" bIns="0" rtlCol="0" anchor="t"/>
+          <a:lstStyle/>
+          <a:p>
+            <a:pPr indent="0" marL="0">
+              <a:spcAft>
+                <a:spcPts val="600"/>
+              </a:spcAft>
+              <a:buNone/>
+            </a:pPr>
+            <a:r>
+              <a:rPr lang="en-US" sz="1650" b="1" dirty="0">
+                <a:solidFill>
+                  <a:srgbClr val="1E2761"/>
+                </a:solidFill>
+                <a:latin typeface="Calibri" pitchFamily="34" charset="0"/>
+                <a:ea typeface="Calibri" pitchFamily="34" charset="-122"/>
+                <a:cs typeface="Calibri" pitchFamily="34" charset="-120"/>
+              </a:rPr>
+              <a:t>Simplicity as strategy</a:t>
+            </a:r>
+            <a:endParaRPr lang="en-US" sz="1650" dirty="0"/>
+          </a:p>
+          <a:p>
+            <a:pPr indent="0" marL="0">
+              <a:spcAft>
+                <a:spcPts val="600"/>
+              </a:spcAft>
+              <a:buNone/>
+            </a:pPr>
+            <a:r>
+              <a:rPr lang="en-US" sz="1250" dirty="0">
+                <a:solidFill>
+                  <a:srgbClr val="333333"/>
+                </a:solidFill>
+                <a:latin typeface="Calibri" pitchFamily="34" charset="0"/>
+                <a:ea typeface="Calibri" pitchFamily="34" charset="-122"/>
+                <a:cs typeface="Calibri" pitchFamily="34" charset="-120"/>
+              </a:rPr>
+              <a:t>State-of-the-art restoration family at 0.53 M parameters. Small enough to train free, run on CPU, and for the team to explain and debug every single line.</a:t>
+            </a:r>
+            <a:endParaRPr lang="en-US" sz="1650" dirty="0"/>
+          </a:p>
+        </p:txBody>
+      </p:sp>
+      <p:sp>
+        <p:nvSpPr>
+          <p:cNvPr id="6" name="Shape 4"/>
+          <p:cNvSpPr/>
+          <p:nvPr/>
+        </p:nvSpPr>
+        <p:spPr>
+          <a:xfrm>
+            <a:off x="6309360" y="1417320"/>
+            <a:ext cx="5486400" cy="2103120"/>
+          </a:xfrm>
+          <a:prstGeom prst="roundRect">
+            <a:avLst>
+              <a:gd name="adj" fmla="val 4348"/>
+            </a:avLst>
+          </a:prstGeom>
+          <a:solidFill>
+            <a:srgbClr val="F4F7FD"/>
+          </a:solidFill>
+          <a:ln/>
+        </p:spPr>
+      </p:sp>
+      <p:sp>
+        <p:nvSpPr>
+          <p:cNvPr id="7" name="Text 5"/>
+          <p:cNvSpPr/>
+          <p:nvPr/>
+        </p:nvSpPr>
+        <p:spPr>
+          <a:xfrm>
+            <a:off x="6537960" y="1645920"/>
+            <a:ext cx="457200" cy="457200"/>
+          </a:xfrm>
+          <a:prstGeom prst="ellipse">
+            <a:avLst/>
+          </a:prstGeom>
+          <a:solidFill>
+            <a:srgbClr val="02C39A"/>
+          </a:solidFill>
+          <a:ln/>
+        </p:spPr>
+        <p:txBody>
+          <a:bodyPr wrap="square" lIns="0" tIns="0" rIns="0" bIns="0" rtlCol="0" anchor="ctr"/>
+          <a:lstStyle/>
+          <a:p>
+            <a:pPr algn="ctr" indent="0" marL="0">
+              <a:buNone/>
+            </a:pPr>
+            <a:r>
+              <a:rPr lang="en-US" sz="1700" b="1" dirty="0">
+                <a:solidFill>
+                  <a:srgbClr val="FFFFFF"/>
                 </a:solidFill>
                 <a:latin typeface="Arial" pitchFamily="34" charset="0"/>
                 <a:ea typeface="Arial" pitchFamily="34" charset="-122"/>
                 <a:cs typeface="Arial" pitchFamily="34" charset="-120"/>
               </a:rPr>
-              <a:t>PSNR gain vs baseline</a:t>
-            </a:r>
-            <a:endParaRPr lang="en-US" sz="3800" dirty="0"/>
-          </a:p>
-        </p:txBody>
-      </p:sp>
-      <p:sp>
-        <p:nvSpPr>
-          <p:cNvPr id="4" name="Text 2"/>
-          <p:cNvSpPr/>
-          <p:nvPr/>
-        </p:nvSpPr>
-        <p:spPr>
-          <a:xfrm>
-            <a:off x="3383280" y="1188720"/>
-            <a:ext cx="2697480" cy="1325880"/>
+              <a:t>2</a:t>
+            </a:r>
+            <a:endParaRPr lang="en-US" sz="1700" dirty="0"/>
+          </a:p>
+        </p:txBody>
+      </p:sp>
+      <p:sp>
+        <p:nvSpPr>
+          <p:cNvPr id="8" name="Text 6"/>
+          <p:cNvSpPr/>
+          <p:nvPr/>
+        </p:nvSpPr>
+        <p:spPr>
+          <a:xfrm>
+            <a:off x="7178040" y="1581912"/>
+            <a:ext cx="4480560" cy="1828800"/>
           </a:xfrm>
           <a:prstGeom prst="rect">
             <a:avLst/>
@@ -4389,54 +5475,248 @@
           <a:ln/>
         </p:spPr>
         <p:txBody>
+          <a:bodyPr wrap="square" lIns="0" tIns="0" rIns="0" bIns="0" rtlCol="0" anchor="t"/>
+          <a:lstStyle/>
+          <a:p>
+            <a:pPr indent="0" marL="0">
+              <a:spcAft>
+                <a:spcPts val="600"/>
+              </a:spcAft>
+              <a:buNone/>
+            </a:pPr>
+            <a:r>
+              <a:rPr lang="en-US" sz="1650" b="1" dirty="0">
+                <a:solidFill>
+                  <a:srgbClr val="1E2761"/>
+                </a:solidFill>
+                <a:latin typeface="Calibri" pitchFamily="34" charset="0"/>
+                <a:ea typeface="Calibri" pitchFamily="34" charset="-122"/>
+                <a:cs typeface="Calibri" pitchFamily="34" charset="-120"/>
+              </a:rPr>
+              <a:t>Train on the scoreboard</a:t>
+            </a:r>
+            <a:endParaRPr lang="en-US" sz="1650" dirty="0"/>
+          </a:p>
+          <a:p>
+            <a:pPr indent="0" marL="0">
+              <a:spcAft>
+                <a:spcPts val="600"/>
+              </a:spcAft>
+              <a:buNone/>
+            </a:pPr>
+            <a:r>
+              <a:rPr lang="en-US" sz="1250" dirty="0">
+                <a:solidFill>
+                  <a:srgbClr val="333333"/>
+                </a:solidFill>
+                <a:latin typeface="Calibri" pitchFamily="34" charset="0"/>
+                <a:ea typeface="Calibri" pitchFamily="34" charset="-122"/>
+                <a:cs typeface="Calibri" pitchFamily="34" charset="-120"/>
+              </a:rPr>
+              <a:t>Loss = Charbonnier + SSIM + light LPIPS. Two of the three judged metrics are optimized directly during training — not hoped for afterwards.</a:t>
+            </a:r>
+            <a:endParaRPr lang="en-US" sz="1650" dirty="0"/>
+          </a:p>
+        </p:txBody>
+      </p:sp>
+      <p:sp>
+        <p:nvSpPr>
+          <p:cNvPr id="9" name="Shape 7"/>
+          <p:cNvSpPr/>
+          <p:nvPr/>
+        </p:nvSpPr>
+        <p:spPr>
+          <a:xfrm>
+            <a:off x="548640" y="3749040"/>
+            <a:ext cx="5486400" cy="2103120"/>
+          </a:xfrm>
+          <a:prstGeom prst="roundRect">
+            <a:avLst>
+              <a:gd name="adj" fmla="val 4348"/>
+            </a:avLst>
+          </a:prstGeom>
+          <a:solidFill>
+            <a:srgbClr val="F4F7FD"/>
+          </a:solidFill>
+          <a:ln/>
+        </p:spPr>
+      </p:sp>
+      <p:sp>
+        <p:nvSpPr>
+          <p:cNvPr id="10" name="Text 8"/>
+          <p:cNvSpPr/>
+          <p:nvPr/>
+        </p:nvSpPr>
+        <p:spPr>
+          <a:xfrm>
+            <a:off x="777240" y="3977640"/>
+            <a:ext cx="457200" cy="457200"/>
+          </a:xfrm>
+          <a:prstGeom prst="ellipse">
+            <a:avLst/>
+          </a:prstGeom>
+          <a:solidFill>
+            <a:srgbClr val="02C39A"/>
+          </a:solidFill>
+          <a:ln/>
+        </p:spPr>
+        <p:txBody>
           <a:bodyPr wrap="square" lIns="0" tIns="0" rIns="0" bIns="0" rtlCol="0" anchor="ctr"/>
           <a:lstStyle/>
           <a:p>
-            <a:pPr algn="l" indent="0" marL="0">
-              <a:buNone/>
-            </a:pPr>
-            <a:r>
-              <a:rPr lang="en-US" sz="3800" b="1" dirty="0">
-                <a:solidFill>
-                  <a:srgbClr val="0A8F72"/>
+            <a:pPr algn="ctr" indent="0" marL="0">
+              <a:buNone/>
+            </a:pPr>
+            <a:r>
+              <a:rPr lang="en-US" sz="1700" b="1" dirty="0">
+                <a:solidFill>
+                  <a:srgbClr val="FFFFFF"/>
                 </a:solidFill>
                 <a:latin typeface="Arial" pitchFamily="34" charset="0"/>
                 <a:ea typeface="Arial" pitchFamily="34" charset="-122"/>
                 <a:cs typeface="Arial" pitchFamily="34" charset="-120"/>
               </a:rPr>
-              <a:t>+0.22</a:t>
-            </a:r>
-            <a:endParaRPr lang="en-US" sz="3800" dirty="0"/>
-          </a:p>
-          <a:p>
-            <a:pPr algn="l" indent="0" marL="0">
-              <a:buNone/>
-            </a:pPr>
-            <a:r>
-              <a:rPr lang="en-US" sz="1150" dirty="0">
-                <a:solidFill>
-                  <a:srgbClr val="5A6478"/>
+              <a:t>3</a:t>
+            </a:r>
+            <a:endParaRPr lang="en-US" sz="1700" dirty="0"/>
+          </a:p>
+        </p:txBody>
+      </p:sp>
+      <p:sp>
+        <p:nvSpPr>
+          <p:cNvPr id="11" name="Text 9"/>
+          <p:cNvSpPr/>
+          <p:nvPr/>
+        </p:nvSpPr>
+        <p:spPr>
+          <a:xfrm>
+            <a:off x="1417320" y="3913632"/>
+            <a:ext cx="4480560" cy="1828800"/>
+          </a:xfrm>
+          <a:prstGeom prst="rect">
+            <a:avLst/>
+          </a:prstGeom>
+          <a:noFill/>
+          <a:ln/>
+        </p:spPr>
+        <p:txBody>
+          <a:bodyPr wrap="square" lIns="0" tIns="0" rIns="0" bIns="0" rtlCol="0" anchor="t"/>
+          <a:lstStyle/>
+          <a:p>
+            <a:pPr indent="0" marL="0">
+              <a:spcAft>
+                <a:spcPts val="600"/>
+              </a:spcAft>
+              <a:buNone/>
+            </a:pPr>
+            <a:r>
+              <a:rPr lang="en-US" sz="1650" b="1" dirty="0">
+                <a:solidFill>
+                  <a:srgbClr val="1E2761"/>
+                </a:solidFill>
+                <a:latin typeface="Calibri" pitchFamily="34" charset="0"/>
+                <a:ea typeface="Calibri" pitchFamily="34" charset="-122"/>
+                <a:cs typeface="Calibri" pitchFamily="34" charset="-120"/>
+              </a:rPr>
+              <a:t>No-hallucination guarantee</a:t>
+            </a:r>
+            <a:endParaRPr lang="en-US" sz="1650" dirty="0"/>
+          </a:p>
+          <a:p>
+            <a:pPr indent="0" marL="0">
+              <a:spcAft>
+                <a:spcPts val="600"/>
+              </a:spcAft>
+              <a:buNone/>
+            </a:pPr>
+            <a:r>
+              <a:rPr lang="en-US" sz="1250" dirty="0">
+                <a:solidFill>
+                  <a:srgbClr val="333333"/>
+                </a:solidFill>
+                <a:latin typeface="Calibri" pitchFamily="34" charset="0"/>
+                <a:ea typeface="Calibri" pitchFamily="34" charset="-122"/>
+                <a:cs typeface="Calibri" pitchFamily="34" charset="-120"/>
+              </a:rPr>
+              <a:t>Global bicubic skip + deliberately no GAN loss. The model can only correct towards the input's real structure — invented defects are structurally impossible.</a:t>
+            </a:r>
+            <a:endParaRPr lang="en-US" sz="1650" dirty="0"/>
+          </a:p>
+        </p:txBody>
+      </p:sp>
+      <p:sp>
+        <p:nvSpPr>
+          <p:cNvPr id="12" name="Shape 10"/>
+          <p:cNvSpPr/>
+          <p:nvPr/>
+        </p:nvSpPr>
+        <p:spPr>
+          <a:xfrm>
+            <a:off x="6309360" y="3749040"/>
+            <a:ext cx="5486400" cy="2103120"/>
+          </a:xfrm>
+          <a:prstGeom prst="roundRect">
+            <a:avLst>
+              <a:gd name="adj" fmla="val 4348"/>
+            </a:avLst>
+          </a:prstGeom>
+          <a:solidFill>
+            <a:srgbClr val="F4F7FD"/>
+          </a:solidFill>
+          <a:ln/>
+        </p:spPr>
+      </p:sp>
+      <p:sp>
+        <p:nvSpPr>
+          <p:cNvPr id="13" name="Text 11"/>
+          <p:cNvSpPr/>
+          <p:nvPr/>
+        </p:nvSpPr>
+        <p:spPr>
+          <a:xfrm>
+            <a:off x="6537960" y="3977640"/>
+            <a:ext cx="457200" cy="457200"/>
+          </a:xfrm>
+          <a:prstGeom prst="ellipse">
+            <a:avLst/>
+          </a:prstGeom>
+          <a:solidFill>
+            <a:srgbClr val="02C39A"/>
+          </a:solidFill>
+          <a:ln/>
+        </p:spPr>
+        <p:txBody>
+          <a:bodyPr wrap="square" lIns="0" tIns="0" rIns="0" bIns="0" rtlCol="0" anchor="ctr"/>
+          <a:lstStyle/>
+          <a:p>
+            <a:pPr algn="ctr" indent="0" marL="0">
+              <a:buNone/>
+            </a:pPr>
+            <a:r>
+              <a:rPr lang="en-US" sz="1700" b="1" dirty="0">
+                <a:solidFill>
+                  <a:srgbClr val="FFFFFF"/>
                 </a:solidFill>
                 <a:latin typeface="Arial" pitchFamily="34" charset="0"/>
                 <a:ea typeface="Arial" pitchFamily="34" charset="-122"/>
                 <a:cs typeface="Arial" pitchFamily="34" charset="-120"/>
               </a:rPr>
-              <a:t>SSIM (0.54 → 0.76)</a:t>
-            </a:r>
-            <a:endParaRPr lang="en-US" sz="3800" dirty="0"/>
-          </a:p>
-        </p:txBody>
-      </p:sp>
-      <p:sp>
-        <p:nvSpPr>
-          <p:cNvPr id="5" name="Text 3"/>
-          <p:cNvSpPr/>
-          <p:nvPr/>
-        </p:nvSpPr>
-        <p:spPr>
-          <a:xfrm>
-            <a:off x="6217920" y="1188720"/>
-            <a:ext cx="2697480" cy="1325880"/>
+              <a:t>4</a:t>
+            </a:r>
+            <a:endParaRPr lang="en-US" sz="1700" dirty="0"/>
+          </a:p>
+        </p:txBody>
+      </p:sp>
+      <p:sp>
+        <p:nvSpPr>
+          <p:cNvPr id="14" name="Text 12"/>
+          <p:cNvSpPr/>
+          <p:nvPr/>
+        </p:nvSpPr>
+        <p:spPr>
+          <a:xfrm>
+            <a:off x="7178040" y="3913632"/>
+            <a:ext cx="4480560" cy="1828800"/>
           </a:xfrm>
           <a:prstGeom prst="rect">
             <a:avLst/>
@@ -4445,94 +5725,332 @@
           <a:ln/>
         </p:spPr>
         <p:txBody>
+          <a:bodyPr wrap="square" lIns="0" tIns="0" rIns="0" bIns="0" rtlCol="0" anchor="t"/>
+          <a:lstStyle/>
+          <a:p>
+            <a:pPr indent="0" marL="0">
+              <a:spcAft>
+                <a:spcPts val="600"/>
+              </a:spcAft>
+              <a:buNone/>
+            </a:pPr>
+            <a:r>
+              <a:rPr lang="en-US" sz="1650" b="1" dirty="0">
+                <a:solidFill>
+                  <a:srgbClr val="1E2761"/>
+                </a:solidFill>
+                <a:latin typeface="Calibri" pitchFamily="34" charset="0"/>
+                <a:ea typeface="Calibri" pitchFamily="34" charset="-122"/>
+                <a:cs typeface="Calibri" pitchFamily="34" charset="-120"/>
+              </a:rPr>
+              <a:t>Float-faithful pipeline</a:t>
+            </a:r>
+            <a:endParaRPr lang="en-US" sz="1650" dirty="0"/>
+          </a:p>
+          <a:p>
+            <a:pPr indent="0" marL="0">
+              <a:spcAft>
+                <a:spcPts val="600"/>
+              </a:spcAft>
+              <a:buNone/>
+            </a:pPr>
+            <a:r>
+              <a:rPr lang="en-US" sz="1250" dirty="0">
+                <a:solidFill>
+                  <a:srgbClr val="333333"/>
+                </a:solidFill>
+                <a:latin typeface="Calibri" pitchFamily="34" charset="0"/>
+                <a:ea typeface="Calibri" pitchFamily="34" charset="-122"/>
+                <a:cs typeface="Calibri" pitchFamily="34" charset="-120"/>
+              </a:rPr>
+              <a:t>Degraded inputs carry values outside [0,1] — real noise signal. Native float32 .npy I/O end to end; a PNG-based pipeline would silently clip and lose it.</a:t>
+            </a:r>
+            <a:endParaRPr lang="en-US" sz="1650" dirty="0"/>
+          </a:p>
+        </p:txBody>
+      </p:sp>
+    </p:spTree>
+  </p:cSld>
+  <p:clrMapOvr>
+    <a:masterClrMapping/>
+  </p:clrMapOvr>
+</p:sld>
+</file>
+
+<file path=ppt/slides/slide7.xml><?xml version="1.0" encoding="utf-8"?>
+<p:sld xmlns:a="http://schemas.openxmlformats.org/drawingml/2006/main" xmlns:r="http://schemas.openxmlformats.org/officeDocument/2006/relationships" xmlns:p="http://schemas.openxmlformats.org/presentationml/2006/main">
+  <p:cSld name="Slide 7">
+    <p:spTree>
+      <p:nvGrpSpPr>
+        <p:cNvPr id="1" name=""/>
+        <p:cNvGrpSpPr/>
+        <p:nvPr/>
+      </p:nvGrpSpPr>
+      <p:grpSpPr>
+        <a:xfrm>
+          <a:off x="0" y="0"/>
+          <a:ext cx="0" cy="0"/>
+          <a:chOff x="0" y="0"/>
+          <a:chExt cx="0" cy="0"/>
+        </a:xfrm>
+      </p:grpSpPr>
+      <p:sp>
+        <p:nvSpPr>
+          <p:cNvPr id="2" name="Text 0"/>
+          <p:cNvSpPr/>
+          <p:nvPr/>
+        </p:nvSpPr>
+        <p:spPr>
+          <a:xfrm>
+            <a:off x="548640" y="320040"/>
+            <a:ext cx="11064240" cy="685800"/>
+          </a:xfrm>
+          <a:prstGeom prst="rect">
+            <a:avLst/>
+          </a:prstGeom>
+          <a:noFill/>
+          <a:ln/>
+        </p:spPr>
+        <p:txBody>
           <a:bodyPr wrap="square" lIns="0" tIns="0" rIns="0" bIns="0" rtlCol="0" anchor="ctr"/>
           <a:lstStyle/>
           <a:p>
-            <a:pPr algn="l" indent="0" marL="0">
-              <a:buNone/>
-            </a:pPr>
-            <a:r>
-              <a:rPr lang="en-US" sz="3800" b="1" dirty="0">
-                <a:solidFill>
-                  <a:srgbClr val="0A8F72"/>
+            <a:pPr indent="0" marL="0">
+              <a:buNone/>
+            </a:pPr>
+            <a:r>
+              <a:rPr lang="en-US" sz="3200" b="1" dirty="0">
+                <a:solidFill>
+                  <a:srgbClr val="1E2761"/>
                 </a:solidFill>
                 <a:latin typeface="Arial" pitchFamily="34" charset="0"/>
                 <a:ea typeface="Arial" pitchFamily="34" charset="-122"/>
                 <a:cs typeface="Arial" pitchFamily="34" charset="-120"/>
               </a:rPr>
-              <a:t>−60 %</a:t>
-            </a:r>
-            <a:endParaRPr lang="en-US" sz="3800" dirty="0"/>
-          </a:p>
+              <a:t>Results — better on every judged metric</a:t>
+            </a:r>
+            <a:endParaRPr lang="en-US" sz="3200" dirty="0"/>
+          </a:p>
+        </p:txBody>
+      </p:sp>
+      <p:sp>
+        <p:nvSpPr>
+          <p:cNvPr id="3" name="Text 1"/>
+          <p:cNvSpPr/>
+          <p:nvPr/>
+        </p:nvSpPr>
+        <p:spPr>
+          <a:xfrm>
+            <a:off x="548640" y="1188720"/>
+            <a:ext cx="2697480" cy="1325880"/>
+          </a:xfrm>
+          <a:prstGeom prst="rect">
+            <a:avLst/>
+          </a:prstGeom>
+          <a:noFill/>
+          <a:ln/>
+        </p:spPr>
+        <p:txBody>
+          <a:bodyPr wrap="square" lIns="0" tIns="0" rIns="0" bIns="0" rtlCol="0" anchor="ctr"/>
+          <a:lstStyle/>
           <a:p>
             <a:pPr algn="l" indent="0" marL="0">
               <a:buNone/>
             </a:pPr>
             <a:r>
-              <a:rPr lang="en-US" sz="1150" dirty="0">
-                <a:solidFill>
-                  <a:srgbClr val="5A6478"/>
+              <a:rPr lang="en-US" sz="3800" b="1" dirty="0">
+                <a:solidFill>
+                  <a:srgbClr val="0A8F72"/>
                 </a:solidFill>
                 <a:latin typeface="Arial" pitchFamily="34" charset="0"/>
                 <a:ea typeface="Arial" pitchFamily="34" charset="-122"/>
                 <a:cs typeface="Arial" pitchFamily="34" charset="-120"/>
               </a:rPr>
-              <a:t>LPIPS (lower is better)</a:t>
+              <a:t>+5.0 dB</a:t>
             </a:r>
             <a:endParaRPr lang="en-US" sz="3800" dirty="0"/>
           </a:p>
-        </p:txBody>
-      </p:sp>
-      <p:sp>
-        <p:nvSpPr>
-          <p:cNvPr id="6" name="Text 4"/>
-          <p:cNvSpPr/>
-          <p:nvPr/>
-        </p:nvSpPr>
-        <p:spPr>
-          <a:xfrm>
-            <a:off x="9052560" y="1188720"/>
-            <a:ext cx="2697480" cy="1325880"/>
-          </a:xfrm>
-          <a:prstGeom prst="rect">
-            <a:avLst/>
-          </a:prstGeom>
-          <a:noFill/>
-          <a:ln/>
-        </p:spPr>
-        <p:txBody>
-          <a:bodyPr wrap="square" lIns="0" tIns="0" rIns="0" bIns="0" rtlCol="0" anchor="ctr"/>
-          <a:lstStyle/>
           <a:p>
             <a:pPr algn="l" indent="0" marL="0">
               <a:buNone/>
             </a:pPr>
             <a:r>
-              <a:rPr lang="en-US" sz="3800" b="1" dirty="0">
-                <a:solidFill>
-                  <a:srgbClr val="1E2761"/>
+              <a:rPr lang="en-US" sz="1150" dirty="0">
+                <a:solidFill>
+                  <a:srgbClr val="5A6478"/>
                 </a:solidFill>
                 <a:latin typeface="Arial" pitchFamily="34" charset="0"/>
                 <a:ea typeface="Arial" pitchFamily="34" charset="-122"/>
                 <a:cs typeface="Arial" pitchFamily="34" charset="-120"/>
               </a:rPr>
-              <a:t>1.2 s</a:t>
+              <a:t>PSNR gain vs baseline</a:t>
             </a:r>
             <a:endParaRPr lang="en-US" sz="3800" dirty="0"/>
           </a:p>
+        </p:txBody>
+      </p:sp>
+      <p:sp>
+        <p:nvSpPr>
+          <p:cNvPr id="4" name="Text 2"/>
+          <p:cNvSpPr/>
+          <p:nvPr/>
+        </p:nvSpPr>
+        <p:spPr>
+          <a:xfrm>
+            <a:off x="3383280" y="1188720"/>
+            <a:ext cx="2697480" cy="1325880"/>
+          </a:xfrm>
+          <a:prstGeom prst="rect">
+            <a:avLst/>
+          </a:prstGeom>
+          <a:noFill/>
+          <a:ln/>
+        </p:spPr>
+        <p:txBody>
+          <a:bodyPr wrap="square" lIns="0" tIns="0" rIns="0" bIns="0" rtlCol="0" anchor="ctr"/>
+          <a:lstStyle/>
           <a:p>
             <a:pPr algn="l" indent="0" marL="0">
               <a:buNone/>
             </a:pPr>
             <a:r>
-              <a:rPr lang="en-US" sz="1150" dirty="0">
-                <a:solidFill>
-                  <a:srgbClr val="5A6478"/>
+              <a:rPr lang="en-US" sz="3800" b="1" dirty="0">
+                <a:solidFill>
+                  <a:srgbClr val="0A8F72"/>
                 </a:solidFill>
                 <a:latin typeface="Arial" pitchFamily="34" charset="0"/>
                 <a:ea typeface="Arial" pitchFamily="34" charset="-122"/>
                 <a:cs typeface="Arial" pitchFamily="34" charset="-120"/>
               </a:rPr>
+              <a:t>+0.22</a:t>
+            </a:r>
+            <a:endParaRPr lang="en-US" sz="3800" dirty="0"/>
+          </a:p>
+          <a:p>
+            <a:pPr algn="l" indent="0" marL="0">
+              <a:buNone/>
+            </a:pPr>
+            <a:r>
+              <a:rPr lang="en-US" sz="1150" dirty="0">
+                <a:solidFill>
+                  <a:srgbClr val="5A6478"/>
+                </a:solidFill>
+                <a:latin typeface="Arial" pitchFamily="34" charset="0"/>
+                <a:ea typeface="Arial" pitchFamily="34" charset="-122"/>
+                <a:cs typeface="Arial" pitchFamily="34" charset="-120"/>
+              </a:rPr>
+              <a:t>SSIM (0.54 → 0.76)</a:t>
+            </a:r>
+            <a:endParaRPr lang="en-US" sz="3800" dirty="0"/>
+          </a:p>
+        </p:txBody>
+      </p:sp>
+      <p:sp>
+        <p:nvSpPr>
+          <p:cNvPr id="5" name="Text 3"/>
+          <p:cNvSpPr/>
+          <p:nvPr/>
+        </p:nvSpPr>
+        <p:spPr>
+          <a:xfrm>
+            <a:off x="6217920" y="1188720"/>
+            <a:ext cx="2697480" cy="1325880"/>
+          </a:xfrm>
+          <a:prstGeom prst="rect">
+            <a:avLst/>
+          </a:prstGeom>
+          <a:noFill/>
+          <a:ln/>
+        </p:spPr>
+        <p:txBody>
+          <a:bodyPr wrap="square" lIns="0" tIns="0" rIns="0" bIns="0" rtlCol="0" anchor="ctr"/>
+          <a:lstStyle/>
+          <a:p>
+            <a:pPr algn="l" indent="0" marL="0">
+              <a:buNone/>
+            </a:pPr>
+            <a:r>
+              <a:rPr lang="en-US" sz="3800" b="1" dirty="0">
+                <a:solidFill>
+                  <a:srgbClr val="0A8F72"/>
+                </a:solidFill>
+                <a:latin typeface="Arial" pitchFamily="34" charset="0"/>
+                <a:ea typeface="Arial" pitchFamily="34" charset="-122"/>
+                <a:cs typeface="Arial" pitchFamily="34" charset="-120"/>
+              </a:rPr>
+              <a:t>−60 %</a:t>
+            </a:r>
+            <a:endParaRPr lang="en-US" sz="3800" dirty="0"/>
+          </a:p>
+          <a:p>
+            <a:pPr algn="l" indent="0" marL="0">
+              <a:buNone/>
+            </a:pPr>
+            <a:r>
+              <a:rPr lang="en-US" sz="1150" dirty="0">
+                <a:solidFill>
+                  <a:srgbClr val="5A6478"/>
+                </a:solidFill>
+                <a:latin typeface="Arial" pitchFamily="34" charset="0"/>
+                <a:ea typeface="Arial" pitchFamily="34" charset="-122"/>
+                <a:cs typeface="Arial" pitchFamily="34" charset="-120"/>
+              </a:rPr>
+              <a:t>LPIPS (lower is better)</a:t>
+            </a:r>
+            <a:endParaRPr lang="en-US" sz="3800" dirty="0"/>
+          </a:p>
+        </p:txBody>
+      </p:sp>
+      <p:sp>
+        <p:nvSpPr>
+          <p:cNvPr id="6" name="Text 4"/>
+          <p:cNvSpPr/>
+          <p:nvPr/>
+        </p:nvSpPr>
+        <p:spPr>
+          <a:xfrm>
+            <a:off x="9052560" y="1188720"/>
+            <a:ext cx="2697480" cy="1325880"/>
+          </a:xfrm>
+          <a:prstGeom prst="rect">
+            <a:avLst/>
+          </a:prstGeom>
+          <a:noFill/>
+          <a:ln/>
+        </p:spPr>
+        <p:txBody>
+          <a:bodyPr wrap="square" lIns="0" tIns="0" rIns="0" bIns="0" rtlCol="0" anchor="ctr"/>
+          <a:lstStyle/>
+          <a:p>
+            <a:pPr algn="l" indent="0" marL="0">
+              <a:buNone/>
+            </a:pPr>
+            <a:r>
+              <a:rPr lang="en-US" sz="3800" b="1" dirty="0">
+                <a:solidFill>
+                  <a:srgbClr val="1E2761"/>
+                </a:solidFill>
+                <a:latin typeface="Arial" pitchFamily="34" charset="0"/>
+                <a:ea typeface="Arial" pitchFamily="34" charset="-122"/>
+                <a:cs typeface="Arial" pitchFamily="34" charset="-120"/>
+              </a:rPr>
+              <a:t>1.2 s</a:t>
+            </a:r>
+            <a:endParaRPr lang="en-US" sz="3800" dirty="0"/>
+          </a:p>
+          <a:p>
+            <a:pPr algn="l" indent="0" marL="0">
+              <a:buNone/>
+            </a:pPr>
+            <a:r>
+              <a:rPr lang="en-US" sz="1150" dirty="0">
+                <a:solidFill>
+                  <a:srgbClr val="5A6478"/>
+                </a:solidFill>
+                <a:latin typeface="Arial" pitchFamily="34" charset="0"/>
+                <a:ea typeface="Arial" pitchFamily="34" charset="-122"/>
+                <a:cs typeface="Arial" pitchFamily="34" charset="-120"/>
+              </a:rPr>
               <a:t>per image on plain CPU</a:t>
             </a:r>
             <a:endParaRPr lang="en-US" sz="3800" dirty="0"/>
@@ -4541,7 +6059,7 @@
       </p:sp>
       <p:graphicFrame>
         <p:nvGraphicFramePr>
-          <p:cNvPr id="7" name="Table 0"/>
+          <p:cNvPr id="8" name="Table 0"/>
           <p:cNvGraphicFramePr>
             <a:graphicFrameLocks noGrp="1"/>
           </p:cNvGraphicFramePr>
@@ -5479,600 +6997,6 @@
 </p:sld>
 </file>
 
-<file path=ppt/slides/slide7.xml><?xml version="1.0" encoding="utf-8"?>
-<p:sld xmlns:a="http://schemas.openxmlformats.org/drawingml/2006/main" xmlns:r="http://schemas.openxmlformats.org/officeDocument/2006/relationships" xmlns:p="http://schemas.openxmlformats.org/presentationml/2006/main">
-  <p:cSld name="Slide 7">
-    <p:spTree>
-      <p:nvGrpSpPr>
-        <p:cNvPr id="1" name=""/>
-        <p:cNvGrpSpPr/>
-        <p:nvPr/>
-      </p:nvGrpSpPr>
-      <p:grpSpPr>
-        <a:xfrm>
-          <a:off x="0" y="0"/>
-          <a:ext cx="0" cy="0"/>
-          <a:chOff x="0" y="0"/>
-          <a:chExt cx="0" cy="0"/>
-        </a:xfrm>
-      </p:grpSpPr>
-      <p:sp>
-        <p:nvSpPr>
-          <p:cNvPr id="2" name="Text 0"/>
-          <p:cNvSpPr/>
-          <p:nvPr/>
-        </p:nvSpPr>
-        <p:spPr>
-          <a:xfrm>
-            <a:off x="548640" y="320040"/>
-            <a:ext cx="11064240" cy="685800"/>
-          </a:xfrm>
-          <a:prstGeom prst="rect">
-            <a:avLst/>
-          </a:prstGeom>
-          <a:noFill/>
-          <a:ln/>
-        </p:spPr>
-        <p:txBody>
-          <a:bodyPr wrap="square" lIns="0" tIns="0" rIns="0" bIns="0" rtlCol="0" anchor="ctr"/>
-          <a:lstStyle/>
-          <a:p>
-            <a:pPr indent="0" marL="0">
-              <a:buNone/>
-            </a:pPr>
-            <a:r>
-              <a:rPr lang="en-US" sz="3200" b="1" dirty="0">
-                <a:solidFill>
-                  <a:srgbClr val="1E2761"/>
-                </a:solidFill>
-                <a:latin typeface="Arial" pitchFamily="34" charset="0"/>
-                <a:ea typeface="Arial" pitchFamily="34" charset="-122"/>
-                <a:cs typeface="Arial" pitchFamily="34" charset="-120"/>
-              </a:rPr>
-              <a:t>Technology</a:t>
-            </a:r>
-            <a:endParaRPr lang="en-US" sz="3200" dirty="0"/>
-          </a:p>
-        </p:txBody>
-      </p:sp>
-      <p:sp>
-        <p:nvSpPr>
-          <p:cNvPr id="3" name="Text 1"/>
-          <p:cNvSpPr/>
-          <p:nvPr/>
-        </p:nvSpPr>
-        <p:spPr>
-          <a:xfrm>
-            <a:off x="548640" y="1280160"/>
-            <a:ext cx="5029200" cy="365760"/>
-          </a:xfrm>
-          <a:prstGeom prst="rect">
-            <a:avLst/>
-          </a:prstGeom>
-          <a:noFill/>
-          <a:ln/>
-        </p:spPr>
-        <p:txBody>
-          <a:bodyPr wrap="square" lIns="0" tIns="0" rIns="0" bIns="0" rtlCol="0" anchor="ctr"/>
-          <a:lstStyle/>
-          <a:p>
-            <a:pPr indent="0" marL="0">
-              <a:buNone/>
-            </a:pPr>
-            <a:r>
-              <a:rPr lang="en-US" sz="1800" b="1" dirty="0">
-                <a:solidFill>
-                  <a:srgbClr val="1E2761"/>
-                </a:solidFill>
-                <a:latin typeface="Arial" pitchFamily="34" charset="0"/>
-                <a:ea typeface="Arial" pitchFamily="34" charset="-122"/>
-                <a:cs typeface="Arial" pitchFamily="34" charset="-120"/>
-              </a:rPr>
-              <a:t>Stack</a:t>
-            </a:r>
-            <a:endParaRPr lang="en-US" sz="1800" dirty="0"/>
-          </a:p>
-        </p:txBody>
-      </p:sp>
-      <p:sp>
-        <p:nvSpPr>
-          <p:cNvPr id="4" name="Text 2"/>
-          <p:cNvSpPr/>
-          <p:nvPr/>
-        </p:nvSpPr>
-        <p:spPr>
-          <a:xfrm>
-            <a:off x="548640" y="1691640"/>
-            <a:ext cx="5212080" cy="2560320"/>
-          </a:xfrm>
-          <a:prstGeom prst="rect">
-            <a:avLst/>
-          </a:prstGeom>
-          <a:noFill/>
-          <a:ln/>
-        </p:spPr>
-        <p:txBody>
-          <a:bodyPr wrap="square" lIns="0" tIns="0" rIns="0" bIns="0" rtlCol="0" anchor="t"/>
-          <a:lstStyle/>
-          <a:p>
-            <a:pPr marL="342900" indent="-342900">
-              <a:spcAft>
-                <a:spcPts val="1000"/>
-              </a:spcAft>
-              <a:buSzPct val="100000"/>
-              <a:buChar char="•"/>
-            </a:pPr>
-            <a:r>
-              <a:rPr lang="en-US" sz="1400" dirty="0">
-                <a:solidFill>
-                  <a:srgbClr val="222222"/>
-                </a:solidFill>
-                <a:latin typeface="Calibri" pitchFamily="34" charset="0"/>
-                <a:ea typeface="Calibri" pitchFamily="34" charset="-122"/>
-                <a:cs typeface="Calibri" pitchFamily="34" charset="-120"/>
-              </a:rPr>
-              <a:t>PyTorch — model, training, inference</a:t>
-            </a:r>
-            <a:endParaRPr lang="en-US" sz="1400" dirty="0"/>
-          </a:p>
-          <a:p>
-            <a:pPr marL="342900" indent="-342900">
-              <a:spcAft>
-                <a:spcPts val="1000"/>
-              </a:spcAft>
-              <a:buSzPct val="100000"/>
-              <a:buChar char="•"/>
-            </a:pPr>
-            <a:r>
-              <a:rPr lang="en-US" sz="1400" dirty="0">
-                <a:solidFill>
-                  <a:srgbClr val="222222"/>
-                </a:solidFill>
-                <a:latin typeface="Calibri" pitchFamily="34" charset="0"/>
-                <a:ea typeface="Calibri" pitchFamily="34" charset="-122"/>
-                <a:cs typeface="Calibri" pitchFamily="34" charset="-120"/>
-              </a:rPr>
-              <a:t>NAFNet-SR — implemented by us, from scratch</a:t>
-            </a:r>
-            <a:endParaRPr lang="en-US" sz="1400" dirty="0"/>
-          </a:p>
-          <a:p>
-            <a:pPr marL="342900" indent="-342900">
-              <a:spcAft>
-                <a:spcPts val="1000"/>
-              </a:spcAft>
-              <a:buSzPct val="100000"/>
-              <a:buChar char="•"/>
-            </a:pPr>
-            <a:r>
-              <a:rPr lang="en-US" sz="1400" dirty="0">
-                <a:solidFill>
-                  <a:srgbClr val="222222"/>
-                </a:solidFill>
-                <a:latin typeface="Calibri" pitchFamily="34" charset="0"/>
-                <a:ea typeface="Calibri" pitchFamily="34" charset="-122"/>
-                <a:cs typeface="Calibri" pitchFamily="34" charset="-120"/>
-              </a:rPr>
-              <a:t>pytorch-msssim + lpips — differentiable quality losses</a:t>
-            </a:r>
-            <a:endParaRPr lang="en-US" sz="1400" dirty="0"/>
-          </a:p>
-          <a:p>
-            <a:pPr marL="342900" indent="-342900">
-              <a:spcAft>
-                <a:spcPts val="1000"/>
-              </a:spcAft>
-              <a:buSzPct val="100000"/>
-              <a:buChar char="•"/>
-            </a:pPr>
-            <a:r>
-              <a:rPr lang="en-US" sz="1400" dirty="0">
-                <a:solidFill>
-                  <a:srgbClr val="222222"/>
-                </a:solidFill>
-                <a:latin typeface="Calibri" pitchFamily="34" charset="0"/>
-                <a:ea typeface="Calibri" pitchFamily="34" charset="-122"/>
-                <a:cs typeface="Calibri" pitchFamily="34" charset="-120"/>
-              </a:rPr>
-              <a:t>scikit-image — reference metrics for honest reporting</a:t>
-            </a:r>
-            <a:endParaRPr lang="en-US" sz="1400" dirty="0"/>
-          </a:p>
-          <a:p>
-            <a:pPr marL="342900" indent="-342900">
-              <a:spcAft>
-                <a:spcPts val="1000"/>
-              </a:spcAft>
-              <a:buSzPct val="100000"/>
-              <a:buChar char="•"/>
-            </a:pPr>
-            <a:r>
-              <a:rPr lang="en-US" sz="1400" dirty="0">
-                <a:solidFill>
-                  <a:srgbClr val="222222"/>
-                </a:solidFill>
-                <a:latin typeface="Calibri" pitchFamily="34" charset="0"/>
-                <a:ea typeface="Calibri" pitchFamily="34" charset="-122"/>
-                <a:cs typeface="Calibri" pitchFamily="34" charset="-120"/>
-              </a:rPr>
-              <a:t>Streamlit — live demo UI (upload → restore → compare)</a:t>
-            </a:r>
-            <a:endParaRPr lang="en-US" sz="1400" dirty="0"/>
-          </a:p>
-        </p:txBody>
-      </p:sp>
-      <p:sp>
-        <p:nvSpPr>
-          <p:cNvPr id="5" name="Text 3"/>
-          <p:cNvSpPr/>
-          <p:nvPr/>
-        </p:nvSpPr>
-        <p:spPr>
-          <a:xfrm>
-            <a:off x="6309360" y="1280160"/>
-            <a:ext cx="5029200" cy="365760"/>
-          </a:xfrm>
-          <a:prstGeom prst="rect">
-            <a:avLst/>
-          </a:prstGeom>
-          <a:noFill/>
-          <a:ln/>
-        </p:spPr>
-        <p:txBody>
-          <a:bodyPr wrap="square" lIns="0" tIns="0" rIns="0" bIns="0" rtlCol="0" anchor="ctr"/>
-          <a:lstStyle/>
-          <a:p>
-            <a:pPr indent="0" marL="0">
-              <a:buNone/>
-            </a:pPr>
-            <a:r>
-              <a:rPr lang="en-US" sz="1800" b="1" dirty="0">
-                <a:solidFill>
-                  <a:srgbClr val="1E2761"/>
-                </a:solidFill>
-                <a:latin typeface="Arial" pitchFamily="34" charset="0"/>
-                <a:ea typeface="Arial" pitchFamily="34" charset="-122"/>
-                <a:cs typeface="Arial" pitchFamily="34" charset="-120"/>
-              </a:rPr>
-              <a:t>Pipeline</a:t>
-            </a:r>
-            <a:endParaRPr lang="en-US" sz="1800" dirty="0"/>
-          </a:p>
-        </p:txBody>
-      </p:sp>
-      <p:sp>
-        <p:nvSpPr>
-          <p:cNvPr id="6" name="Text 4"/>
-          <p:cNvSpPr/>
-          <p:nvPr/>
-        </p:nvSpPr>
-        <p:spPr>
-          <a:xfrm>
-            <a:off x="6309360" y="1783080"/>
-            <a:ext cx="457200" cy="457200"/>
-          </a:xfrm>
-          <a:prstGeom prst="ellipse">
-            <a:avLst/>
-          </a:prstGeom>
-          <a:solidFill>
-            <a:srgbClr val="1E2761"/>
-          </a:solidFill>
-          <a:ln/>
-        </p:spPr>
-        <p:txBody>
-          <a:bodyPr wrap="square" rtlCol="0" anchor="ctr"/>
-          <a:lstStyle/>
-          <a:p>
-            <a:pPr algn="ctr" indent="0" marL="0">
-              <a:buNone/>
-            </a:pPr>
-            <a:r>
-              <a:rPr lang="en-US" sz="1600" b="1" dirty="0">
-                <a:solidFill>
-                  <a:srgbClr val="FFFFFF"/>
-                </a:solidFill>
-                <a:latin typeface="Arial" pitchFamily="34" charset="0"/>
-                <a:ea typeface="Arial" pitchFamily="34" charset="-122"/>
-                <a:cs typeface="Arial" pitchFamily="34" charset="-120"/>
-              </a:rPr>
-              <a:t>1</a:t>
-            </a:r>
-            <a:endParaRPr lang="en-US" sz="1600" dirty="0"/>
-          </a:p>
-        </p:txBody>
-      </p:sp>
-      <p:sp>
-        <p:nvSpPr>
-          <p:cNvPr id="7" name="Text 5"/>
-          <p:cNvSpPr/>
-          <p:nvPr/>
-        </p:nvSpPr>
-        <p:spPr>
-          <a:xfrm>
-            <a:off x="6949440" y="1737360"/>
-            <a:ext cx="4709160" cy="594360"/>
-          </a:xfrm>
-          <a:prstGeom prst="rect">
-            <a:avLst/>
-          </a:prstGeom>
-          <a:noFill/>
-          <a:ln/>
-        </p:spPr>
-        <p:txBody>
-          <a:bodyPr wrap="square" lIns="0" tIns="0" rIns="0" bIns="0" rtlCol="0" anchor="ctr"/>
-          <a:lstStyle/>
-          <a:p>
-            <a:pPr indent="0" marL="0">
-              <a:buNone/>
-            </a:pPr>
-            <a:r>
-              <a:rPr lang="en-US" sz="1350" b="1" dirty="0">
-                <a:solidFill>
-                  <a:srgbClr val="1E2761"/>
-                </a:solidFill>
-                <a:latin typeface="Calibri" pitchFamily="34" charset="0"/>
-                <a:ea typeface="Calibri" pitchFamily="34" charset="-122"/>
-                <a:cs typeface="Calibri" pitchFamily="34" charset="-120"/>
-              </a:rPr>
-              <a:t>Train  —  </a:t>
-            </a:r>
-            <a:pPr indent="0" marL="0">
-              <a:buNone/>
-            </a:pPr>
-            <a:r>
-              <a:rPr lang="en-US" sz="1350" dirty="0">
-                <a:solidFill>
-                  <a:srgbClr val="333333"/>
-                </a:solidFill>
-                <a:latin typeface="Calibri" pitchFamily="34" charset="0"/>
-                <a:ea typeface="Calibri" pitchFamily="34" charset="-122"/>
-                <a:cs typeface="Calibri" pitchFamily="34" charset="-120"/>
-              </a:rPr>
-              <a:t>Google Colab T4 (free) · 100 epochs · ≈ 2 hours</a:t>
-            </a:r>
-            <a:endParaRPr lang="en-US" sz="1350" dirty="0"/>
-          </a:p>
-        </p:txBody>
-      </p:sp>
-      <p:sp>
-        <p:nvSpPr>
-          <p:cNvPr id="8" name="Text 6"/>
-          <p:cNvSpPr/>
-          <p:nvPr/>
-        </p:nvSpPr>
-        <p:spPr>
-          <a:xfrm>
-            <a:off x="6309360" y="2651760"/>
-            <a:ext cx="457200" cy="457200"/>
-          </a:xfrm>
-          <a:prstGeom prst="ellipse">
-            <a:avLst/>
-          </a:prstGeom>
-          <a:solidFill>
-            <a:srgbClr val="1E2761"/>
-          </a:solidFill>
-          <a:ln/>
-        </p:spPr>
-        <p:txBody>
-          <a:bodyPr wrap="square" rtlCol="0" anchor="ctr"/>
-          <a:lstStyle/>
-          <a:p>
-            <a:pPr algn="ctr" indent="0" marL="0">
-              <a:buNone/>
-            </a:pPr>
-            <a:r>
-              <a:rPr lang="en-US" sz="1600" b="1" dirty="0">
-                <a:solidFill>
-                  <a:srgbClr val="FFFFFF"/>
-                </a:solidFill>
-                <a:latin typeface="Arial" pitchFamily="34" charset="0"/>
-                <a:ea typeface="Arial" pitchFamily="34" charset="-122"/>
-                <a:cs typeface="Arial" pitchFamily="34" charset="-120"/>
-              </a:rPr>
-              <a:t>2</a:t>
-            </a:r>
-            <a:endParaRPr lang="en-US" sz="1600" dirty="0"/>
-          </a:p>
-        </p:txBody>
-      </p:sp>
-      <p:sp>
-        <p:nvSpPr>
-          <p:cNvPr id="9" name="Text 7"/>
-          <p:cNvSpPr/>
-          <p:nvPr/>
-        </p:nvSpPr>
-        <p:spPr>
-          <a:xfrm>
-            <a:off x="6949440" y="2606040"/>
-            <a:ext cx="4709160" cy="594360"/>
-          </a:xfrm>
-          <a:prstGeom prst="rect">
-            <a:avLst/>
-          </a:prstGeom>
-          <a:noFill/>
-          <a:ln/>
-        </p:spPr>
-        <p:txBody>
-          <a:bodyPr wrap="square" lIns="0" tIns="0" rIns="0" bIns="0" rtlCol="0" anchor="ctr"/>
-          <a:lstStyle/>
-          <a:p>
-            <a:pPr indent="0" marL="0">
-              <a:buNone/>
-            </a:pPr>
-            <a:r>
-              <a:rPr lang="en-US" sz="1350" b="1" dirty="0">
-                <a:solidFill>
-                  <a:srgbClr val="1E2761"/>
-                </a:solidFill>
-                <a:latin typeface="Calibri" pitchFamily="34" charset="0"/>
-                <a:ea typeface="Calibri" pitchFamily="34" charset="-122"/>
-                <a:cs typeface="Calibri" pitchFamily="34" charset="-120"/>
-              </a:rPr>
-              <a:t>Evaluate  —  </a:t>
-            </a:r>
-            <a:pPr indent="0" marL="0">
-              <a:buNone/>
-            </a:pPr>
-            <a:r>
-              <a:rPr lang="en-US" sz="1350" dirty="0">
-                <a:solidFill>
-                  <a:srgbClr val="333333"/>
-                </a:solidFill>
-                <a:latin typeface="Calibri" pitchFamily="34" charset="0"/>
-                <a:ea typeface="Calibri" pitchFamily="34" charset="-122"/>
-                <a:cs typeface="Calibri" pitchFamily="34" charset="-120"/>
-              </a:rPr>
-              <a:t>PSNR / SSIM / LPIPS per image + CSV report</a:t>
-            </a:r>
-            <a:endParaRPr lang="en-US" sz="1350" dirty="0"/>
-          </a:p>
-        </p:txBody>
-      </p:sp>
-      <p:sp>
-        <p:nvSpPr>
-          <p:cNvPr id="10" name="Text 8"/>
-          <p:cNvSpPr/>
-          <p:nvPr/>
-        </p:nvSpPr>
-        <p:spPr>
-          <a:xfrm>
-            <a:off x="6309360" y="3520440"/>
-            <a:ext cx="457200" cy="457200"/>
-          </a:xfrm>
-          <a:prstGeom prst="ellipse">
-            <a:avLst/>
-          </a:prstGeom>
-          <a:solidFill>
-            <a:srgbClr val="1E2761"/>
-          </a:solidFill>
-          <a:ln/>
-        </p:spPr>
-        <p:txBody>
-          <a:bodyPr wrap="square" rtlCol="0" anchor="ctr"/>
-          <a:lstStyle/>
-          <a:p>
-            <a:pPr algn="ctr" indent="0" marL="0">
-              <a:buNone/>
-            </a:pPr>
-            <a:r>
-              <a:rPr lang="en-US" sz="1600" b="1" dirty="0">
-                <a:solidFill>
-                  <a:srgbClr val="FFFFFF"/>
-                </a:solidFill>
-                <a:latin typeface="Arial" pitchFamily="34" charset="0"/>
-                <a:ea typeface="Arial" pitchFamily="34" charset="-122"/>
-                <a:cs typeface="Arial" pitchFamily="34" charset="-120"/>
-              </a:rPr>
-              <a:t>3</a:t>
-            </a:r>
-            <a:endParaRPr lang="en-US" sz="1600" dirty="0"/>
-          </a:p>
-        </p:txBody>
-      </p:sp>
-      <p:sp>
-        <p:nvSpPr>
-          <p:cNvPr id="11" name="Text 9"/>
-          <p:cNvSpPr/>
-          <p:nvPr/>
-        </p:nvSpPr>
-        <p:spPr>
-          <a:xfrm>
-            <a:off x="6949440" y="3474720"/>
-            <a:ext cx="4709160" cy="594360"/>
-          </a:xfrm>
-          <a:prstGeom prst="rect">
-            <a:avLst/>
-          </a:prstGeom>
-          <a:noFill/>
-          <a:ln/>
-        </p:spPr>
-        <p:txBody>
-          <a:bodyPr wrap="square" lIns="0" tIns="0" rIns="0" bIns="0" rtlCol="0" anchor="ctr"/>
-          <a:lstStyle/>
-          <a:p>
-            <a:pPr indent="0" marL="0">
-              <a:buNone/>
-            </a:pPr>
-            <a:r>
-              <a:rPr lang="en-US" sz="1350" b="1" dirty="0">
-                <a:solidFill>
-                  <a:srgbClr val="1E2761"/>
-                </a:solidFill>
-                <a:latin typeface="Calibri" pitchFamily="34" charset="0"/>
-                <a:ea typeface="Calibri" pitchFamily="34" charset="-122"/>
-                <a:cs typeface="Calibri" pitchFamily="34" charset="-120"/>
-              </a:rPr>
-              <a:t>Deploy  —  </a:t>
-            </a:r>
-            <a:pPr indent="0" marL="0">
-              <a:buNone/>
-            </a:pPr>
-            <a:r>
-              <a:rPr lang="en-US" sz="1350" dirty="0">
-                <a:solidFill>
-                  <a:srgbClr val="333333"/>
-                </a:solidFill>
-                <a:latin typeface="Calibri" pitchFamily="34" charset="0"/>
-                <a:ea typeface="Calibri" pitchFamily="34" charset="-122"/>
-                <a:cs typeface="Calibri" pitchFamily="34" charset="-120"/>
-              </a:rPr>
-              <a:t>Streamlit demo · 1.2 s/image on CPU, no GPU needed</a:t>
-            </a:r>
-            <a:endParaRPr lang="en-US" sz="1350" dirty="0"/>
-          </a:p>
-        </p:txBody>
-      </p:sp>
-      <p:sp>
-        <p:nvSpPr>
-          <p:cNvPr id="12" name="Text 10"/>
-          <p:cNvSpPr/>
-          <p:nvPr/>
-        </p:nvSpPr>
-        <p:spPr>
-          <a:xfrm>
-            <a:off x="548640" y="5120640"/>
-            <a:ext cx="11018520" cy="731520"/>
-          </a:xfrm>
-          <a:prstGeom prst="roundRect">
-            <a:avLst>
-              <a:gd name="adj" fmla="val 12500"/>
-            </a:avLst>
-          </a:prstGeom>
-          <a:solidFill>
-            <a:srgbClr val="F4F7FD"/>
-          </a:solidFill>
-          <a:ln/>
-        </p:spPr>
-        <p:txBody>
-          <a:bodyPr wrap="square" rtlCol="0" anchor="ctr"/>
-          <a:lstStyle/>
-          <a:p>
-            <a:pPr algn="ctr" indent="0" marL="0">
-              <a:buNone/>
-            </a:pPr>
-            <a:r>
-              <a:rPr lang="en-US" sz="1400" b="1" dirty="0">
-                <a:solidFill>
-                  <a:srgbClr val="1E2761"/>
-                </a:solidFill>
-                <a:latin typeface="Calibri" pitchFamily="34" charset="0"/>
-                <a:ea typeface="Calibri" pitchFamily="34" charset="-122"/>
-                <a:cs typeface="Calibri" pitchFamily="34" charset="-120"/>
-              </a:rPr>
-              <a:t>Fully reproducible: seeded data splits · frozen benchmark · model config stored inside the checkpoint → inference needs zero code edits.</a:t>
-            </a:r>
-            <a:endParaRPr lang="en-US" sz="1400" dirty="0"/>
-          </a:p>
-        </p:txBody>
-      </p:sp>
-    </p:spTree>
-  </p:cSld>
-  <p:clrMapOvr>
-    <a:masterClrMapping/>
-  </p:clrMapOvr>
-</p:sld>
-</file>
-
 <file path=ppt/slides/slide8.xml><?xml version="1.0" encoding="utf-8"?>
 <p:sld xmlns:a="http://schemas.openxmlformats.org/drawingml/2006/main" xmlns:r="http://schemas.openxmlformats.org/officeDocument/2006/relationships" xmlns:p="http://schemas.openxmlformats.org/presentationml/2006/main">
   <p:cSld name="Slide 8">
@@ -6123,7 +7047,7 @@
                 <a:ea typeface="Arial" pitchFamily="34" charset="-122"/>
                 <a:cs typeface="Arial" pitchFamily="34" charset="-120"/>
               </a:rPr>
-              <a:t>Code &amp; Reproducibility</a:t>
+              <a:t>Impact &amp; Feasibility</a:t>
             </a:r>
             <a:endParaRPr lang="en-US" sz="3200" dirty="0"/>
           </a:p>
@@ -6137,12 +7061,302 @@
         </p:nvSpPr>
         <p:spPr>
           <a:xfrm>
-            <a:off x="548640" y="1371600"/>
-            <a:ext cx="5394960" cy="3383280"/>
+            <a:off x="548640" y="1234440"/>
+            <a:ext cx="5212080" cy="320040"/>
+          </a:xfrm>
+          <a:prstGeom prst="rect">
+            <a:avLst/>
+          </a:prstGeom>
+          <a:noFill/>
+          <a:ln/>
+        </p:spPr>
+        <p:txBody>
+          <a:bodyPr wrap="square" lIns="0" tIns="0" rIns="0" bIns="0" rtlCol="0" anchor="ctr"/>
+          <a:lstStyle/>
+          <a:p>
+            <a:pPr indent="0" marL="0">
+              <a:buNone/>
+            </a:pPr>
+            <a:r>
+              <a:rPr lang="en-US" sz="1700" b="1" dirty="0">
+                <a:solidFill>
+                  <a:srgbClr val="1E2761"/>
+                </a:solidFill>
+                <a:latin typeface="Arial" pitchFamily="34" charset="0"/>
+                <a:ea typeface="Arial" pitchFamily="34" charset="-122"/>
+                <a:cs typeface="Arial" pitchFamily="34" charset="-120"/>
+              </a:rPr>
+              <a:t>Impact</a:t>
+            </a:r>
+            <a:endParaRPr lang="en-US" sz="1700" dirty="0"/>
+          </a:p>
+        </p:txBody>
+      </p:sp>
+      <p:sp>
+        <p:nvSpPr>
+          <p:cNvPr id="4" name="Text 2"/>
+          <p:cNvSpPr/>
+          <p:nvPr/>
+        </p:nvSpPr>
+        <p:spPr>
+          <a:xfrm>
+            <a:off x="548640" y="1600200"/>
+            <a:ext cx="5212080" cy="2377440"/>
+          </a:xfrm>
+          <a:prstGeom prst="rect">
+            <a:avLst/>
+          </a:prstGeom>
+          <a:noFill/>
+          <a:ln/>
+        </p:spPr>
+        <p:txBody>
+          <a:bodyPr wrap="square" lIns="0" tIns="0" rIns="0" bIns="0" rtlCol="0" anchor="t"/>
+          <a:lstStyle/>
+          <a:p>
+            <a:pPr marL="342900" indent="-342900">
+              <a:spcAft>
+                <a:spcPts val="900"/>
+              </a:spcAft>
+              <a:buSzPct val="100000"/>
+              <a:buChar char="•"/>
+            </a:pPr>
+            <a:r>
+              <a:rPr lang="en-US" sz="1350" dirty="0">
+                <a:solidFill>
+                  <a:srgbClr val="222222"/>
+                </a:solidFill>
+                <a:latin typeface="Calibri" pitchFamily="34" charset="0"/>
+                <a:ea typeface="Calibri" pitchFamily="34" charset="-122"/>
+                <a:cs typeface="Calibri" pitchFamily="34" charset="-120"/>
+              </a:rPr>
+              <a:t>Defects hidden in noise become visible — fewer missed escapes, fewer false alarms</a:t>
+            </a:r>
+            <a:endParaRPr lang="en-US" sz="1350" dirty="0"/>
+          </a:p>
+          <a:p>
+            <a:pPr marL="342900" indent="-342900">
+              <a:spcAft>
+                <a:spcPts val="900"/>
+              </a:spcAft>
+              <a:buSzPct val="100000"/>
+              <a:buChar char="•"/>
+            </a:pPr>
+            <a:r>
+              <a:rPr lang="en-US" sz="1350" dirty="0">
+                <a:solidFill>
+                  <a:srgbClr val="222222"/>
+                </a:solidFill>
+                <a:latin typeface="Calibri" pitchFamily="34" charset="0"/>
+                <a:ea typeface="Calibri" pitchFamily="34" charset="-122"/>
+                <a:cs typeface="Calibri" pitchFamily="34" charset="-120"/>
+              </a:rPr>
+              <a:t>Enables faster, lower-dose scans: capture noisier images quickly, restore in software</a:t>
+            </a:r>
+            <a:endParaRPr lang="en-US" sz="1350" dirty="0"/>
+          </a:p>
+          <a:p>
+            <a:pPr marL="342900" indent="-342900">
+              <a:spcAft>
+                <a:spcPts val="900"/>
+              </a:spcAft>
+              <a:buSzPct val="100000"/>
+              <a:buChar char="•"/>
+            </a:pPr>
+            <a:r>
+              <a:rPr lang="en-US" sz="1350" dirty="0">
+                <a:solidFill>
+                  <a:srgbClr val="222222"/>
+                </a:solidFill>
+                <a:latin typeface="Calibri" pitchFamily="34" charset="0"/>
+                <a:ea typeface="Calibri" pitchFamily="34" charset="-122"/>
+                <a:cs typeface="Calibri" pitchFamily="34" charset="-120"/>
+              </a:rPr>
+              <a:t>Higher inspection throughput without buying new microscope hardware</a:t>
+            </a:r>
+            <a:endParaRPr lang="en-US" sz="1350" dirty="0"/>
+          </a:p>
+          <a:p>
+            <a:pPr marL="342900" indent="-342900">
+              <a:spcAft>
+                <a:spcPts val="900"/>
+              </a:spcAft>
+              <a:buSzPct val="100000"/>
+              <a:buChar char="•"/>
+            </a:pPr>
+            <a:r>
+              <a:rPr lang="en-US" sz="1350" dirty="0">
+                <a:solidFill>
+                  <a:srgbClr val="222222"/>
+                </a:solidFill>
+                <a:latin typeface="Calibri" pitchFamily="34" charset="0"/>
+                <a:ea typeface="Calibri" pitchFamily="34" charset="-122"/>
+                <a:cs typeface="Calibri" pitchFamily="34" charset="-120"/>
+              </a:rPr>
+              <a:t>Fidelity-first design keeps engineers' trust — the model never invents structure</a:t>
+            </a:r>
+            <a:endParaRPr lang="en-US" sz="1350" dirty="0"/>
+          </a:p>
+        </p:txBody>
+      </p:sp>
+      <p:sp>
+        <p:nvSpPr>
+          <p:cNvPr id="5" name="Text 3"/>
+          <p:cNvSpPr/>
+          <p:nvPr/>
+        </p:nvSpPr>
+        <p:spPr>
+          <a:xfrm>
+            <a:off x="6309360" y="1234440"/>
+            <a:ext cx="5303520" cy="320040"/>
+          </a:xfrm>
+          <a:prstGeom prst="rect">
+            <a:avLst/>
+          </a:prstGeom>
+          <a:noFill/>
+          <a:ln/>
+        </p:spPr>
+        <p:txBody>
+          <a:bodyPr wrap="square" lIns="0" tIns="0" rIns="0" bIns="0" rtlCol="0" anchor="ctr"/>
+          <a:lstStyle/>
+          <a:p>
+            <a:pPr indent="0" marL="0">
+              <a:buNone/>
+            </a:pPr>
+            <a:r>
+              <a:rPr lang="en-US" sz="1700" b="1" dirty="0">
+                <a:solidFill>
+                  <a:srgbClr val="1E2761"/>
+                </a:solidFill>
+                <a:latin typeface="Arial" pitchFamily="34" charset="0"/>
+                <a:ea typeface="Arial" pitchFamily="34" charset="-122"/>
+                <a:cs typeface="Arial" pitchFamily="34" charset="-120"/>
+              </a:rPr>
+              <a:t>Feasibility</a:t>
+            </a:r>
+            <a:endParaRPr lang="en-US" sz="1700" dirty="0"/>
+          </a:p>
+        </p:txBody>
+      </p:sp>
+      <p:sp>
+        <p:nvSpPr>
+          <p:cNvPr id="6" name="Text 4"/>
+          <p:cNvSpPr/>
+          <p:nvPr/>
+        </p:nvSpPr>
+        <p:spPr>
+          <a:xfrm>
+            <a:off x="6309360" y="1600200"/>
+            <a:ext cx="5303520" cy="2377440"/>
+          </a:xfrm>
+          <a:prstGeom prst="rect">
+            <a:avLst/>
+          </a:prstGeom>
+          <a:noFill/>
+          <a:ln/>
+        </p:spPr>
+        <p:txBody>
+          <a:bodyPr wrap="square" lIns="0" tIns="0" rIns="0" bIns="0" rtlCol="0" anchor="t"/>
+          <a:lstStyle/>
+          <a:p>
+            <a:pPr marL="342900" indent="-342900">
+              <a:spcAft>
+                <a:spcPts val="900"/>
+              </a:spcAft>
+              <a:buSzPct val="100000"/>
+              <a:buChar char="•"/>
+            </a:pPr>
+            <a:r>
+              <a:rPr lang="en-US" sz="1350" dirty="0">
+                <a:solidFill>
+                  <a:srgbClr val="222222"/>
+                </a:solidFill>
+                <a:latin typeface="Calibri" pitchFamily="34" charset="0"/>
+                <a:ea typeface="Calibri" pitchFamily="34" charset="-122"/>
+                <a:cs typeface="Calibri" pitchFamily="34" charset="-120"/>
+              </a:rPr>
+              <a:t>Already built and working end to end — not a concept</a:t>
+            </a:r>
+            <a:endParaRPr lang="en-US" sz="1350" dirty="0"/>
+          </a:p>
+          <a:p>
+            <a:pPr marL="342900" indent="-342900">
+              <a:spcAft>
+                <a:spcPts val="900"/>
+              </a:spcAft>
+              <a:buSzPct val="100000"/>
+              <a:buChar char="•"/>
+            </a:pPr>
+            <a:r>
+              <a:rPr lang="en-US" sz="1350" dirty="0">
+                <a:solidFill>
+                  <a:srgbClr val="222222"/>
+                </a:solidFill>
+                <a:latin typeface="Calibri" pitchFamily="34" charset="0"/>
+                <a:ea typeface="Calibri" pitchFamily="34" charset="-122"/>
+                <a:cs typeface="Calibri" pitchFamily="34" charset="-120"/>
+              </a:rPr>
+              <a:t>6.5 MB model runs on a plain laptop CPU; no GPU needed to deploy</a:t>
+            </a:r>
+            <a:endParaRPr lang="en-US" sz="1350" dirty="0"/>
+          </a:p>
+          <a:p>
+            <a:pPr marL="342900" indent="-342900">
+              <a:spcAft>
+                <a:spcPts val="900"/>
+              </a:spcAft>
+              <a:buSzPct val="100000"/>
+              <a:buChar char="•"/>
+            </a:pPr>
+            <a:r>
+              <a:rPr lang="en-US" sz="1350" dirty="0">
+                <a:solidFill>
+                  <a:srgbClr val="222222"/>
+                </a:solidFill>
+                <a:latin typeface="Calibri" pitchFamily="34" charset="0"/>
+                <a:ea typeface="Calibri" pitchFamily="34" charset="-122"/>
+                <a:cs typeface="Calibri" pitchFamily="34" charset="-120"/>
+              </a:rPr>
+              <a:t>Zero infrastructure cost: trained free on Colab, fully open-source stack</a:t>
+            </a:r>
+            <a:endParaRPr lang="en-US" sz="1350" dirty="0"/>
+          </a:p>
+          <a:p>
+            <a:pPr marL="342900" indent="-342900">
+              <a:spcAft>
+                <a:spcPts val="900"/>
+              </a:spcAft>
+              <a:buSzPct val="100000"/>
+              <a:buChar char="•"/>
+            </a:pPr>
+            <a:r>
+              <a:rPr lang="en-US" sz="1350" dirty="0">
+                <a:solidFill>
+                  <a:srgbClr val="222222"/>
+                </a:solidFill>
+                <a:latin typeface="Calibri" pitchFamily="34" charset="0"/>
+                <a:ea typeface="Calibri" pitchFamily="34" charset="-122"/>
+                <a:cs typeface="Calibri" pitchFamily="34" charset="-120"/>
+              </a:rPr>
+              <a:t>Drop-in usage: folder in → folder out, plus a web UI for operators</a:t>
+            </a:r>
+            <a:endParaRPr lang="en-US" sz="1350" dirty="0"/>
+          </a:p>
+        </p:txBody>
+      </p:sp>
+      <p:sp>
+        <p:nvSpPr>
+          <p:cNvPr id="7" name="Text 5"/>
+          <p:cNvSpPr/>
+          <p:nvPr/>
+        </p:nvSpPr>
+        <p:spPr>
+          <a:xfrm>
+            <a:off x="548640" y="4343400"/>
+            <a:ext cx="2606040" cy="960120"/>
           </a:xfrm>
           <a:prstGeom prst="roundRect">
             <a:avLst>
-              <a:gd name="adj" fmla="val 2703"/>
+              <a:gd name="adj" fmla="val 7619"/>
             </a:avLst>
           </a:prstGeom>
           <a:solidFill>
@@ -6151,283 +7365,238 @@
           <a:ln/>
         </p:spPr>
         <p:txBody>
-          <a:bodyPr wrap="square" lIns="203200" tIns="203200" rIns="203200" bIns="203200" rtlCol="0" anchor="ctr"/>
-          <a:lstStyle/>
-          <a:p>
-            <a:pPr indent="0" marL="0">
-              <a:buNone/>
-            </a:pPr>
-            <a:r>
-              <a:rPr lang="en-US" sz="1300" dirty="0">
+          <a:bodyPr wrap="square" lIns="0" tIns="0" rIns="0" bIns="0" rtlCol="0" anchor="ctr"/>
+          <a:lstStyle/>
+          <a:p>
+            <a:pPr algn="ctr" indent="0" marL="0">
+              <a:buNone/>
+            </a:pPr>
+            <a:r>
+              <a:rPr lang="en-US" sz="2600" b="1" dirty="0">
                 <a:solidFill>
                   <a:srgbClr val="1E2761"/>
                 </a:solidFill>
-                <a:latin typeface="Courier New" pitchFamily="34" charset="0"/>
-                <a:ea typeface="Courier New" pitchFamily="34" charset="-122"/>
-                <a:cs typeface="Courier New" pitchFamily="34" charset="-120"/>
-              </a:rPr>
-              <a:t>project/</a:t>
-            </a:r>
-            <a:endParaRPr lang="en-US" sz="1300" dirty="0"/>
-          </a:p>
-          <a:p>
-            <a:pPr indent="0" marL="0">
-              <a:buNone/>
-            </a:pPr>
-            <a:r>
-              <a:rPr lang="en-US" sz="1300" dirty="0">
-                <a:solidFill>
-                  <a:srgbClr val="1E2761"/>
-                </a:solidFill>
-                <a:latin typeface="Courier New" pitchFamily="34" charset="0"/>
-                <a:ea typeface="Courier New" pitchFamily="34" charset="-122"/>
-                <a:cs typeface="Courier New" pitchFamily="34" charset="-120"/>
-              </a:rPr>
-              <a:t>├─ dataset/      loader + degradation pipeline</a:t>
-            </a:r>
-            <a:endParaRPr lang="en-US" sz="1300" dirty="0"/>
-          </a:p>
-          <a:p>
-            <a:pPr indent="0" marL="0">
-              <a:buNone/>
-            </a:pPr>
-            <a:r>
-              <a:rPr lang="en-US" sz="1300" dirty="0">
-                <a:solidFill>
-                  <a:srgbClr val="1E2761"/>
-                </a:solidFill>
-                <a:latin typeface="Courier New" pitchFamily="34" charset="0"/>
-                <a:ea typeface="Courier New" pitchFamily="34" charset="-122"/>
-                <a:cs typeface="Courier New" pitchFamily="34" charset="-120"/>
-              </a:rPr>
-              <a:t>├─ models/       nafnet.py (the architecture)</a:t>
-            </a:r>
-            <a:endParaRPr lang="en-US" sz="1300" dirty="0"/>
-          </a:p>
-          <a:p>
-            <a:pPr indent="0" marL="0">
-              <a:buNone/>
-            </a:pPr>
-            <a:r>
-              <a:rPr lang="en-US" sz="1300" dirty="0">
-                <a:solidFill>
-                  <a:srgbClr val="1E2761"/>
-                </a:solidFill>
-                <a:latin typeface="Courier New" pitchFamily="34" charset="0"/>
-                <a:ea typeface="Courier New" pitchFamily="34" charset="-122"/>
-                <a:cs typeface="Courier New" pitchFamily="34" charset="-120"/>
-              </a:rPr>
-              <a:t>├─ utils/        image_io · losses · metrics</a:t>
-            </a:r>
-            <a:endParaRPr lang="en-US" sz="1300" dirty="0"/>
-          </a:p>
-          <a:p>
-            <a:pPr indent="0" marL="0">
-              <a:buNone/>
-            </a:pPr>
-            <a:r>
-              <a:rPr lang="en-US" sz="1300" dirty="0">
-                <a:solidFill>
-                  <a:srgbClr val="1E2761"/>
-                </a:solidFill>
-                <a:latin typeface="Courier New" pitchFamily="34" charset="0"/>
-                <a:ea typeface="Courier New" pitchFamily="34" charset="-122"/>
-                <a:cs typeface="Courier New" pitchFamily="34" charset="-120"/>
-              </a:rPr>
-              <a:t>├─ train.py      training loop</a:t>
-            </a:r>
-            <a:endParaRPr lang="en-US" sz="1300" dirty="0"/>
-          </a:p>
-          <a:p>
-            <a:pPr indent="0" marL="0">
-              <a:buNone/>
-            </a:pPr>
-            <a:r>
-              <a:rPr lang="en-US" sz="1300" dirty="0">
-                <a:solidFill>
-                  <a:srgbClr val="1E2761"/>
-                </a:solidFill>
-                <a:latin typeface="Courier New" pitchFamily="34" charset="0"/>
-                <a:ea typeface="Courier New" pitchFamily="34" charset="-122"/>
-                <a:cs typeface="Courier New" pitchFamily="34" charset="-120"/>
-              </a:rPr>
-              <a:t>├─ evaluate.py   metric report (CSV)</a:t>
-            </a:r>
-            <a:endParaRPr lang="en-US" sz="1300" dirty="0"/>
-          </a:p>
-          <a:p>
-            <a:pPr indent="0" marL="0">
-              <a:buNone/>
-            </a:pPr>
-            <a:r>
-              <a:rPr lang="en-US" sz="1300" dirty="0">
-                <a:solidFill>
-                  <a:srgbClr val="1E2761"/>
-                </a:solidFill>
-                <a:latin typeface="Courier New" pitchFamily="34" charset="0"/>
-                <a:ea typeface="Courier New" pitchFamily="34" charset="-122"/>
-                <a:cs typeface="Courier New" pitchFamily="34" charset="-120"/>
-              </a:rPr>
-              <a:t>├─ inference.py  batch restore → submission</a:t>
-            </a:r>
-            <a:endParaRPr lang="en-US" sz="1300" dirty="0"/>
-          </a:p>
-          <a:p>
-            <a:pPr indent="0" marL="0">
-              <a:buNone/>
-            </a:pPr>
-            <a:r>
-              <a:rPr lang="en-US" sz="1300" dirty="0">
-                <a:solidFill>
-                  <a:srgbClr val="1E2761"/>
-                </a:solidFill>
-                <a:latin typeface="Courier New" pitchFamily="34" charset="0"/>
-                <a:ea typeface="Courier New" pitchFamily="34" charset="-122"/>
-                <a:cs typeface="Courier New" pitchFamily="34" charset="-120"/>
-              </a:rPr>
-              <a:t>├─ app.py        Streamlit demo</a:t>
-            </a:r>
-            <a:endParaRPr lang="en-US" sz="1300" dirty="0"/>
-          </a:p>
-          <a:p>
-            <a:pPr indent="0" marL="0">
-              <a:buNone/>
-            </a:pPr>
-            <a:r>
-              <a:rPr lang="en-US" sz="1300" dirty="0">
-                <a:solidFill>
-                  <a:srgbClr val="1E2761"/>
-                </a:solidFill>
-                <a:latin typeface="Courier New" pitchFamily="34" charset="0"/>
-                <a:ea typeface="Courier New" pitchFamily="34" charset="-122"/>
-                <a:cs typeface="Courier New" pitchFamily="34" charset="-120"/>
-              </a:rPr>
-              <a:t>└─ README.md     results + 4-command repro</a:t>
-            </a:r>
-            <a:endParaRPr lang="en-US" sz="1300" dirty="0"/>
-          </a:p>
-        </p:txBody>
-      </p:sp>
-      <p:sp>
-        <p:nvSpPr>
-          <p:cNvPr id="4" name="Text 2"/>
-          <p:cNvSpPr/>
-          <p:nvPr/>
-        </p:nvSpPr>
-        <p:spPr>
-          <a:xfrm>
-            <a:off x="6400800" y="1463040"/>
-            <a:ext cx="5212080" cy="2286000"/>
-          </a:xfrm>
-          <a:prstGeom prst="rect">
-            <a:avLst/>
-          </a:prstGeom>
-          <a:noFill/>
-          <a:ln/>
-        </p:spPr>
-        <p:txBody>
-          <a:bodyPr wrap="square" lIns="0" tIns="0" rIns="0" bIns="0" rtlCol="0" anchor="t"/>
-          <a:lstStyle/>
-          <a:p>
-            <a:pPr marL="342900" indent="-342900">
-              <a:spcAft>
-                <a:spcPts val="1200"/>
-              </a:spcAft>
-              <a:buSzPct val="100000"/>
-              <a:buChar char="•"/>
-            </a:pPr>
-            <a:r>
-              <a:rPr lang="en-US" sz="1450" dirty="0">
-                <a:solidFill>
-                  <a:srgbClr val="222222"/>
-                </a:solidFill>
-                <a:latin typeface="Calibri" pitchFamily="34" charset="0"/>
-                <a:ea typeface="Calibri" pitchFamily="34" charset="-122"/>
-                <a:cs typeface="Calibri" pitchFamily="34" charset="-120"/>
-              </a:rPr>
-              <a:t>Small and readable on purpose — nine short modules</a:t>
-            </a:r>
-            <a:endParaRPr lang="en-US" sz="1450" dirty="0"/>
-          </a:p>
-          <a:p>
-            <a:pPr marL="342900" indent="-342900">
-              <a:spcAft>
-                <a:spcPts val="1200"/>
-              </a:spcAft>
-              <a:buSzPct val="100000"/>
-              <a:buChar char="•"/>
-            </a:pPr>
-            <a:r>
-              <a:rPr lang="en-US" sz="1450" dirty="0">
-                <a:solidFill>
-                  <a:srgbClr val="222222"/>
-                </a:solidFill>
-                <a:latin typeface="Calibri" pitchFamily="34" charset="0"/>
-                <a:ea typeface="Calibri" pitchFamily="34" charset="-122"/>
-                <a:cs typeface="Calibri" pitchFamily="34" charset="-120"/>
-              </a:rPr>
-              <a:t>Every file commented with WHY, not just what</a:t>
-            </a:r>
-            <a:endParaRPr lang="en-US" sz="1450" dirty="0"/>
-          </a:p>
-          <a:p>
-            <a:pPr marL="342900" indent="-342900">
-              <a:spcAft>
-                <a:spcPts val="1200"/>
-              </a:spcAft>
-              <a:buSzPct val="100000"/>
-              <a:buChar char="•"/>
-            </a:pPr>
-            <a:r>
-              <a:rPr lang="en-US" sz="1450" dirty="0">
-                <a:solidFill>
-                  <a:srgbClr val="222222"/>
-                </a:solidFill>
-                <a:latin typeface="Calibri" pitchFamily="34" charset="0"/>
-                <a:ea typeface="Calibri" pitchFamily="34" charset="-122"/>
-                <a:cs typeface="Calibri" pitchFamily="34" charset="-120"/>
-              </a:rPr>
-              <a:t>README reproduces every number in this deck with 4 commands</a:t>
-            </a:r>
-            <a:endParaRPr lang="en-US" sz="1450" dirty="0"/>
-          </a:p>
-          <a:p>
-            <a:pPr marL="342900" indent="-342900">
-              <a:spcAft>
-                <a:spcPts val="1200"/>
-              </a:spcAft>
-              <a:buSzPct val="100000"/>
-              <a:buChar char="•"/>
-            </a:pPr>
-            <a:r>
-              <a:rPr lang="en-US" sz="1450" dirty="0">
-                <a:solidFill>
-                  <a:srgbClr val="222222"/>
-                </a:solidFill>
-                <a:latin typeface="Calibri" pitchFamily="34" charset="0"/>
-                <a:ea typeface="Calibri" pitchFamily="34" charset="-122"/>
-                <a:cs typeface="Calibri" pitchFamily="34" charset="-120"/>
-              </a:rPr>
-              <a:t>Trained model (6.8 MB) committed with the code</a:t>
-            </a:r>
-            <a:endParaRPr lang="en-US" sz="1450" dirty="0"/>
-          </a:p>
-        </p:txBody>
-      </p:sp>
-      <p:sp>
-        <p:nvSpPr>
-          <p:cNvPr id="5" name="Text 3"/>
-          <p:cNvSpPr/>
-          <p:nvPr/>
-        </p:nvSpPr>
-        <p:spPr>
-          <a:xfrm>
-            <a:off x="6400800" y="3977640"/>
-            <a:ext cx="5212080" cy="868680"/>
+                <a:latin typeface="Arial" pitchFamily="34" charset="0"/>
+                <a:ea typeface="Arial" pitchFamily="34" charset="-122"/>
+                <a:cs typeface="Arial" pitchFamily="34" charset="-120"/>
+              </a:rPr>
+              <a:t>6.5 MB</a:t>
+            </a:r>
+            <a:endParaRPr lang="en-US" sz="2600" dirty="0"/>
+          </a:p>
+          <a:p>
+            <a:pPr algn="ctr" indent="0" marL="0">
+              <a:buNone/>
+            </a:pPr>
+            <a:r>
+              <a:rPr lang="en-US" sz="1100" dirty="0">
+                <a:solidFill>
+                  <a:srgbClr val="5A6478"/>
+                </a:solidFill>
+                <a:latin typeface="Arial" pitchFamily="34" charset="0"/>
+                <a:ea typeface="Arial" pitchFamily="34" charset="-122"/>
+                <a:cs typeface="Arial" pitchFamily="34" charset="-120"/>
+              </a:rPr>
+              <a:t>model size</a:t>
+            </a:r>
+            <a:endParaRPr lang="en-US" sz="2600" dirty="0"/>
+          </a:p>
+        </p:txBody>
+      </p:sp>
+      <p:sp>
+        <p:nvSpPr>
+          <p:cNvPr id="8" name="Text 6"/>
+          <p:cNvSpPr/>
+          <p:nvPr/>
+        </p:nvSpPr>
+        <p:spPr>
+          <a:xfrm>
+            <a:off x="3337560" y="4343400"/>
+            <a:ext cx="2606040" cy="960120"/>
           </a:xfrm>
           <a:prstGeom prst="roundRect">
             <a:avLst>
-              <a:gd name="adj" fmla="val 10526"/>
+              <a:gd name="adj" fmla="val 7619"/>
+            </a:avLst>
+          </a:prstGeom>
+          <a:solidFill>
+            <a:srgbClr val="F4F7FD"/>
+          </a:solidFill>
+          <a:ln/>
+        </p:spPr>
+        <p:txBody>
+          <a:bodyPr wrap="square" lIns="0" tIns="0" rIns="0" bIns="0" rtlCol="0" anchor="ctr"/>
+          <a:lstStyle/>
+          <a:p>
+            <a:pPr algn="ctr" indent="0" marL="0">
+              <a:buNone/>
+            </a:pPr>
+            <a:r>
+              <a:rPr lang="en-US" sz="2600" b="1" dirty="0">
+                <a:solidFill>
+                  <a:srgbClr val="1E2761"/>
+                </a:solidFill>
+                <a:latin typeface="Arial" pitchFamily="34" charset="0"/>
+                <a:ea typeface="Arial" pitchFamily="34" charset="-122"/>
+                <a:cs typeface="Arial" pitchFamily="34" charset="-120"/>
+              </a:rPr>
+              <a:t>1.2 s</a:t>
+            </a:r>
+            <a:endParaRPr lang="en-US" sz="2600" dirty="0"/>
+          </a:p>
+          <a:p>
+            <a:pPr algn="ctr" indent="0" marL="0">
+              <a:buNone/>
+            </a:pPr>
+            <a:r>
+              <a:rPr lang="en-US" sz="1100" dirty="0">
+                <a:solidFill>
+                  <a:srgbClr val="5A6478"/>
+                </a:solidFill>
+                <a:latin typeface="Arial" pitchFamily="34" charset="0"/>
+                <a:ea typeface="Arial" pitchFamily="34" charset="-122"/>
+                <a:cs typeface="Arial" pitchFamily="34" charset="-120"/>
+              </a:rPr>
+              <a:t>per image, CPU</a:t>
+            </a:r>
+            <a:endParaRPr lang="en-US" sz="2600" dirty="0"/>
+          </a:p>
+        </p:txBody>
+      </p:sp>
+      <p:sp>
+        <p:nvSpPr>
+          <p:cNvPr id="9" name="Text 7"/>
+          <p:cNvSpPr/>
+          <p:nvPr/>
+        </p:nvSpPr>
+        <p:spPr>
+          <a:xfrm>
+            <a:off x="6126480" y="4343400"/>
+            <a:ext cx="2606040" cy="960120"/>
+          </a:xfrm>
+          <a:prstGeom prst="roundRect">
+            <a:avLst>
+              <a:gd name="adj" fmla="val 7619"/>
+            </a:avLst>
+          </a:prstGeom>
+          <a:solidFill>
+            <a:srgbClr val="F4F7FD"/>
+          </a:solidFill>
+          <a:ln/>
+        </p:spPr>
+        <p:txBody>
+          <a:bodyPr wrap="square" lIns="0" tIns="0" rIns="0" bIns="0" rtlCol="0" anchor="ctr"/>
+          <a:lstStyle/>
+          <a:p>
+            <a:pPr algn="ctr" indent="0" marL="0">
+              <a:buNone/>
+            </a:pPr>
+            <a:r>
+              <a:rPr lang="en-US" sz="2600" b="1" dirty="0">
+                <a:solidFill>
+                  <a:srgbClr val="1E2761"/>
+                </a:solidFill>
+                <a:latin typeface="Arial" pitchFamily="34" charset="0"/>
+                <a:ea typeface="Arial" pitchFamily="34" charset="-122"/>
+                <a:cs typeface="Arial" pitchFamily="34" charset="-120"/>
+              </a:rPr>
+              <a:t>8 min</a:t>
+            </a:r>
+            <a:endParaRPr lang="en-US" sz="2600" dirty="0"/>
+          </a:p>
+          <a:p>
+            <a:pPr algn="ctr" indent="0" marL="0">
+              <a:buNone/>
+            </a:pPr>
+            <a:r>
+              <a:rPr lang="en-US" sz="1100" dirty="0">
+                <a:solidFill>
+                  <a:srgbClr val="5A6478"/>
+                </a:solidFill>
+                <a:latin typeface="Arial" pitchFamily="34" charset="0"/>
+                <a:ea typeface="Arial" pitchFamily="34" charset="-122"/>
+                <a:cs typeface="Arial" pitchFamily="34" charset="-120"/>
+              </a:rPr>
+              <a:t>for all 400 test images</a:t>
+            </a:r>
+            <a:endParaRPr lang="en-US" sz="2600" dirty="0"/>
+          </a:p>
+        </p:txBody>
+      </p:sp>
+      <p:sp>
+        <p:nvSpPr>
+          <p:cNvPr id="10" name="Text 8"/>
+          <p:cNvSpPr/>
+          <p:nvPr/>
+        </p:nvSpPr>
+        <p:spPr>
+          <a:xfrm>
+            <a:off x="8915400" y="4343400"/>
+            <a:ext cx="2606040" cy="960120"/>
+          </a:xfrm>
+          <a:prstGeom prst="roundRect">
+            <a:avLst>
+              <a:gd name="adj" fmla="val 7619"/>
+            </a:avLst>
+          </a:prstGeom>
+          <a:solidFill>
+            <a:srgbClr val="F4F7FD"/>
+          </a:solidFill>
+          <a:ln/>
+        </p:spPr>
+        <p:txBody>
+          <a:bodyPr wrap="square" lIns="0" tIns="0" rIns="0" bIns="0" rtlCol="0" anchor="ctr"/>
+          <a:lstStyle/>
+          <a:p>
+            <a:pPr algn="ctr" indent="0" marL="0">
+              <a:buNone/>
+            </a:pPr>
+            <a:r>
+              <a:rPr lang="en-US" sz="2600" b="1" dirty="0">
+                <a:solidFill>
+                  <a:srgbClr val="1E2761"/>
+                </a:solidFill>
+                <a:latin typeface="Arial" pitchFamily="34" charset="0"/>
+                <a:ea typeface="Arial" pitchFamily="34" charset="-122"/>
+                <a:cs typeface="Arial" pitchFamily="34" charset="-120"/>
+              </a:rPr>
+              <a:t>₹0</a:t>
+            </a:r>
+            <a:endParaRPr lang="en-US" sz="2600" dirty="0"/>
+          </a:p>
+          <a:p>
+            <a:pPr algn="ctr" indent="0" marL="0">
+              <a:buNone/>
+            </a:pPr>
+            <a:r>
+              <a:rPr lang="en-US" sz="1100" dirty="0">
+                <a:solidFill>
+                  <a:srgbClr val="5A6478"/>
+                </a:solidFill>
+                <a:latin typeface="Arial" pitchFamily="34" charset="0"/>
+                <a:ea typeface="Arial" pitchFamily="34" charset="-122"/>
+                <a:cs typeface="Arial" pitchFamily="34" charset="-120"/>
+              </a:rPr>
+              <a:t>hardware cost</a:t>
+            </a:r>
+            <a:endParaRPr lang="en-US" sz="2600" dirty="0"/>
+          </a:p>
+        </p:txBody>
+      </p:sp>
+      <p:sp>
+        <p:nvSpPr>
+          <p:cNvPr id="11" name="Text 9"/>
+          <p:cNvSpPr/>
+          <p:nvPr/>
+        </p:nvSpPr>
+        <p:spPr>
+          <a:xfrm>
+            <a:off x="548640" y="5532120"/>
+            <a:ext cx="11018520" cy="594360"/>
+          </a:xfrm>
+          <a:prstGeom prst="roundRect">
+            <a:avLst>
+              <a:gd name="adj" fmla="val 15385"/>
             </a:avLst>
           </a:prstGeom>
           <a:solidFill>
@@ -6447,28 +7616,11 @@
                 <a:solidFill>
                   <a:srgbClr val="FFFFFF"/>
                 </a:solidFill>
-                <a:latin typeface="Courier New" pitchFamily="34" charset="0"/>
-                <a:ea typeface="Courier New" pitchFamily="34" charset="-122"/>
-                <a:cs typeface="Courier New" pitchFamily="34" charset="-120"/>
-              </a:rPr>
-              <a:t>github.com/prakharbajaj1551/</a:t>
-            </a:r>
-            <a:endParaRPr lang="en-US" sz="1400" dirty="0"/>
-          </a:p>
-          <a:p>
-            <a:pPr algn="ctr" indent="0" marL="0">
-              <a:buNone/>
-            </a:pPr>
-            <a:r>
-              <a:rPr lang="en-US" sz="1400" b="1" dirty="0">
-                <a:solidFill>
-                  <a:srgbClr val="FFFFFF"/>
-                </a:solidFill>
-                <a:latin typeface="Courier New" pitchFamily="34" charset="0"/>
-                <a:ea typeface="Courier New" pitchFamily="34" charset="-122"/>
-                <a:cs typeface="Courier New" pitchFamily="34" charset="-120"/>
-              </a:rPr>
-              <a:t>semicon-image-restoration</a:t>
+                <a:latin typeface="Calibri" pitchFamily="34" charset="0"/>
+                <a:ea typeface="Calibri" pitchFamily="34" charset="-122"/>
+                <a:cs typeface="Calibri" pitchFamily="34" charset="-120"/>
+              </a:rPr>
+              <a:t>Ready to pilot today: point it at an inspection folder and the restored images appear alongside.</a:t>
             </a:r>
             <a:endParaRPr lang="en-US" sz="1400" dirty="0"/>
           </a:p>
@@ -6485,13 +7637,6 @@
 <file path=ppt/slides/slide9.xml><?xml version="1.0" encoding="utf-8"?>
 <p:sld xmlns:a="http://schemas.openxmlformats.org/drawingml/2006/main" xmlns:r="http://schemas.openxmlformats.org/officeDocument/2006/relationships" xmlns:p="http://schemas.openxmlformats.org/presentationml/2006/main">
   <p:cSld name="Slide 9">
-    <p:bg>
-      <p:bgPr>
-        <a:solidFill>
-          <a:srgbClr val="1E2761"/>
-        </a:solidFill>
-      </p:bgPr>
-    </p:bg>
     <p:spTree>
       <p:nvGrpSpPr>
         <p:cNvPr id="1" name=""/>
@@ -6514,8 +7659,8 @@
         </p:nvSpPr>
         <p:spPr>
           <a:xfrm>
-            <a:off x="731520" y="548640"/>
-            <a:ext cx="10058400" cy="731520"/>
+            <a:off x="548640" y="320040"/>
+            <a:ext cx="11064240" cy="685800"/>
           </a:xfrm>
           <a:prstGeom prst="rect">
             <a:avLst/>
@@ -6533,13 +7678,13 @@
             <a:r>
               <a:rPr lang="en-US" sz="3200" b="1" dirty="0">
                 <a:solidFill>
-                  <a:srgbClr val="FFFFFF"/>
+                  <a:srgbClr val="1E2761"/>
                 </a:solidFill>
                 <a:latin typeface="Arial" pitchFamily="34" charset="0"/>
                 <a:ea typeface="Arial" pitchFamily="34" charset="-122"/>
                 <a:cs typeface="Arial" pitchFamily="34" charset="-120"/>
               </a:rPr>
-              <a:t>References</a:t>
+              <a:t>Technology</a:t>
             </a:r>
             <a:endParaRPr lang="en-US" sz="3200" dirty="0"/>
           </a:p>
@@ -6553,8 +7698,8 @@
         </p:nvSpPr>
         <p:spPr>
           <a:xfrm>
-            <a:off x="731520" y="1645920"/>
-            <a:ext cx="10698480" cy="2377440"/>
+            <a:off x="548640" y="1280160"/>
+            <a:ext cx="5029200" cy="365760"/>
           </a:xfrm>
           <a:prstGeom prst="rect">
             <a:avLst/>
@@ -6563,104 +7708,164 @@
           <a:ln/>
         </p:spPr>
         <p:txBody>
+          <a:bodyPr wrap="square" lIns="0" tIns="0" rIns="0" bIns="0" rtlCol="0" anchor="ctr"/>
+          <a:lstStyle/>
+          <a:p>
+            <a:pPr indent="0" marL="0">
+              <a:buNone/>
+            </a:pPr>
+            <a:r>
+              <a:rPr lang="en-US" sz="1800" b="1" dirty="0">
+                <a:solidFill>
+                  <a:srgbClr val="1E2761"/>
+                </a:solidFill>
+                <a:latin typeface="Arial" pitchFamily="34" charset="0"/>
+                <a:ea typeface="Arial" pitchFamily="34" charset="-122"/>
+                <a:cs typeface="Arial" pitchFamily="34" charset="-120"/>
+              </a:rPr>
+              <a:t>Stack</a:t>
+            </a:r>
+            <a:endParaRPr lang="en-US" sz="1800" dirty="0"/>
+          </a:p>
+        </p:txBody>
+      </p:sp>
+      <p:sp>
+        <p:nvSpPr>
+          <p:cNvPr id="4" name="Text 2"/>
+          <p:cNvSpPr/>
+          <p:nvPr/>
+        </p:nvSpPr>
+        <p:spPr>
+          <a:xfrm>
+            <a:off x="548640" y="1691640"/>
+            <a:ext cx="5212080" cy="2560320"/>
+          </a:xfrm>
+          <a:prstGeom prst="rect">
+            <a:avLst/>
+          </a:prstGeom>
+          <a:noFill/>
+          <a:ln/>
+        </p:spPr>
+        <p:txBody>
           <a:bodyPr wrap="square" lIns="0" tIns="0" rIns="0" bIns="0" rtlCol="0" anchor="t"/>
           <a:lstStyle/>
           <a:p>
             <a:pPr marL="342900" indent="-342900">
               <a:spcAft>
-                <a:spcPts val="1400"/>
+                <a:spcPts val="1000"/>
               </a:spcAft>
               <a:buSzPct val="100000"/>
               <a:buChar char="•"/>
             </a:pPr>
             <a:r>
-              <a:rPr lang="en-US" sz="1500" dirty="0">
-                <a:solidFill>
-                  <a:srgbClr val="CADCFC"/>
-                </a:solidFill>
-                <a:latin typeface="Calibri" pitchFamily="34" charset="0"/>
-                <a:ea typeface="Calibri" pitchFamily="34" charset="-122"/>
-                <a:cs typeface="Calibri" pitchFamily="34" charset="-120"/>
-              </a:rPr>
-              <a:t>Chen et al. — “Simple Baselines for Image Restoration” (NAFNet), ECCV 2022 · arXiv:2204.04676</a:t>
-            </a:r>
-            <a:endParaRPr lang="en-US" sz="1500" dirty="0"/>
+              <a:rPr lang="en-US" sz="1400" dirty="0">
+                <a:solidFill>
+                  <a:srgbClr val="222222"/>
+                </a:solidFill>
+                <a:latin typeface="Calibri" pitchFamily="34" charset="0"/>
+                <a:ea typeface="Calibri" pitchFamily="34" charset="-122"/>
+                <a:cs typeface="Calibri" pitchFamily="34" charset="-120"/>
+              </a:rPr>
+              <a:t>PyTorch — model, training, inference</a:t>
+            </a:r>
+            <a:endParaRPr lang="en-US" sz="1400" dirty="0"/>
           </a:p>
           <a:p>
             <a:pPr marL="342900" indent="-342900">
               <a:spcAft>
-                <a:spcPts val="1400"/>
+                <a:spcPts val="1000"/>
               </a:spcAft>
               <a:buSzPct val="100000"/>
               <a:buChar char="•"/>
             </a:pPr>
             <a:r>
-              <a:rPr lang="en-US" sz="1500" dirty="0">
-                <a:solidFill>
-                  <a:srgbClr val="CADCFC"/>
-                </a:solidFill>
-                <a:latin typeface="Calibri" pitchFamily="34" charset="0"/>
-                <a:ea typeface="Calibri" pitchFamily="34" charset="-122"/>
-                <a:cs typeface="Calibri" pitchFamily="34" charset="-120"/>
-              </a:rPr>
-              <a:t>Shi et al. — “Real-Time Single Image Super-Resolution Using an Efficient Sub-Pixel CNN” (PixelShuffle), CVPR 2016</a:t>
-            </a:r>
-            <a:endParaRPr lang="en-US" sz="1500" dirty="0"/>
+              <a:rPr lang="en-US" sz="1400" dirty="0">
+                <a:solidFill>
+                  <a:srgbClr val="222222"/>
+                </a:solidFill>
+                <a:latin typeface="Calibri" pitchFamily="34" charset="0"/>
+                <a:ea typeface="Calibri" pitchFamily="34" charset="-122"/>
+                <a:cs typeface="Calibri" pitchFamily="34" charset="-120"/>
+              </a:rPr>
+              <a:t>NAFNet-SR — implemented by us, from scratch</a:t>
+            </a:r>
+            <a:endParaRPr lang="en-US" sz="1400" dirty="0"/>
           </a:p>
           <a:p>
             <a:pPr marL="342900" indent="-342900">
               <a:spcAft>
-                <a:spcPts val="1400"/>
+                <a:spcPts val="1000"/>
               </a:spcAft>
               <a:buSzPct val="100000"/>
               <a:buChar char="•"/>
             </a:pPr>
             <a:r>
-              <a:rPr lang="en-US" sz="1500" dirty="0">
-                <a:solidFill>
-                  <a:srgbClr val="CADCFC"/>
-                </a:solidFill>
-                <a:latin typeface="Calibri" pitchFamily="34" charset="0"/>
-                <a:ea typeface="Calibri" pitchFamily="34" charset="-122"/>
-                <a:cs typeface="Calibri" pitchFamily="34" charset="-120"/>
-              </a:rPr>
-              <a:t>Zhang et al. — “The Unreasonable Effectiveness of Deep Features as a Perceptual Metric” (LPIPS), CVPR 2018</a:t>
-            </a:r>
-            <a:endParaRPr lang="en-US" sz="1500" dirty="0"/>
+              <a:rPr lang="en-US" sz="1400" dirty="0">
+                <a:solidFill>
+                  <a:srgbClr val="222222"/>
+                </a:solidFill>
+                <a:latin typeface="Calibri" pitchFamily="34" charset="0"/>
+                <a:ea typeface="Calibri" pitchFamily="34" charset="-122"/>
+                <a:cs typeface="Calibri" pitchFamily="34" charset="-120"/>
+              </a:rPr>
+              <a:t>pytorch-msssim + lpips — differentiable quality losses</a:t>
+            </a:r>
+            <a:endParaRPr lang="en-US" sz="1400" dirty="0"/>
           </a:p>
           <a:p>
             <a:pPr marL="342900" indent="-342900">
               <a:spcAft>
-                <a:spcPts val="1400"/>
+                <a:spcPts val="1000"/>
               </a:spcAft>
               <a:buSzPct val="100000"/>
               <a:buChar char="•"/>
             </a:pPr>
             <a:r>
-              <a:rPr lang="en-US" sz="1500" dirty="0">
-                <a:solidFill>
-                  <a:srgbClr val="CADCFC"/>
-                </a:solidFill>
-                <a:latin typeface="Calibri" pitchFamily="34" charset="0"/>
-                <a:ea typeface="Calibri" pitchFamily="34" charset="-122"/>
-                <a:cs typeface="Calibri" pitchFamily="34" charset="-120"/>
-              </a:rPr>
-              <a:t>Open-source libraries: PyTorch · pytorch-msssim · lpips · scikit-image · Streamlit</a:t>
-            </a:r>
-            <a:endParaRPr lang="en-US" sz="1500" dirty="0"/>
-          </a:p>
-        </p:txBody>
-      </p:sp>
-      <p:sp>
-        <p:nvSpPr>
-          <p:cNvPr id="4" name="Text 2"/>
-          <p:cNvSpPr/>
-          <p:nvPr/>
-        </p:nvSpPr>
-        <p:spPr>
-          <a:xfrm>
-            <a:off x="731520" y="4846320"/>
-            <a:ext cx="10698480" cy="731520"/>
+              <a:rPr lang="en-US" sz="1400" dirty="0">
+                <a:solidFill>
+                  <a:srgbClr val="222222"/>
+                </a:solidFill>
+                <a:latin typeface="Calibri" pitchFamily="34" charset="0"/>
+                <a:ea typeface="Calibri" pitchFamily="34" charset="-122"/>
+                <a:cs typeface="Calibri" pitchFamily="34" charset="-120"/>
+              </a:rPr>
+              <a:t>scikit-image — reference metrics for honest reporting</a:t>
+            </a:r>
+            <a:endParaRPr lang="en-US" sz="1400" dirty="0"/>
+          </a:p>
+          <a:p>
+            <a:pPr marL="342900" indent="-342900">
+              <a:spcAft>
+                <a:spcPts val="1000"/>
+              </a:spcAft>
+              <a:buSzPct val="100000"/>
+              <a:buChar char="•"/>
+            </a:pPr>
+            <a:r>
+              <a:rPr lang="en-US" sz="1400" dirty="0">
+                <a:solidFill>
+                  <a:srgbClr val="222222"/>
+                </a:solidFill>
+                <a:latin typeface="Calibri" pitchFamily="34" charset="0"/>
+                <a:ea typeface="Calibri" pitchFamily="34" charset="-122"/>
+                <a:cs typeface="Calibri" pitchFamily="34" charset="-120"/>
+              </a:rPr>
+              <a:t>Streamlit — live demo UI (upload → restore → compare)</a:t>
+            </a:r>
+            <a:endParaRPr lang="en-US" sz="1400" dirty="0"/>
+          </a:p>
+        </p:txBody>
+      </p:sp>
+      <p:sp>
+        <p:nvSpPr>
+          <p:cNvPr id="5" name="Text 3"/>
+          <p:cNvSpPr/>
+          <p:nvPr/>
+        </p:nvSpPr>
+        <p:spPr>
+          <a:xfrm>
+            <a:off x="6309360" y="1280160"/>
+            <a:ext cx="5029200" cy="365760"/>
           </a:xfrm>
           <a:prstGeom prst="rect">
             <a:avLst/>
@@ -6676,30 +7881,71 @@
               <a:buNone/>
             </a:pPr>
             <a:r>
-              <a:rPr lang="en-US" sz="4000" b="1" dirty="0">
-                <a:solidFill>
-                  <a:srgbClr val="FFFFFF"/>
+              <a:rPr lang="en-US" sz="1800" b="1" dirty="0">
+                <a:solidFill>
+                  <a:srgbClr val="1E2761"/>
                 </a:solidFill>
                 <a:latin typeface="Arial" pitchFamily="34" charset="0"/>
                 <a:ea typeface="Arial" pitchFamily="34" charset="-122"/>
                 <a:cs typeface="Arial" pitchFamily="34" charset="-120"/>
               </a:rPr>
-              <a:t>Thank you</a:t>
-            </a:r>
-            <a:endParaRPr lang="en-US" sz="4000" dirty="0"/>
-          </a:p>
-        </p:txBody>
-      </p:sp>
-      <p:sp>
-        <p:nvSpPr>
-          <p:cNvPr id="5" name="Text 3"/>
-          <p:cNvSpPr/>
-          <p:nvPr/>
-        </p:nvSpPr>
-        <p:spPr>
-          <a:xfrm>
-            <a:off x="731520" y="5669280"/>
-            <a:ext cx="10698480" cy="457200"/>
+              <a:t>Pipeline</a:t>
+            </a:r>
+            <a:endParaRPr lang="en-US" sz="1800" dirty="0"/>
+          </a:p>
+        </p:txBody>
+      </p:sp>
+      <p:sp>
+        <p:nvSpPr>
+          <p:cNvPr id="6" name="Text 4"/>
+          <p:cNvSpPr/>
+          <p:nvPr/>
+        </p:nvSpPr>
+        <p:spPr>
+          <a:xfrm>
+            <a:off x="6309360" y="1783080"/>
+            <a:ext cx="457200" cy="457200"/>
+          </a:xfrm>
+          <a:prstGeom prst="ellipse">
+            <a:avLst/>
+          </a:prstGeom>
+          <a:solidFill>
+            <a:srgbClr val="1E2761"/>
+          </a:solidFill>
+          <a:ln/>
+        </p:spPr>
+        <p:txBody>
+          <a:bodyPr wrap="square" rtlCol="0" anchor="ctr"/>
+          <a:lstStyle/>
+          <a:p>
+            <a:pPr algn="ctr" indent="0" marL="0">
+              <a:buNone/>
+            </a:pPr>
+            <a:r>
+              <a:rPr lang="en-US" sz="1600" b="1" dirty="0">
+                <a:solidFill>
+                  <a:srgbClr val="FFFFFF"/>
+                </a:solidFill>
+                <a:latin typeface="Arial" pitchFamily="34" charset="0"/>
+                <a:ea typeface="Arial" pitchFamily="34" charset="-122"/>
+                <a:cs typeface="Arial" pitchFamily="34" charset="-120"/>
+              </a:rPr>
+              <a:t>1</a:t>
+            </a:r>
+            <a:endParaRPr lang="en-US" sz="1600" dirty="0"/>
+          </a:p>
+        </p:txBody>
+      </p:sp>
+      <p:sp>
+        <p:nvSpPr>
+          <p:cNvPr id="7" name="Text 5"/>
+          <p:cNvSpPr/>
+          <p:nvPr/>
+        </p:nvSpPr>
+        <p:spPr>
+          <a:xfrm>
+            <a:off x="6949440" y="1737360"/>
+            <a:ext cx="4709160" cy="594360"/>
           </a:xfrm>
           <a:prstGeom prst="rect">
             <a:avLst/>
@@ -6715,17 +7961,262 @@
               <a:buNone/>
             </a:pPr>
             <a:r>
-              <a:rPr lang="en-US" sz="1600" dirty="0">
-                <a:solidFill>
-                  <a:srgbClr val="02C39A"/>
-                </a:solidFill>
-                <a:latin typeface="Calibri" pitchFamily="34" charset="0"/>
-                <a:ea typeface="Calibri" pitchFamily="34" charset="-122"/>
-                <a:cs typeface="Calibri" pitchFamily="34" charset="-120"/>
-              </a:rPr>
-              <a:t>Team BYTE BRIGADE  ·  questions welcome</a:t>
+              <a:rPr lang="en-US" sz="1350" b="1" dirty="0">
+                <a:solidFill>
+                  <a:srgbClr val="1E2761"/>
+                </a:solidFill>
+                <a:latin typeface="Calibri" pitchFamily="34" charset="0"/>
+                <a:ea typeface="Calibri" pitchFamily="34" charset="-122"/>
+                <a:cs typeface="Calibri" pitchFamily="34" charset="-120"/>
+              </a:rPr>
+              <a:t>Train  —  </a:t>
+            </a:r>
+            <a:pPr indent="0" marL="0">
+              <a:buNone/>
+            </a:pPr>
+            <a:r>
+              <a:rPr lang="en-US" sz="1350" dirty="0">
+                <a:solidFill>
+                  <a:srgbClr val="333333"/>
+                </a:solidFill>
+                <a:latin typeface="Calibri" pitchFamily="34" charset="0"/>
+                <a:ea typeface="Calibri" pitchFamily="34" charset="-122"/>
+                <a:cs typeface="Calibri" pitchFamily="34" charset="-120"/>
+              </a:rPr>
+              <a:t>Google Colab T4 (free) · 100 epochs · ≈ 2 hours</a:t>
+            </a:r>
+            <a:endParaRPr lang="en-US" sz="1350" dirty="0"/>
+          </a:p>
+        </p:txBody>
+      </p:sp>
+      <p:sp>
+        <p:nvSpPr>
+          <p:cNvPr id="8" name="Text 6"/>
+          <p:cNvSpPr/>
+          <p:nvPr/>
+        </p:nvSpPr>
+        <p:spPr>
+          <a:xfrm>
+            <a:off x="6309360" y="2651760"/>
+            <a:ext cx="457200" cy="457200"/>
+          </a:xfrm>
+          <a:prstGeom prst="ellipse">
+            <a:avLst/>
+          </a:prstGeom>
+          <a:solidFill>
+            <a:srgbClr val="1E2761"/>
+          </a:solidFill>
+          <a:ln/>
+        </p:spPr>
+        <p:txBody>
+          <a:bodyPr wrap="square" rtlCol="0" anchor="ctr"/>
+          <a:lstStyle/>
+          <a:p>
+            <a:pPr algn="ctr" indent="0" marL="0">
+              <a:buNone/>
+            </a:pPr>
+            <a:r>
+              <a:rPr lang="en-US" sz="1600" b="1" dirty="0">
+                <a:solidFill>
+                  <a:srgbClr val="FFFFFF"/>
+                </a:solidFill>
+                <a:latin typeface="Arial" pitchFamily="34" charset="0"/>
+                <a:ea typeface="Arial" pitchFamily="34" charset="-122"/>
+                <a:cs typeface="Arial" pitchFamily="34" charset="-120"/>
+              </a:rPr>
+              <a:t>2</a:t>
             </a:r>
             <a:endParaRPr lang="en-US" sz="1600" dirty="0"/>
+          </a:p>
+        </p:txBody>
+      </p:sp>
+      <p:sp>
+        <p:nvSpPr>
+          <p:cNvPr id="9" name="Text 7"/>
+          <p:cNvSpPr/>
+          <p:nvPr/>
+        </p:nvSpPr>
+        <p:spPr>
+          <a:xfrm>
+            <a:off x="6949440" y="2606040"/>
+            <a:ext cx="4709160" cy="594360"/>
+          </a:xfrm>
+          <a:prstGeom prst="rect">
+            <a:avLst/>
+          </a:prstGeom>
+          <a:noFill/>
+          <a:ln/>
+        </p:spPr>
+        <p:txBody>
+          <a:bodyPr wrap="square" lIns="0" tIns="0" rIns="0" bIns="0" rtlCol="0" anchor="ctr"/>
+          <a:lstStyle/>
+          <a:p>
+            <a:pPr indent="0" marL="0">
+              <a:buNone/>
+            </a:pPr>
+            <a:r>
+              <a:rPr lang="en-US" sz="1350" b="1" dirty="0">
+                <a:solidFill>
+                  <a:srgbClr val="1E2761"/>
+                </a:solidFill>
+                <a:latin typeface="Calibri" pitchFamily="34" charset="0"/>
+                <a:ea typeface="Calibri" pitchFamily="34" charset="-122"/>
+                <a:cs typeface="Calibri" pitchFamily="34" charset="-120"/>
+              </a:rPr>
+              <a:t>Evaluate  —  </a:t>
+            </a:r>
+            <a:pPr indent="0" marL="0">
+              <a:buNone/>
+            </a:pPr>
+            <a:r>
+              <a:rPr lang="en-US" sz="1350" dirty="0">
+                <a:solidFill>
+                  <a:srgbClr val="333333"/>
+                </a:solidFill>
+                <a:latin typeface="Calibri" pitchFamily="34" charset="0"/>
+                <a:ea typeface="Calibri" pitchFamily="34" charset="-122"/>
+                <a:cs typeface="Calibri" pitchFamily="34" charset="-120"/>
+              </a:rPr>
+              <a:t>PSNR / SSIM / LPIPS per image + CSV report</a:t>
+            </a:r>
+            <a:endParaRPr lang="en-US" sz="1350" dirty="0"/>
+          </a:p>
+        </p:txBody>
+      </p:sp>
+      <p:sp>
+        <p:nvSpPr>
+          <p:cNvPr id="10" name="Text 8"/>
+          <p:cNvSpPr/>
+          <p:nvPr/>
+        </p:nvSpPr>
+        <p:spPr>
+          <a:xfrm>
+            <a:off x="6309360" y="3520440"/>
+            <a:ext cx="457200" cy="457200"/>
+          </a:xfrm>
+          <a:prstGeom prst="ellipse">
+            <a:avLst/>
+          </a:prstGeom>
+          <a:solidFill>
+            <a:srgbClr val="1E2761"/>
+          </a:solidFill>
+          <a:ln/>
+        </p:spPr>
+        <p:txBody>
+          <a:bodyPr wrap="square" rtlCol="0" anchor="ctr"/>
+          <a:lstStyle/>
+          <a:p>
+            <a:pPr algn="ctr" indent="0" marL="0">
+              <a:buNone/>
+            </a:pPr>
+            <a:r>
+              <a:rPr lang="en-US" sz="1600" b="1" dirty="0">
+                <a:solidFill>
+                  <a:srgbClr val="FFFFFF"/>
+                </a:solidFill>
+                <a:latin typeface="Arial" pitchFamily="34" charset="0"/>
+                <a:ea typeface="Arial" pitchFamily="34" charset="-122"/>
+                <a:cs typeface="Arial" pitchFamily="34" charset="-120"/>
+              </a:rPr>
+              <a:t>3</a:t>
+            </a:r>
+            <a:endParaRPr lang="en-US" sz="1600" dirty="0"/>
+          </a:p>
+        </p:txBody>
+      </p:sp>
+      <p:sp>
+        <p:nvSpPr>
+          <p:cNvPr id="11" name="Text 9"/>
+          <p:cNvSpPr/>
+          <p:nvPr/>
+        </p:nvSpPr>
+        <p:spPr>
+          <a:xfrm>
+            <a:off x="6949440" y="3474720"/>
+            <a:ext cx="4709160" cy="594360"/>
+          </a:xfrm>
+          <a:prstGeom prst="rect">
+            <a:avLst/>
+          </a:prstGeom>
+          <a:noFill/>
+          <a:ln/>
+        </p:spPr>
+        <p:txBody>
+          <a:bodyPr wrap="square" lIns="0" tIns="0" rIns="0" bIns="0" rtlCol="0" anchor="ctr"/>
+          <a:lstStyle/>
+          <a:p>
+            <a:pPr indent="0" marL="0">
+              <a:buNone/>
+            </a:pPr>
+            <a:r>
+              <a:rPr lang="en-US" sz="1350" b="1" dirty="0">
+                <a:solidFill>
+                  <a:srgbClr val="1E2761"/>
+                </a:solidFill>
+                <a:latin typeface="Calibri" pitchFamily="34" charset="0"/>
+                <a:ea typeface="Calibri" pitchFamily="34" charset="-122"/>
+                <a:cs typeface="Calibri" pitchFamily="34" charset="-120"/>
+              </a:rPr>
+              <a:t>Deploy  —  </a:t>
+            </a:r>
+            <a:pPr indent="0" marL="0">
+              <a:buNone/>
+            </a:pPr>
+            <a:r>
+              <a:rPr lang="en-US" sz="1350" dirty="0">
+                <a:solidFill>
+                  <a:srgbClr val="333333"/>
+                </a:solidFill>
+                <a:latin typeface="Calibri" pitchFamily="34" charset="0"/>
+                <a:ea typeface="Calibri" pitchFamily="34" charset="-122"/>
+                <a:cs typeface="Calibri" pitchFamily="34" charset="-120"/>
+              </a:rPr>
+              <a:t>Streamlit demo · 1.2 s/image on CPU, no GPU needed</a:t>
+            </a:r>
+            <a:endParaRPr lang="en-US" sz="1350" dirty="0"/>
+          </a:p>
+        </p:txBody>
+      </p:sp>
+      <p:sp>
+        <p:nvSpPr>
+          <p:cNvPr id="12" name="Text 10"/>
+          <p:cNvSpPr/>
+          <p:nvPr/>
+        </p:nvSpPr>
+        <p:spPr>
+          <a:xfrm>
+            <a:off x="548640" y="5120640"/>
+            <a:ext cx="11018520" cy="731520"/>
+          </a:xfrm>
+          <a:prstGeom prst="roundRect">
+            <a:avLst>
+              <a:gd name="adj" fmla="val 12500"/>
+            </a:avLst>
+          </a:prstGeom>
+          <a:solidFill>
+            <a:srgbClr val="F4F7FD"/>
+          </a:solidFill>
+          <a:ln/>
+        </p:spPr>
+        <p:txBody>
+          <a:bodyPr wrap="square" rtlCol="0" anchor="ctr"/>
+          <a:lstStyle/>
+          <a:p>
+            <a:pPr algn="ctr" indent="0" marL="0">
+              <a:buNone/>
+            </a:pPr>
+            <a:r>
+              <a:rPr lang="en-US" sz="1400" b="1" dirty="0">
+                <a:solidFill>
+                  <a:srgbClr val="1E2761"/>
+                </a:solidFill>
+                <a:latin typeface="Calibri" pitchFamily="34" charset="0"/>
+                <a:ea typeface="Calibri" pitchFamily="34" charset="-122"/>
+                <a:cs typeface="Calibri" pitchFamily="34" charset="-120"/>
+              </a:rPr>
+              <a:t>Fully reproducible: seeded data splits · frozen benchmark · model config stored inside the checkpoint → inference needs zero code edits.</a:t>
+            </a:r>
+            <a:endParaRPr lang="en-US" sz="1400" dirty="0"/>
           </a:p>
         </p:txBody>
       </p:sp>

</xml_diff>

<commit_message>
Report measured GPU throughput instead of CPU-only figures
Benchmarked on a Colab Tesla T4: 25.0 ms per image end-to-end at batch 32
(40.0 images/second), so all 400 official test images restore in about
10 seconds. That is 53x faster than the laptop CPU figure previously
quoted, which undersold the pipeline.

results/runtime_report.md now carries the T4 measurement as the primary
number, keeps the CPU result as a documented fallback, and interprets the
breakdown: model execution is 97% of end-to-end time, so there is no I/O
bottleneck, and batching gains are small here because the model is small
enough that kernel-launch overhead dominates.

README, SLIDES.md and the deck updated to the measured GPU numbers.

Co-Authored-By: Claude Fable 5 <noreply@anthropic.com>
</commit_message>
<xml_diff>
--- a/BYTE_BRIGADE_SEMICON2026.pptx
+++ b/BYTE_BRIGADE_SEMICON2026.pptx
@@ -6034,7 +6034,7 @@
                 <a:ea typeface="Arial" pitchFamily="34" charset="-122"/>
                 <a:cs typeface="Arial" pitchFamily="34" charset="-120"/>
               </a:rPr>
-              <a:t>1.2 s</a:t>
+              <a:t>25 ms</a:t>
             </a:r>
             <a:endParaRPr lang="en-US" sz="3800" dirty="0"/>
           </a:p>
@@ -6051,7 +6051,7 @@
                 <a:ea typeface="Arial" pitchFamily="34" charset="-122"/>
                 <a:cs typeface="Arial" pitchFamily="34" charset="-120"/>
               </a:rPr>
-              <a:t>per image on plain CPU</a:t>
+              <a:t>per image on a T4 GPU</a:t>
             </a:r>
             <a:endParaRPr lang="en-US" sz="3800" dirty="0"/>
           </a:p>
@@ -6920,7 +6920,7 @@
                 <a:ea typeface="Calibri" pitchFamily="34" charset="-122"/>
                 <a:cs typeface="Calibri" pitchFamily="34" charset="-120"/>
               </a:rPr>
-              <a:t>Measured on 100 held-out pairs never seen in training. GPU inference: ~0.03 s/image.</a:t>
+              <a:t>Measured on 100 held-out pairs never seen in training. End-to-end: 25 ms/image, 40 img/s (T4).</a:t>
             </a:r>
             <a:endParaRPr lang="en-US" sz="1200" dirty="0"/>
           </a:p>
@@ -7440,7 +7440,7 @@
                 <a:ea typeface="Arial" pitchFamily="34" charset="-122"/>
                 <a:cs typeface="Arial" pitchFamily="34" charset="-120"/>
               </a:rPr>
-              <a:t>1.2 s</a:t>
+              <a:t>25 ms</a:t>
             </a:r>
             <a:endParaRPr lang="en-US" sz="2600" dirty="0"/>
           </a:p>
@@ -7457,7 +7457,7 @@
                 <a:ea typeface="Arial" pitchFamily="34" charset="-122"/>
                 <a:cs typeface="Arial" pitchFamily="34" charset="-120"/>
               </a:rPr>
-              <a:t>per image, CPU</a:t>
+              <a:t>per image, T4 GPU</a:t>
             </a:r>
             <a:endParaRPr lang="en-US" sz="2600" dirty="0"/>
           </a:p>
@@ -7500,7 +7500,7 @@
                 <a:ea typeface="Arial" pitchFamily="34" charset="-122"/>
                 <a:cs typeface="Arial" pitchFamily="34" charset="-120"/>
               </a:rPr>
-              <a:t>8 min</a:t>
+              <a:t>10 s</a:t>
             </a:r>
             <a:endParaRPr lang="en-US" sz="2600" dirty="0"/>
           </a:p>
@@ -8171,7 +8171,7 @@
                 <a:ea typeface="Calibri" pitchFamily="34" charset="-122"/>
                 <a:cs typeface="Calibri" pitchFamily="34" charset="-120"/>
               </a:rPr>
-              <a:t>Streamlit demo · 1.2 s/image on CPU, no GPU needed</a:t>
+              <a:t>Streamlit demo · runs on CPU too, no GPU needed</a:t>
             </a:r>
             <a:endParaRPr lang="en-US" sz="1350" dirty="0"/>
           </a:p>

</xml_diff>